<commit_message>
docs(proposal): replace placeholder contact information
</commit_message>
<xml_diff>
--- a/Desktop/Proposal/exports/LeadFlow-Proposal-v1.0.pptx
+++ b/Desktop/Proposal/exports/LeadFlow-Proposal-v1.0.pptx
@@ -145,7 +145,7 @@
           <p:cNvPr id="2" name="Title 1">
             <a:extLst>
               <a:ext uri="{FF2B5EF4-FFF2-40B4-BE49-F238E27FC236}">
-                <a16:creationId xmlns:a16="http://schemas.microsoft.com/office/drawing/2014/main" id="{C894082D-CDCD-9B59-F6BB-C67A7FFA4549}"/>
+                <a16:creationId xmlns:a16="http://schemas.microsoft.com/office/drawing/2014/main" id="{C1E22094-4858-DD62-FCAC-4231B25C70F0}"/>
               </a:ext>
             </a:extLst>
           </p:cNvPr>
@@ -182,7 +182,7 @@
           <p:cNvPr id="3" name="Subtitle 2">
             <a:extLst>
               <a:ext uri="{FF2B5EF4-FFF2-40B4-BE49-F238E27FC236}">
-                <a16:creationId xmlns:a16="http://schemas.microsoft.com/office/drawing/2014/main" id="{F6C3374B-345F-211D-ABB0-230E723CB941}"/>
+                <a16:creationId xmlns:a16="http://schemas.microsoft.com/office/drawing/2014/main" id="{AC8B790F-0AB7-462B-817A-E94E71850984}"/>
               </a:ext>
             </a:extLst>
           </p:cNvPr>
@@ -252,7 +252,7 @@
           <p:cNvPr id="4" name="Date Placeholder 3">
             <a:extLst>
               <a:ext uri="{FF2B5EF4-FFF2-40B4-BE49-F238E27FC236}">
-                <a16:creationId xmlns:a16="http://schemas.microsoft.com/office/drawing/2014/main" id="{03B64C1D-E119-3072-9C19-9094CBE3ECEA}"/>
+                <a16:creationId xmlns:a16="http://schemas.microsoft.com/office/drawing/2014/main" id="{C3DABFA7-D100-5B1B-10B4-271B4604E99B}"/>
               </a:ext>
             </a:extLst>
           </p:cNvPr>
@@ -268,7 +268,7 @@
           <a:bodyPr/>
           <a:lstStyle/>
           <a:p>
-            <a:fld id="{6460E8BC-2008-488A-91D3-42E9EA121979}" type="datetimeFigureOut">
+            <a:fld id="{06F0BCA8-90DB-4D97-BB85-C321F5FFDC10}" type="datetimeFigureOut">
               <a:rPr lang="en-US" smtClean="0"/>
               <a:t>7/11/2026</a:t>
             </a:fld>
@@ -281,7 +281,7 @@
           <p:cNvPr id="5" name="Footer Placeholder 4">
             <a:extLst>
               <a:ext uri="{FF2B5EF4-FFF2-40B4-BE49-F238E27FC236}">
-                <a16:creationId xmlns:a16="http://schemas.microsoft.com/office/drawing/2014/main" id="{4A7818DE-973B-F0B4-7F7A-09AA5B30A354}"/>
+                <a16:creationId xmlns:a16="http://schemas.microsoft.com/office/drawing/2014/main" id="{24C60BCF-9CB1-C49F-EAE0-0716DE770801}"/>
               </a:ext>
             </a:extLst>
           </p:cNvPr>
@@ -306,7 +306,7 @@
           <p:cNvPr id="6" name="Slide Number Placeholder 5">
             <a:extLst>
               <a:ext uri="{FF2B5EF4-FFF2-40B4-BE49-F238E27FC236}">
-                <a16:creationId xmlns:a16="http://schemas.microsoft.com/office/drawing/2014/main" id="{C6522FE2-0CC2-8F95-39AF-9488CA222EAA}"/>
+                <a16:creationId xmlns:a16="http://schemas.microsoft.com/office/drawing/2014/main" id="{ADB868E1-27A1-DB55-3B6E-A77DDAAC6E96}"/>
               </a:ext>
             </a:extLst>
           </p:cNvPr>
@@ -322,7 +322,7 @@
           <a:bodyPr/>
           <a:lstStyle/>
           <a:p>
-            <a:fld id="{D1098AEC-CBAB-47D2-8592-558BC0B61040}" type="slidenum">
+            <a:fld id="{0BDB6D22-B9A3-4D53-BECF-43E12A719D70}" type="slidenum">
               <a:rPr lang="en-US" smtClean="0"/>
               <a:t>‹#›</a:t>
             </a:fld>
@@ -333,7 +333,7 @@
     </p:spTree>
     <p:extLst>
       <p:ext uri="{BB962C8B-B14F-4D97-AF65-F5344CB8AC3E}">
-        <p14:creationId xmlns:p14="http://schemas.microsoft.com/office/powerpoint/2010/main" val="3367918131"/>
+        <p14:creationId xmlns:p14="http://schemas.microsoft.com/office/powerpoint/2010/main" val="598486629"/>
       </p:ext>
     </p:extLst>
   </p:cSld>
@@ -365,7 +365,7 @@
           <p:cNvPr id="2" name="Title 1">
             <a:extLst>
               <a:ext uri="{FF2B5EF4-FFF2-40B4-BE49-F238E27FC236}">
-                <a16:creationId xmlns:a16="http://schemas.microsoft.com/office/drawing/2014/main" id="{0CDD911E-CF7E-1620-2606-F815959B2607}"/>
+                <a16:creationId xmlns:a16="http://schemas.microsoft.com/office/drawing/2014/main" id="{828910D2-0A12-91AD-9CBD-7B4E7A590F65}"/>
               </a:ext>
             </a:extLst>
           </p:cNvPr>
@@ -393,7 +393,7 @@
           <p:cNvPr id="3" name="Vertical Text Placeholder 2">
             <a:extLst>
               <a:ext uri="{FF2B5EF4-FFF2-40B4-BE49-F238E27FC236}">
-                <a16:creationId xmlns:a16="http://schemas.microsoft.com/office/drawing/2014/main" id="{A6E38904-035A-86AE-9823-788B3E40E3D7}"/>
+                <a16:creationId xmlns:a16="http://schemas.microsoft.com/office/drawing/2014/main" id="{67DAE542-5E3F-3AD1-90E3-CF9217B19B9D}"/>
               </a:ext>
             </a:extLst>
           </p:cNvPr>
@@ -450,7 +450,7 @@
           <p:cNvPr id="4" name="Date Placeholder 3">
             <a:extLst>
               <a:ext uri="{FF2B5EF4-FFF2-40B4-BE49-F238E27FC236}">
-                <a16:creationId xmlns:a16="http://schemas.microsoft.com/office/drawing/2014/main" id="{DD1A2D92-20A1-531F-2AFA-C4D47F932D5B}"/>
+                <a16:creationId xmlns:a16="http://schemas.microsoft.com/office/drawing/2014/main" id="{613EB554-2CB9-C044-B212-097DA9C17251}"/>
               </a:ext>
             </a:extLst>
           </p:cNvPr>
@@ -466,7 +466,7 @@
           <a:bodyPr/>
           <a:lstStyle/>
           <a:p>
-            <a:fld id="{6460E8BC-2008-488A-91D3-42E9EA121979}" type="datetimeFigureOut">
+            <a:fld id="{06F0BCA8-90DB-4D97-BB85-C321F5FFDC10}" type="datetimeFigureOut">
               <a:rPr lang="en-US" smtClean="0"/>
               <a:t>7/11/2026</a:t>
             </a:fld>
@@ -479,7 +479,7 @@
           <p:cNvPr id="5" name="Footer Placeholder 4">
             <a:extLst>
               <a:ext uri="{FF2B5EF4-FFF2-40B4-BE49-F238E27FC236}">
-                <a16:creationId xmlns:a16="http://schemas.microsoft.com/office/drawing/2014/main" id="{B51028E3-726A-64C1-E197-64F627E7CC82}"/>
+                <a16:creationId xmlns:a16="http://schemas.microsoft.com/office/drawing/2014/main" id="{80E6B62B-715E-1C26-8DCB-C943464A9CBB}"/>
               </a:ext>
             </a:extLst>
           </p:cNvPr>
@@ -504,7 +504,7 @@
           <p:cNvPr id="6" name="Slide Number Placeholder 5">
             <a:extLst>
               <a:ext uri="{FF2B5EF4-FFF2-40B4-BE49-F238E27FC236}">
-                <a16:creationId xmlns:a16="http://schemas.microsoft.com/office/drawing/2014/main" id="{C379D50E-C530-78DB-5514-0F0AE7E64A69}"/>
+                <a16:creationId xmlns:a16="http://schemas.microsoft.com/office/drawing/2014/main" id="{D8595887-F983-43D6-490D-52E2BD44BA91}"/>
               </a:ext>
             </a:extLst>
           </p:cNvPr>
@@ -520,7 +520,7 @@
           <a:bodyPr/>
           <a:lstStyle/>
           <a:p>
-            <a:fld id="{D1098AEC-CBAB-47D2-8592-558BC0B61040}" type="slidenum">
+            <a:fld id="{0BDB6D22-B9A3-4D53-BECF-43E12A719D70}" type="slidenum">
               <a:rPr lang="en-US" smtClean="0"/>
               <a:t>‹#›</a:t>
             </a:fld>
@@ -531,7 +531,7 @@
     </p:spTree>
     <p:extLst>
       <p:ext uri="{BB962C8B-B14F-4D97-AF65-F5344CB8AC3E}">
-        <p14:creationId xmlns:p14="http://schemas.microsoft.com/office/powerpoint/2010/main" val="539894531"/>
+        <p14:creationId xmlns:p14="http://schemas.microsoft.com/office/powerpoint/2010/main" val="3326148293"/>
       </p:ext>
     </p:extLst>
   </p:cSld>
@@ -563,7 +563,7 @@
           <p:cNvPr id="2" name="Vertical Title 1">
             <a:extLst>
               <a:ext uri="{FF2B5EF4-FFF2-40B4-BE49-F238E27FC236}">
-                <a16:creationId xmlns:a16="http://schemas.microsoft.com/office/drawing/2014/main" id="{0617623C-30B0-1F1E-568B-DE51EC7CCF53}"/>
+                <a16:creationId xmlns:a16="http://schemas.microsoft.com/office/drawing/2014/main" id="{58C8F3FE-F186-1ADE-E521-BE17FD83EB7A}"/>
               </a:ext>
             </a:extLst>
           </p:cNvPr>
@@ -596,7 +596,7 @@
           <p:cNvPr id="3" name="Vertical Text Placeholder 2">
             <a:extLst>
               <a:ext uri="{FF2B5EF4-FFF2-40B4-BE49-F238E27FC236}">
-                <a16:creationId xmlns:a16="http://schemas.microsoft.com/office/drawing/2014/main" id="{3EE46318-7540-1ADC-E3C3-0E8FDD0D86EB}"/>
+                <a16:creationId xmlns:a16="http://schemas.microsoft.com/office/drawing/2014/main" id="{E258FF9C-262D-DF97-8208-E9FD2E0412DC}"/>
               </a:ext>
             </a:extLst>
           </p:cNvPr>
@@ -658,7 +658,7 @@
           <p:cNvPr id="4" name="Date Placeholder 3">
             <a:extLst>
               <a:ext uri="{FF2B5EF4-FFF2-40B4-BE49-F238E27FC236}">
-                <a16:creationId xmlns:a16="http://schemas.microsoft.com/office/drawing/2014/main" id="{E3317BDE-0889-AD03-F719-6809A644356F}"/>
+                <a16:creationId xmlns:a16="http://schemas.microsoft.com/office/drawing/2014/main" id="{626D5E98-FECF-DCD6-632E-A6A0D883CF50}"/>
               </a:ext>
             </a:extLst>
           </p:cNvPr>
@@ -674,7 +674,7 @@
           <a:bodyPr/>
           <a:lstStyle/>
           <a:p>
-            <a:fld id="{6460E8BC-2008-488A-91D3-42E9EA121979}" type="datetimeFigureOut">
+            <a:fld id="{06F0BCA8-90DB-4D97-BB85-C321F5FFDC10}" type="datetimeFigureOut">
               <a:rPr lang="en-US" smtClean="0"/>
               <a:t>7/11/2026</a:t>
             </a:fld>
@@ -687,7 +687,7 @@
           <p:cNvPr id="5" name="Footer Placeholder 4">
             <a:extLst>
               <a:ext uri="{FF2B5EF4-FFF2-40B4-BE49-F238E27FC236}">
-                <a16:creationId xmlns:a16="http://schemas.microsoft.com/office/drawing/2014/main" id="{005608CE-45FF-8125-37FF-54FA24C721AE}"/>
+                <a16:creationId xmlns:a16="http://schemas.microsoft.com/office/drawing/2014/main" id="{26456053-E3F9-63FE-E800-3A7A98ED8032}"/>
               </a:ext>
             </a:extLst>
           </p:cNvPr>
@@ -712,7 +712,7 @@
           <p:cNvPr id="6" name="Slide Number Placeholder 5">
             <a:extLst>
               <a:ext uri="{FF2B5EF4-FFF2-40B4-BE49-F238E27FC236}">
-                <a16:creationId xmlns:a16="http://schemas.microsoft.com/office/drawing/2014/main" id="{D751A000-12BC-99C1-1B17-D0995320207C}"/>
+                <a16:creationId xmlns:a16="http://schemas.microsoft.com/office/drawing/2014/main" id="{934B75C3-4F09-F452-AEAC-AF0A68436370}"/>
               </a:ext>
             </a:extLst>
           </p:cNvPr>
@@ -728,7 +728,7 @@
           <a:bodyPr/>
           <a:lstStyle/>
           <a:p>
-            <a:fld id="{D1098AEC-CBAB-47D2-8592-558BC0B61040}" type="slidenum">
+            <a:fld id="{0BDB6D22-B9A3-4D53-BECF-43E12A719D70}" type="slidenum">
               <a:rPr lang="en-US" smtClean="0"/>
               <a:t>‹#›</a:t>
             </a:fld>
@@ -739,7 +739,7 @@
     </p:spTree>
     <p:extLst>
       <p:ext uri="{BB962C8B-B14F-4D97-AF65-F5344CB8AC3E}">
-        <p14:creationId xmlns:p14="http://schemas.microsoft.com/office/powerpoint/2010/main" val="766247365"/>
+        <p14:creationId xmlns:p14="http://schemas.microsoft.com/office/powerpoint/2010/main" val="3984497823"/>
       </p:ext>
     </p:extLst>
   </p:cSld>
@@ -771,7 +771,7 @@
           <p:cNvPr id="2" name="Title 1">
             <a:extLst>
               <a:ext uri="{FF2B5EF4-FFF2-40B4-BE49-F238E27FC236}">
-                <a16:creationId xmlns:a16="http://schemas.microsoft.com/office/drawing/2014/main" id="{2B5A30EC-22F4-D877-D745-B7C1A0E159A2}"/>
+                <a16:creationId xmlns:a16="http://schemas.microsoft.com/office/drawing/2014/main" id="{E8AFC074-EF7E-1F72-5EA8-4DAD1F174E0F}"/>
               </a:ext>
             </a:extLst>
           </p:cNvPr>
@@ -799,7 +799,7 @@
           <p:cNvPr id="3" name="Content Placeholder 2">
             <a:extLst>
               <a:ext uri="{FF2B5EF4-FFF2-40B4-BE49-F238E27FC236}">
-                <a16:creationId xmlns:a16="http://schemas.microsoft.com/office/drawing/2014/main" id="{E18CFB9B-3632-5649-28D4-CDBAEB4B9928}"/>
+                <a16:creationId xmlns:a16="http://schemas.microsoft.com/office/drawing/2014/main" id="{3CB93F29-286C-B61B-9C02-32063F7EE6D7}"/>
               </a:ext>
             </a:extLst>
           </p:cNvPr>
@@ -856,7 +856,7 @@
           <p:cNvPr id="4" name="Date Placeholder 3">
             <a:extLst>
               <a:ext uri="{FF2B5EF4-FFF2-40B4-BE49-F238E27FC236}">
-                <a16:creationId xmlns:a16="http://schemas.microsoft.com/office/drawing/2014/main" id="{0519BBD2-ADFE-5A5F-22E9-D9A00BB25086}"/>
+                <a16:creationId xmlns:a16="http://schemas.microsoft.com/office/drawing/2014/main" id="{8249F381-46DD-35FA-438B-8C81F43F8759}"/>
               </a:ext>
             </a:extLst>
           </p:cNvPr>
@@ -872,7 +872,7 @@
           <a:bodyPr/>
           <a:lstStyle/>
           <a:p>
-            <a:fld id="{6460E8BC-2008-488A-91D3-42E9EA121979}" type="datetimeFigureOut">
+            <a:fld id="{06F0BCA8-90DB-4D97-BB85-C321F5FFDC10}" type="datetimeFigureOut">
               <a:rPr lang="en-US" smtClean="0"/>
               <a:t>7/11/2026</a:t>
             </a:fld>
@@ -885,7 +885,7 @@
           <p:cNvPr id="5" name="Footer Placeholder 4">
             <a:extLst>
               <a:ext uri="{FF2B5EF4-FFF2-40B4-BE49-F238E27FC236}">
-                <a16:creationId xmlns:a16="http://schemas.microsoft.com/office/drawing/2014/main" id="{ADAF2051-FA0C-50CE-65DB-74BA3D1F3983}"/>
+                <a16:creationId xmlns:a16="http://schemas.microsoft.com/office/drawing/2014/main" id="{9DB1CB94-B447-6B5F-0C19-402AB0E9BC8D}"/>
               </a:ext>
             </a:extLst>
           </p:cNvPr>
@@ -910,7 +910,7 @@
           <p:cNvPr id="6" name="Slide Number Placeholder 5">
             <a:extLst>
               <a:ext uri="{FF2B5EF4-FFF2-40B4-BE49-F238E27FC236}">
-                <a16:creationId xmlns:a16="http://schemas.microsoft.com/office/drawing/2014/main" id="{3A3532E5-D284-1C86-9963-1C2F7006B7E6}"/>
+                <a16:creationId xmlns:a16="http://schemas.microsoft.com/office/drawing/2014/main" id="{F788E90C-1DCB-6982-6707-EE88EB3B5878}"/>
               </a:ext>
             </a:extLst>
           </p:cNvPr>
@@ -926,7 +926,7 @@
           <a:bodyPr/>
           <a:lstStyle/>
           <a:p>
-            <a:fld id="{D1098AEC-CBAB-47D2-8592-558BC0B61040}" type="slidenum">
+            <a:fld id="{0BDB6D22-B9A3-4D53-BECF-43E12A719D70}" type="slidenum">
               <a:rPr lang="en-US" smtClean="0"/>
               <a:t>‹#›</a:t>
             </a:fld>
@@ -937,7 +937,7 @@
     </p:spTree>
     <p:extLst>
       <p:ext uri="{BB962C8B-B14F-4D97-AF65-F5344CB8AC3E}">
-        <p14:creationId xmlns:p14="http://schemas.microsoft.com/office/powerpoint/2010/main" val="3431140505"/>
+        <p14:creationId xmlns:p14="http://schemas.microsoft.com/office/powerpoint/2010/main" val="937395066"/>
       </p:ext>
     </p:extLst>
   </p:cSld>
@@ -969,7 +969,7 @@
           <p:cNvPr id="2" name="Title 1">
             <a:extLst>
               <a:ext uri="{FF2B5EF4-FFF2-40B4-BE49-F238E27FC236}">
-                <a16:creationId xmlns:a16="http://schemas.microsoft.com/office/drawing/2014/main" id="{3D2DC8D7-B40B-0B30-7443-3C43E701D5E0}"/>
+                <a16:creationId xmlns:a16="http://schemas.microsoft.com/office/drawing/2014/main" id="{AE3948B0-812E-A9A4-0B0A-F8B9C67976D5}"/>
               </a:ext>
             </a:extLst>
           </p:cNvPr>
@@ -1006,7 +1006,7 @@
           <p:cNvPr id="3" name="Text Placeholder 2">
             <a:extLst>
               <a:ext uri="{FF2B5EF4-FFF2-40B4-BE49-F238E27FC236}">
-                <a16:creationId xmlns:a16="http://schemas.microsoft.com/office/drawing/2014/main" id="{2884CBE8-48CB-BAA0-CCE1-98899D7125A7}"/>
+                <a16:creationId xmlns:a16="http://schemas.microsoft.com/office/drawing/2014/main" id="{74C09B40-562A-8A83-6EDB-DDBC2FD28BE5}"/>
               </a:ext>
             </a:extLst>
           </p:cNvPr>
@@ -1131,7 +1131,7 @@
           <p:cNvPr id="4" name="Date Placeholder 3">
             <a:extLst>
               <a:ext uri="{FF2B5EF4-FFF2-40B4-BE49-F238E27FC236}">
-                <a16:creationId xmlns:a16="http://schemas.microsoft.com/office/drawing/2014/main" id="{8C52793A-46C2-238F-30D2-BB4B9069BB52}"/>
+                <a16:creationId xmlns:a16="http://schemas.microsoft.com/office/drawing/2014/main" id="{BD819338-4013-A919-B12B-4F915F490ED9}"/>
               </a:ext>
             </a:extLst>
           </p:cNvPr>
@@ -1147,7 +1147,7 @@
           <a:bodyPr/>
           <a:lstStyle/>
           <a:p>
-            <a:fld id="{6460E8BC-2008-488A-91D3-42E9EA121979}" type="datetimeFigureOut">
+            <a:fld id="{06F0BCA8-90DB-4D97-BB85-C321F5FFDC10}" type="datetimeFigureOut">
               <a:rPr lang="en-US" smtClean="0"/>
               <a:t>7/11/2026</a:t>
             </a:fld>
@@ -1160,7 +1160,7 @@
           <p:cNvPr id="5" name="Footer Placeholder 4">
             <a:extLst>
               <a:ext uri="{FF2B5EF4-FFF2-40B4-BE49-F238E27FC236}">
-                <a16:creationId xmlns:a16="http://schemas.microsoft.com/office/drawing/2014/main" id="{995FA876-DED2-0115-BA13-557BE367A60E}"/>
+                <a16:creationId xmlns:a16="http://schemas.microsoft.com/office/drawing/2014/main" id="{2EC96C89-8136-5218-DBF9-EE65BBB5D005}"/>
               </a:ext>
             </a:extLst>
           </p:cNvPr>
@@ -1185,7 +1185,7 @@
           <p:cNvPr id="6" name="Slide Number Placeholder 5">
             <a:extLst>
               <a:ext uri="{FF2B5EF4-FFF2-40B4-BE49-F238E27FC236}">
-                <a16:creationId xmlns:a16="http://schemas.microsoft.com/office/drawing/2014/main" id="{0FA70240-B39D-57CC-032F-01500DA9F8A8}"/>
+                <a16:creationId xmlns:a16="http://schemas.microsoft.com/office/drawing/2014/main" id="{2E7FBA0E-704D-D267-0AFD-9475E40DF06D}"/>
               </a:ext>
             </a:extLst>
           </p:cNvPr>
@@ -1201,7 +1201,7 @@
           <a:bodyPr/>
           <a:lstStyle/>
           <a:p>
-            <a:fld id="{D1098AEC-CBAB-47D2-8592-558BC0B61040}" type="slidenum">
+            <a:fld id="{0BDB6D22-B9A3-4D53-BECF-43E12A719D70}" type="slidenum">
               <a:rPr lang="en-US" smtClean="0"/>
               <a:t>‹#›</a:t>
             </a:fld>
@@ -1212,7 +1212,7 @@
     </p:spTree>
     <p:extLst>
       <p:ext uri="{BB962C8B-B14F-4D97-AF65-F5344CB8AC3E}">
-        <p14:creationId xmlns:p14="http://schemas.microsoft.com/office/powerpoint/2010/main" val="2618739410"/>
+        <p14:creationId xmlns:p14="http://schemas.microsoft.com/office/powerpoint/2010/main" val="2178901110"/>
       </p:ext>
     </p:extLst>
   </p:cSld>
@@ -1244,7 +1244,7 @@
           <p:cNvPr id="2" name="Title 1">
             <a:extLst>
               <a:ext uri="{FF2B5EF4-FFF2-40B4-BE49-F238E27FC236}">
-                <a16:creationId xmlns:a16="http://schemas.microsoft.com/office/drawing/2014/main" id="{55F688AA-3B2B-C8E1-0E16-FDC1377286C5}"/>
+                <a16:creationId xmlns:a16="http://schemas.microsoft.com/office/drawing/2014/main" id="{E77577B6-FC73-B630-575A-E0B932FDD6A3}"/>
               </a:ext>
             </a:extLst>
           </p:cNvPr>
@@ -1272,7 +1272,7 @@
           <p:cNvPr id="3" name="Content Placeholder 2">
             <a:extLst>
               <a:ext uri="{FF2B5EF4-FFF2-40B4-BE49-F238E27FC236}">
-                <a16:creationId xmlns:a16="http://schemas.microsoft.com/office/drawing/2014/main" id="{FFB18357-545D-A395-CCC0-A764CD6A11A0}"/>
+                <a16:creationId xmlns:a16="http://schemas.microsoft.com/office/drawing/2014/main" id="{77298EF6-F121-0471-7736-98A5B3DCCDBD}"/>
               </a:ext>
             </a:extLst>
           </p:cNvPr>
@@ -1334,7 +1334,7 @@
           <p:cNvPr id="4" name="Content Placeholder 3">
             <a:extLst>
               <a:ext uri="{FF2B5EF4-FFF2-40B4-BE49-F238E27FC236}">
-                <a16:creationId xmlns:a16="http://schemas.microsoft.com/office/drawing/2014/main" id="{937515C3-6A1F-E18E-0F35-A34555FB8F9E}"/>
+                <a16:creationId xmlns:a16="http://schemas.microsoft.com/office/drawing/2014/main" id="{955F03C8-44CE-1BE1-B61A-3FB7D93781CA}"/>
               </a:ext>
             </a:extLst>
           </p:cNvPr>
@@ -1396,7 +1396,7 @@
           <p:cNvPr id="5" name="Date Placeholder 4">
             <a:extLst>
               <a:ext uri="{FF2B5EF4-FFF2-40B4-BE49-F238E27FC236}">
-                <a16:creationId xmlns:a16="http://schemas.microsoft.com/office/drawing/2014/main" id="{0F40D50B-6701-DC1B-F88D-B524A809613D}"/>
+                <a16:creationId xmlns:a16="http://schemas.microsoft.com/office/drawing/2014/main" id="{01C3425E-9638-2554-46FD-08D474F644D5}"/>
               </a:ext>
             </a:extLst>
           </p:cNvPr>
@@ -1412,7 +1412,7 @@
           <a:bodyPr/>
           <a:lstStyle/>
           <a:p>
-            <a:fld id="{6460E8BC-2008-488A-91D3-42E9EA121979}" type="datetimeFigureOut">
+            <a:fld id="{06F0BCA8-90DB-4D97-BB85-C321F5FFDC10}" type="datetimeFigureOut">
               <a:rPr lang="en-US" smtClean="0"/>
               <a:t>7/11/2026</a:t>
             </a:fld>
@@ -1425,7 +1425,7 @@
           <p:cNvPr id="6" name="Footer Placeholder 5">
             <a:extLst>
               <a:ext uri="{FF2B5EF4-FFF2-40B4-BE49-F238E27FC236}">
-                <a16:creationId xmlns:a16="http://schemas.microsoft.com/office/drawing/2014/main" id="{5767D23F-FF17-761F-608B-BB979595FBE0}"/>
+                <a16:creationId xmlns:a16="http://schemas.microsoft.com/office/drawing/2014/main" id="{EF7F977A-475B-E6A9-D6A9-47D7F99F032C}"/>
               </a:ext>
             </a:extLst>
           </p:cNvPr>
@@ -1450,7 +1450,7 @@
           <p:cNvPr id="7" name="Slide Number Placeholder 6">
             <a:extLst>
               <a:ext uri="{FF2B5EF4-FFF2-40B4-BE49-F238E27FC236}">
-                <a16:creationId xmlns:a16="http://schemas.microsoft.com/office/drawing/2014/main" id="{DA8B209D-7C20-6E67-FF36-366A9C754E87}"/>
+                <a16:creationId xmlns:a16="http://schemas.microsoft.com/office/drawing/2014/main" id="{44700487-0662-6EAA-946B-C9F2B054C594}"/>
               </a:ext>
             </a:extLst>
           </p:cNvPr>
@@ -1466,7 +1466,7 @@
           <a:bodyPr/>
           <a:lstStyle/>
           <a:p>
-            <a:fld id="{D1098AEC-CBAB-47D2-8592-558BC0B61040}" type="slidenum">
+            <a:fld id="{0BDB6D22-B9A3-4D53-BECF-43E12A719D70}" type="slidenum">
               <a:rPr lang="en-US" smtClean="0"/>
               <a:t>‹#›</a:t>
             </a:fld>
@@ -1477,7 +1477,7 @@
     </p:spTree>
     <p:extLst>
       <p:ext uri="{BB962C8B-B14F-4D97-AF65-F5344CB8AC3E}">
-        <p14:creationId xmlns:p14="http://schemas.microsoft.com/office/powerpoint/2010/main" val="970473004"/>
+        <p14:creationId xmlns:p14="http://schemas.microsoft.com/office/powerpoint/2010/main" val="3384313111"/>
       </p:ext>
     </p:extLst>
   </p:cSld>
@@ -1509,7 +1509,7 @@
           <p:cNvPr id="2" name="Title 1">
             <a:extLst>
               <a:ext uri="{FF2B5EF4-FFF2-40B4-BE49-F238E27FC236}">
-                <a16:creationId xmlns:a16="http://schemas.microsoft.com/office/drawing/2014/main" id="{1742939C-C3DB-D0D2-6458-ACC05EFAA9CD}"/>
+                <a16:creationId xmlns:a16="http://schemas.microsoft.com/office/drawing/2014/main" id="{35FB442F-20E2-F73D-FC5F-21341B5F2799}"/>
               </a:ext>
             </a:extLst>
           </p:cNvPr>
@@ -1542,7 +1542,7 @@
           <p:cNvPr id="3" name="Text Placeholder 2">
             <a:extLst>
               <a:ext uri="{FF2B5EF4-FFF2-40B4-BE49-F238E27FC236}">
-                <a16:creationId xmlns:a16="http://schemas.microsoft.com/office/drawing/2014/main" id="{3FF8FD7F-E561-70F7-6819-D19BE79F524D}"/>
+                <a16:creationId xmlns:a16="http://schemas.microsoft.com/office/drawing/2014/main" id="{FFE9A7A7-D66C-3361-7A8B-E88B4621487C}"/>
               </a:ext>
             </a:extLst>
           </p:cNvPr>
@@ -1613,7 +1613,7 @@
           <p:cNvPr id="4" name="Content Placeholder 3">
             <a:extLst>
               <a:ext uri="{FF2B5EF4-FFF2-40B4-BE49-F238E27FC236}">
-                <a16:creationId xmlns:a16="http://schemas.microsoft.com/office/drawing/2014/main" id="{523AAB8E-48E4-A1BA-C536-76D7D63F2B37}"/>
+                <a16:creationId xmlns:a16="http://schemas.microsoft.com/office/drawing/2014/main" id="{2D34C8E6-EB52-7D76-BFF7-DA46C8566CB5}"/>
               </a:ext>
             </a:extLst>
           </p:cNvPr>
@@ -1675,7 +1675,7 @@
           <p:cNvPr id="5" name="Text Placeholder 4">
             <a:extLst>
               <a:ext uri="{FF2B5EF4-FFF2-40B4-BE49-F238E27FC236}">
-                <a16:creationId xmlns:a16="http://schemas.microsoft.com/office/drawing/2014/main" id="{1A1F5E42-5065-C6CD-371E-52F34694B262}"/>
+                <a16:creationId xmlns:a16="http://schemas.microsoft.com/office/drawing/2014/main" id="{D3A6ECA7-D8E3-FE09-2188-AE542E31B1DC}"/>
               </a:ext>
             </a:extLst>
           </p:cNvPr>
@@ -1746,7 +1746,7 @@
           <p:cNvPr id="6" name="Content Placeholder 5">
             <a:extLst>
               <a:ext uri="{FF2B5EF4-FFF2-40B4-BE49-F238E27FC236}">
-                <a16:creationId xmlns:a16="http://schemas.microsoft.com/office/drawing/2014/main" id="{229F60F3-DA7C-68AF-1C09-61FBB1550619}"/>
+                <a16:creationId xmlns:a16="http://schemas.microsoft.com/office/drawing/2014/main" id="{A79CEA59-7362-2A14-8606-DEC6A7E48536}"/>
               </a:ext>
             </a:extLst>
           </p:cNvPr>
@@ -1808,7 +1808,7 @@
           <p:cNvPr id="7" name="Date Placeholder 6">
             <a:extLst>
               <a:ext uri="{FF2B5EF4-FFF2-40B4-BE49-F238E27FC236}">
-                <a16:creationId xmlns:a16="http://schemas.microsoft.com/office/drawing/2014/main" id="{0EC3CDB4-CADB-9F2B-A949-9E29DE0FBF0A}"/>
+                <a16:creationId xmlns:a16="http://schemas.microsoft.com/office/drawing/2014/main" id="{3805A217-C689-172C-5D57-422DA5088C87}"/>
               </a:ext>
             </a:extLst>
           </p:cNvPr>
@@ -1824,7 +1824,7 @@
           <a:bodyPr/>
           <a:lstStyle/>
           <a:p>
-            <a:fld id="{6460E8BC-2008-488A-91D3-42E9EA121979}" type="datetimeFigureOut">
+            <a:fld id="{06F0BCA8-90DB-4D97-BB85-C321F5FFDC10}" type="datetimeFigureOut">
               <a:rPr lang="en-US" smtClean="0"/>
               <a:t>7/11/2026</a:t>
             </a:fld>
@@ -1837,7 +1837,7 @@
           <p:cNvPr id="8" name="Footer Placeholder 7">
             <a:extLst>
               <a:ext uri="{FF2B5EF4-FFF2-40B4-BE49-F238E27FC236}">
-                <a16:creationId xmlns:a16="http://schemas.microsoft.com/office/drawing/2014/main" id="{4925B675-422E-C0B6-6A14-AF108AD4B0F2}"/>
+                <a16:creationId xmlns:a16="http://schemas.microsoft.com/office/drawing/2014/main" id="{A0C23FE6-D765-6262-E98D-409060374E4B}"/>
               </a:ext>
             </a:extLst>
           </p:cNvPr>
@@ -1862,7 +1862,7 @@
           <p:cNvPr id="9" name="Slide Number Placeholder 8">
             <a:extLst>
               <a:ext uri="{FF2B5EF4-FFF2-40B4-BE49-F238E27FC236}">
-                <a16:creationId xmlns:a16="http://schemas.microsoft.com/office/drawing/2014/main" id="{795892A8-9EDD-1CB8-3C1F-646333542E93}"/>
+                <a16:creationId xmlns:a16="http://schemas.microsoft.com/office/drawing/2014/main" id="{79F03EA6-C61E-024C-5D50-9368B393DDC0}"/>
               </a:ext>
             </a:extLst>
           </p:cNvPr>
@@ -1878,7 +1878,7 @@
           <a:bodyPr/>
           <a:lstStyle/>
           <a:p>
-            <a:fld id="{D1098AEC-CBAB-47D2-8592-558BC0B61040}" type="slidenum">
+            <a:fld id="{0BDB6D22-B9A3-4D53-BECF-43E12A719D70}" type="slidenum">
               <a:rPr lang="en-US" smtClean="0"/>
               <a:t>‹#›</a:t>
             </a:fld>
@@ -1889,7 +1889,7 @@
     </p:spTree>
     <p:extLst>
       <p:ext uri="{BB962C8B-B14F-4D97-AF65-F5344CB8AC3E}">
-        <p14:creationId xmlns:p14="http://schemas.microsoft.com/office/powerpoint/2010/main" val="796735600"/>
+        <p14:creationId xmlns:p14="http://schemas.microsoft.com/office/powerpoint/2010/main" val="161158049"/>
       </p:ext>
     </p:extLst>
   </p:cSld>
@@ -1921,7 +1921,7 @@
           <p:cNvPr id="2" name="Title 1">
             <a:extLst>
               <a:ext uri="{FF2B5EF4-FFF2-40B4-BE49-F238E27FC236}">
-                <a16:creationId xmlns:a16="http://schemas.microsoft.com/office/drawing/2014/main" id="{6173DDAB-58AD-E081-2CA0-3EFA4D997DDF}"/>
+                <a16:creationId xmlns:a16="http://schemas.microsoft.com/office/drawing/2014/main" id="{60FD09B1-092E-6519-CB22-E9A5AC5B1B5C}"/>
               </a:ext>
             </a:extLst>
           </p:cNvPr>
@@ -1949,7 +1949,7 @@
           <p:cNvPr id="3" name="Date Placeholder 2">
             <a:extLst>
               <a:ext uri="{FF2B5EF4-FFF2-40B4-BE49-F238E27FC236}">
-                <a16:creationId xmlns:a16="http://schemas.microsoft.com/office/drawing/2014/main" id="{18FFF249-4C2A-BFF4-C05F-00C2ADF53152}"/>
+                <a16:creationId xmlns:a16="http://schemas.microsoft.com/office/drawing/2014/main" id="{4168F744-F8B4-8DEB-B81F-BE548063B4A8}"/>
               </a:ext>
             </a:extLst>
           </p:cNvPr>
@@ -1965,7 +1965,7 @@
           <a:bodyPr/>
           <a:lstStyle/>
           <a:p>
-            <a:fld id="{6460E8BC-2008-488A-91D3-42E9EA121979}" type="datetimeFigureOut">
+            <a:fld id="{06F0BCA8-90DB-4D97-BB85-C321F5FFDC10}" type="datetimeFigureOut">
               <a:rPr lang="en-US" smtClean="0"/>
               <a:t>7/11/2026</a:t>
             </a:fld>
@@ -1978,7 +1978,7 @@
           <p:cNvPr id="4" name="Footer Placeholder 3">
             <a:extLst>
               <a:ext uri="{FF2B5EF4-FFF2-40B4-BE49-F238E27FC236}">
-                <a16:creationId xmlns:a16="http://schemas.microsoft.com/office/drawing/2014/main" id="{2452CA46-32D5-A23C-5FED-B6180F3AEAFD}"/>
+                <a16:creationId xmlns:a16="http://schemas.microsoft.com/office/drawing/2014/main" id="{A4DC79B4-A426-72D4-3F46-C3AF140B3FF5}"/>
               </a:ext>
             </a:extLst>
           </p:cNvPr>
@@ -2003,7 +2003,7 @@
           <p:cNvPr id="5" name="Slide Number Placeholder 4">
             <a:extLst>
               <a:ext uri="{FF2B5EF4-FFF2-40B4-BE49-F238E27FC236}">
-                <a16:creationId xmlns:a16="http://schemas.microsoft.com/office/drawing/2014/main" id="{F63B9131-5567-2530-66A4-5E271AA1A912}"/>
+                <a16:creationId xmlns:a16="http://schemas.microsoft.com/office/drawing/2014/main" id="{AF506797-B875-06D0-DEA7-66FD9558EC88}"/>
               </a:ext>
             </a:extLst>
           </p:cNvPr>
@@ -2019,7 +2019,7 @@
           <a:bodyPr/>
           <a:lstStyle/>
           <a:p>
-            <a:fld id="{D1098AEC-CBAB-47D2-8592-558BC0B61040}" type="slidenum">
+            <a:fld id="{0BDB6D22-B9A3-4D53-BECF-43E12A719D70}" type="slidenum">
               <a:rPr lang="en-US" smtClean="0"/>
               <a:t>‹#›</a:t>
             </a:fld>
@@ -2030,7 +2030,7 @@
     </p:spTree>
     <p:extLst>
       <p:ext uri="{BB962C8B-B14F-4D97-AF65-F5344CB8AC3E}">
-        <p14:creationId xmlns:p14="http://schemas.microsoft.com/office/powerpoint/2010/main" val="2350075539"/>
+        <p14:creationId xmlns:p14="http://schemas.microsoft.com/office/powerpoint/2010/main" val="1945771606"/>
       </p:ext>
     </p:extLst>
   </p:cSld>
@@ -2062,7 +2062,7 @@
           <p:cNvPr id="2" name="Date Placeholder 1">
             <a:extLst>
               <a:ext uri="{FF2B5EF4-FFF2-40B4-BE49-F238E27FC236}">
-                <a16:creationId xmlns:a16="http://schemas.microsoft.com/office/drawing/2014/main" id="{DE613A58-2F0D-B0C9-E246-D10D4C56DE59}"/>
+                <a16:creationId xmlns:a16="http://schemas.microsoft.com/office/drawing/2014/main" id="{33F57D1B-013C-63EA-357A-D2CE6B52229D}"/>
               </a:ext>
             </a:extLst>
           </p:cNvPr>
@@ -2078,7 +2078,7 @@
           <a:bodyPr/>
           <a:lstStyle/>
           <a:p>
-            <a:fld id="{6460E8BC-2008-488A-91D3-42E9EA121979}" type="datetimeFigureOut">
+            <a:fld id="{06F0BCA8-90DB-4D97-BB85-C321F5FFDC10}" type="datetimeFigureOut">
               <a:rPr lang="en-US" smtClean="0"/>
               <a:t>7/11/2026</a:t>
             </a:fld>
@@ -2091,7 +2091,7 @@
           <p:cNvPr id="3" name="Footer Placeholder 2">
             <a:extLst>
               <a:ext uri="{FF2B5EF4-FFF2-40B4-BE49-F238E27FC236}">
-                <a16:creationId xmlns:a16="http://schemas.microsoft.com/office/drawing/2014/main" id="{117D560C-9C81-D7B6-0AF3-47C6C0AE64BD}"/>
+                <a16:creationId xmlns:a16="http://schemas.microsoft.com/office/drawing/2014/main" id="{0E6E1856-D197-746A-FCAC-71825E7E0794}"/>
               </a:ext>
             </a:extLst>
           </p:cNvPr>
@@ -2116,7 +2116,7 @@
           <p:cNvPr id="4" name="Slide Number Placeholder 3">
             <a:extLst>
               <a:ext uri="{FF2B5EF4-FFF2-40B4-BE49-F238E27FC236}">
-                <a16:creationId xmlns:a16="http://schemas.microsoft.com/office/drawing/2014/main" id="{6C476D5D-5C5F-A055-2B8B-92AC9F058750}"/>
+                <a16:creationId xmlns:a16="http://schemas.microsoft.com/office/drawing/2014/main" id="{077EACC6-1C8A-E542-38F7-9ACDC2DA3D91}"/>
               </a:ext>
             </a:extLst>
           </p:cNvPr>
@@ -2132,7 +2132,7 @@
           <a:bodyPr/>
           <a:lstStyle/>
           <a:p>
-            <a:fld id="{D1098AEC-CBAB-47D2-8592-558BC0B61040}" type="slidenum">
+            <a:fld id="{0BDB6D22-B9A3-4D53-BECF-43E12A719D70}" type="slidenum">
               <a:rPr lang="en-US" smtClean="0"/>
               <a:t>‹#›</a:t>
             </a:fld>
@@ -2143,7 +2143,7 @@
     </p:spTree>
     <p:extLst>
       <p:ext uri="{BB962C8B-B14F-4D97-AF65-F5344CB8AC3E}">
-        <p14:creationId xmlns:p14="http://schemas.microsoft.com/office/powerpoint/2010/main" val="132690962"/>
+        <p14:creationId xmlns:p14="http://schemas.microsoft.com/office/powerpoint/2010/main" val="1087883133"/>
       </p:ext>
     </p:extLst>
   </p:cSld>
@@ -2175,7 +2175,7 @@
           <p:cNvPr id="2" name="Title 1">
             <a:extLst>
               <a:ext uri="{FF2B5EF4-FFF2-40B4-BE49-F238E27FC236}">
-                <a16:creationId xmlns:a16="http://schemas.microsoft.com/office/drawing/2014/main" id="{35AE0F04-55EA-6438-3514-68F5D819527A}"/>
+                <a16:creationId xmlns:a16="http://schemas.microsoft.com/office/drawing/2014/main" id="{116B97CC-F04C-BBD9-CBFB-B447893A585F}"/>
               </a:ext>
             </a:extLst>
           </p:cNvPr>
@@ -2212,7 +2212,7 @@
           <p:cNvPr id="3" name="Content Placeholder 2">
             <a:extLst>
               <a:ext uri="{FF2B5EF4-FFF2-40B4-BE49-F238E27FC236}">
-                <a16:creationId xmlns:a16="http://schemas.microsoft.com/office/drawing/2014/main" id="{FC4E39ED-2FAC-13D3-EB3D-180868062A61}"/>
+                <a16:creationId xmlns:a16="http://schemas.microsoft.com/office/drawing/2014/main" id="{85568603-CFBC-EE50-0ED8-B8E3F645630C}"/>
               </a:ext>
             </a:extLst>
           </p:cNvPr>
@@ -2302,7 +2302,7 @@
           <p:cNvPr id="4" name="Text Placeholder 3">
             <a:extLst>
               <a:ext uri="{FF2B5EF4-FFF2-40B4-BE49-F238E27FC236}">
-                <a16:creationId xmlns:a16="http://schemas.microsoft.com/office/drawing/2014/main" id="{9880271D-EA94-67D9-36B0-AD3D6A29C803}"/>
+                <a16:creationId xmlns:a16="http://schemas.microsoft.com/office/drawing/2014/main" id="{29FB8B6E-30FC-1C88-8B20-DB6601073F71}"/>
               </a:ext>
             </a:extLst>
           </p:cNvPr>
@@ -2373,7 +2373,7 @@
           <p:cNvPr id="5" name="Date Placeholder 4">
             <a:extLst>
               <a:ext uri="{FF2B5EF4-FFF2-40B4-BE49-F238E27FC236}">
-                <a16:creationId xmlns:a16="http://schemas.microsoft.com/office/drawing/2014/main" id="{C285C521-7A69-3C60-3950-285D02F9FC2F}"/>
+                <a16:creationId xmlns:a16="http://schemas.microsoft.com/office/drawing/2014/main" id="{019E3F94-C212-3AB8-C889-2D1A4D150973}"/>
               </a:ext>
             </a:extLst>
           </p:cNvPr>
@@ -2389,7 +2389,7 @@
           <a:bodyPr/>
           <a:lstStyle/>
           <a:p>
-            <a:fld id="{6460E8BC-2008-488A-91D3-42E9EA121979}" type="datetimeFigureOut">
+            <a:fld id="{06F0BCA8-90DB-4D97-BB85-C321F5FFDC10}" type="datetimeFigureOut">
               <a:rPr lang="en-US" smtClean="0"/>
               <a:t>7/11/2026</a:t>
             </a:fld>
@@ -2402,7 +2402,7 @@
           <p:cNvPr id="6" name="Footer Placeholder 5">
             <a:extLst>
               <a:ext uri="{FF2B5EF4-FFF2-40B4-BE49-F238E27FC236}">
-                <a16:creationId xmlns:a16="http://schemas.microsoft.com/office/drawing/2014/main" id="{E19E9C6B-765C-96FC-F46C-8AA78D78440A}"/>
+                <a16:creationId xmlns:a16="http://schemas.microsoft.com/office/drawing/2014/main" id="{75B37CA8-B6E7-ECBA-97E0-F90539858DBD}"/>
               </a:ext>
             </a:extLst>
           </p:cNvPr>
@@ -2427,7 +2427,7 @@
           <p:cNvPr id="7" name="Slide Number Placeholder 6">
             <a:extLst>
               <a:ext uri="{FF2B5EF4-FFF2-40B4-BE49-F238E27FC236}">
-                <a16:creationId xmlns:a16="http://schemas.microsoft.com/office/drawing/2014/main" id="{A4927617-6036-8BA5-C8FA-BC646BCAFDA6}"/>
+                <a16:creationId xmlns:a16="http://schemas.microsoft.com/office/drawing/2014/main" id="{CCF96257-E97E-EA7B-FC4E-775052290470}"/>
               </a:ext>
             </a:extLst>
           </p:cNvPr>
@@ -2443,7 +2443,7 @@
           <a:bodyPr/>
           <a:lstStyle/>
           <a:p>
-            <a:fld id="{D1098AEC-CBAB-47D2-8592-558BC0B61040}" type="slidenum">
+            <a:fld id="{0BDB6D22-B9A3-4D53-BECF-43E12A719D70}" type="slidenum">
               <a:rPr lang="en-US" smtClean="0"/>
               <a:t>‹#›</a:t>
             </a:fld>
@@ -2454,7 +2454,7 @@
     </p:spTree>
     <p:extLst>
       <p:ext uri="{BB962C8B-B14F-4D97-AF65-F5344CB8AC3E}">
-        <p14:creationId xmlns:p14="http://schemas.microsoft.com/office/powerpoint/2010/main" val="541805816"/>
+        <p14:creationId xmlns:p14="http://schemas.microsoft.com/office/powerpoint/2010/main" val="3922041337"/>
       </p:ext>
     </p:extLst>
   </p:cSld>
@@ -2486,7 +2486,7 @@
           <p:cNvPr id="2" name="Title 1">
             <a:extLst>
               <a:ext uri="{FF2B5EF4-FFF2-40B4-BE49-F238E27FC236}">
-                <a16:creationId xmlns:a16="http://schemas.microsoft.com/office/drawing/2014/main" id="{BCE5B46E-0307-FA37-1A44-570433406C67}"/>
+                <a16:creationId xmlns:a16="http://schemas.microsoft.com/office/drawing/2014/main" id="{6ABD9324-7165-8BB8-E419-46F0F96A2F6E}"/>
               </a:ext>
             </a:extLst>
           </p:cNvPr>
@@ -2523,7 +2523,7 @@
           <p:cNvPr id="3" name="Picture Placeholder 2">
             <a:extLst>
               <a:ext uri="{FF2B5EF4-FFF2-40B4-BE49-F238E27FC236}">
-                <a16:creationId xmlns:a16="http://schemas.microsoft.com/office/drawing/2014/main" id="{BCF8D6B1-D626-676D-3C9F-E36D42434148}"/>
+                <a16:creationId xmlns:a16="http://schemas.microsoft.com/office/drawing/2014/main" id="{0423B0F0-DD01-77AA-C828-2B3BA42AFD53}"/>
               </a:ext>
             </a:extLst>
           </p:cNvPr>
@@ -2590,7 +2590,7 @@
           <p:cNvPr id="4" name="Text Placeholder 3">
             <a:extLst>
               <a:ext uri="{FF2B5EF4-FFF2-40B4-BE49-F238E27FC236}">
-                <a16:creationId xmlns:a16="http://schemas.microsoft.com/office/drawing/2014/main" id="{E1B8CCFB-E58E-8541-0043-50EA2476D797}"/>
+                <a16:creationId xmlns:a16="http://schemas.microsoft.com/office/drawing/2014/main" id="{F5A2B303-4BE2-58ED-AABE-45F334661E5A}"/>
               </a:ext>
             </a:extLst>
           </p:cNvPr>
@@ -2661,7 +2661,7 @@
           <p:cNvPr id="5" name="Date Placeholder 4">
             <a:extLst>
               <a:ext uri="{FF2B5EF4-FFF2-40B4-BE49-F238E27FC236}">
-                <a16:creationId xmlns:a16="http://schemas.microsoft.com/office/drawing/2014/main" id="{B21C9E45-1E1B-2DCB-BCC0-4C8D012BEC08}"/>
+                <a16:creationId xmlns:a16="http://schemas.microsoft.com/office/drawing/2014/main" id="{0E4D6E39-21F8-AAA5-4BE5-13EE60F6F8FF}"/>
               </a:ext>
             </a:extLst>
           </p:cNvPr>
@@ -2677,7 +2677,7 @@
           <a:bodyPr/>
           <a:lstStyle/>
           <a:p>
-            <a:fld id="{6460E8BC-2008-488A-91D3-42E9EA121979}" type="datetimeFigureOut">
+            <a:fld id="{06F0BCA8-90DB-4D97-BB85-C321F5FFDC10}" type="datetimeFigureOut">
               <a:rPr lang="en-US" smtClean="0"/>
               <a:t>7/11/2026</a:t>
             </a:fld>
@@ -2690,7 +2690,7 @@
           <p:cNvPr id="6" name="Footer Placeholder 5">
             <a:extLst>
               <a:ext uri="{FF2B5EF4-FFF2-40B4-BE49-F238E27FC236}">
-                <a16:creationId xmlns:a16="http://schemas.microsoft.com/office/drawing/2014/main" id="{C35D755C-026E-A367-BBBB-7F3119B37C8F}"/>
+                <a16:creationId xmlns:a16="http://schemas.microsoft.com/office/drawing/2014/main" id="{D731C5D6-98D4-1413-6966-6CADE96A57E0}"/>
               </a:ext>
             </a:extLst>
           </p:cNvPr>
@@ -2715,7 +2715,7 @@
           <p:cNvPr id="7" name="Slide Number Placeholder 6">
             <a:extLst>
               <a:ext uri="{FF2B5EF4-FFF2-40B4-BE49-F238E27FC236}">
-                <a16:creationId xmlns:a16="http://schemas.microsoft.com/office/drawing/2014/main" id="{042D521B-F4D1-904E-9BC3-B75D75D4C95C}"/>
+                <a16:creationId xmlns:a16="http://schemas.microsoft.com/office/drawing/2014/main" id="{B66F6484-655B-90D2-72D9-C47DD7E4F937}"/>
               </a:ext>
             </a:extLst>
           </p:cNvPr>
@@ -2731,7 +2731,7 @@
           <a:bodyPr/>
           <a:lstStyle/>
           <a:p>
-            <a:fld id="{D1098AEC-CBAB-47D2-8592-558BC0B61040}" type="slidenum">
+            <a:fld id="{0BDB6D22-B9A3-4D53-BECF-43E12A719D70}" type="slidenum">
               <a:rPr lang="en-US" smtClean="0"/>
               <a:t>‹#›</a:t>
             </a:fld>
@@ -2742,7 +2742,7 @@
     </p:spTree>
     <p:extLst>
       <p:ext uri="{BB962C8B-B14F-4D97-AF65-F5344CB8AC3E}">
-        <p14:creationId xmlns:p14="http://schemas.microsoft.com/office/powerpoint/2010/main" val="2096461149"/>
+        <p14:creationId xmlns:p14="http://schemas.microsoft.com/office/powerpoint/2010/main" val="108997241"/>
       </p:ext>
     </p:extLst>
   </p:cSld>
@@ -2779,7 +2779,7 @@
           <p:cNvPr id="2" name="Title Placeholder 1">
             <a:extLst>
               <a:ext uri="{FF2B5EF4-FFF2-40B4-BE49-F238E27FC236}">
-                <a16:creationId xmlns:a16="http://schemas.microsoft.com/office/drawing/2014/main" id="{E39F5386-DC2B-A2AD-5FAB-FFC9369669F9}"/>
+                <a16:creationId xmlns:a16="http://schemas.microsoft.com/office/drawing/2014/main" id="{899F6976-5CCD-0196-19EF-542AFC2BAD0E}"/>
               </a:ext>
             </a:extLst>
           </p:cNvPr>
@@ -2817,7 +2817,7 @@
           <p:cNvPr id="3" name="Text Placeholder 2">
             <a:extLst>
               <a:ext uri="{FF2B5EF4-FFF2-40B4-BE49-F238E27FC236}">
-                <a16:creationId xmlns:a16="http://schemas.microsoft.com/office/drawing/2014/main" id="{A6596686-C609-889C-79EA-E5C1D2E4B682}"/>
+                <a16:creationId xmlns:a16="http://schemas.microsoft.com/office/drawing/2014/main" id="{3ADCABB7-7ACD-D6BE-A594-E038401AD98E}"/>
               </a:ext>
             </a:extLst>
           </p:cNvPr>
@@ -2884,7 +2884,7 @@
           <p:cNvPr id="4" name="Date Placeholder 3">
             <a:extLst>
               <a:ext uri="{FF2B5EF4-FFF2-40B4-BE49-F238E27FC236}">
-                <a16:creationId xmlns:a16="http://schemas.microsoft.com/office/drawing/2014/main" id="{48516CDA-913D-9CD5-C8CB-E08C4C191E74}"/>
+                <a16:creationId xmlns:a16="http://schemas.microsoft.com/office/drawing/2014/main" id="{CD12C3C1-71CF-442B-AD15-011D5AF8A02C}"/>
               </a:ext>
             </a:extLst>
           </p:cNvPr>
@@ -2918,7 +2918,7 @@
             </a:lvl1pPr>
           </a:lstStyle>
           <a:p>
-            <a:fld id="{6460E8BC-2008-488A-91D3-42E9EA121979}" type="datetimeFigureOut">
+            <a:fld id="{06F0BCA8-90DB-4D97-BB85-C321F5FFDC10}" type="datetimeFigureOut">
               <a:rPr lang="en-US" smtClean="0"/>
               <a:t>7/11/2026</a:t>
             </a:fld>
@@ -2931,7 +2931,7 @@
           <p:cNvPr id="5" name="Footer Placeholder 4">
             <a:extLst>
               <a:ext uri="{FF2B5EF4-FFF2-40B4-BE49-F238E27FC236}">
-                <a16:creationId xmlns:a16="http://schemas.microsoft.com/office/drawing/2014/main" id="{1F70AB4B-A160-D815-E764-D090E69BF4CF}"/>
+                <a16:creationId xmlns:a16="http://schemas.microsoft.com/office/drawing/2014/main" id="{9A1B1181-FC50-0D05-9F87-F4F42E84ABE3}"/>
               </a:ext>
             </a:extLst>
           </p:cNvPr>
@@ -2974,7 +2974,7 @@
           <p:cNvPr id="6" name="Slide Number Placeholder 5">
             <a:extLst>
               <a:ext uri="{FF2B5EF4-FFF2-40B4-BE49-F238E27FC236}">
-                <a16:creationId xmlns:a16="http://schemas.microsoft.com/office/drawing/2014/main" id="{182A4641-6E46-7AA8-E987-96F8A47104BA}"/>
+                <a16:creationId xmlns:a16="http://schemas.microsoft.com/office/drawing/2014/main" id="{52019BA1-5D6B-C203-25CF-992D10EC8584}"/>
               </a:ext>
             </a:extLst>
           </p:cNvPr>
@@ -3008,7 +3008,7 @@
             </a:lvl1pPr>
           </a:lstStyle>
           <a:p>
-            <a:fld id="{D1098AEC-CBAB-47D2-8592-558BC0B61040}" type="slidenum">
+            <a:fld id="{0BDB6D22-B9A3-4D53-BECF-43E12A719D70}" type="slidenum">
               <a:rPr lang="en-US" smtClean="0"/>
               <a:t>‹#›</a:t>
             </a:fld>
@@ -3019,7 +3019,7 @@
     </p:spTree>
     <p:extLst>
       <p:ext uri="{BB962C8B-B14F-4D97-AF65-F5344CB8AC3E}">
-        <p14:creationId xmlns:p14="http://schemas.microsoft.com/office/powerpoint/2010/main" val="2932324880"/>
+        <p14:creationId xmlns:p14="http://schemas.microsoft.com/office/powerpoint/2010/main" val="370525170"/>
       </p:ext>
     </p:extLst>
   </p:cSld>
@@ -3342,7 +3342,7 @@
           <p:cNvPr id="3" name="Graphic 2">
             <a:extLst>
               <a:ext uri="{FF2B5EF4-FFF2-40B4-BE49-F238E27FC236}">
-                <a16:creationId xmlns:a16="http://schemas.microsoft.com/office/drawing/2014/main" id="{A3C7D3A9-C238-F68C-55F0-B57BD8945043}"/>
+                <a16:creationId xmlns:a16="http://schemas.microsoft.com/office/drawing/2014/main" id="{CAAA78F5-DC53-DFAF-6A9B-FBB2374664F9}"/>
               </a:ext>
             </a:extLst>
           </p:cNvPr>
@@ -3376,7 +3376,7 @@
     </p:spTree>
     <p:extLst>
       <p:ext uri="{BB962C8B-B14F-4D97-AF65-F5344CB8AC3E}">
-        <p14:creationId xmlns:p14="http://schemas.microsoft.com/office/powerpoint/2010/main" val="4081669220"/>
+        <p14:creationId xmlns:p14="http://schemas.microsoft.com/office/powerpoint/2010/main" val="3379358246"/>
       </p:ext>
     </p:extLst>
   </p:cSld>
@@ -3408,7 +3408,7 @@
           <p:cNvPr id="3" name="Graphic 2">
             <a:extLst>
               <a:ext uri="{FF2B5EF4-FFF2-40B4-BE49-F238E27FC236}">
-                <a16:creationId xmlns:a16="http://schemas.microsoft.com/office/drawing/2014/main" id="{283CF6F5-3D13-04D1-8D55-7CD439FEE736}"/>
+                <a16:creationId xmlns:a16="http://schemas.microsoft.com/office/drawing/2014/main" id="{A8987AE6-B244-7516-94F4-E152CAE9D5E1}"/>
               </a:ext>
             </a:extLst>
           </p:cNvPr>
@@ -3442,7 +3442,7 @@
     </p:spTree>
     <p:extLst>
       <p:ext uri="{BB962C8B-B14F-4D97-AF65-F5344CB8AC3E}">
-        <p14:creationId xmlns:p14="http://schemas.microsoft.com/office/powerpoint/2010/main" val="3953688906"/>
+        <p14:creationId xmlns:p14="http://schemas.microsoft.com/office/powerpoint/2010/main" val="1549981714"/>
       </p:ext>
     </p:extLst>
   </p:cSld>
@@ -3474,7 +3474,7 @@
           <p:cNvPr id="3" name="Graphic 2">
             <a:extLst>
               <a:ext uri="{FF2B5EF4-FFF2-40B4-BE49-F238E27FC236}">
-                <a16:creationId xmlns:a16="http://schemas.microsoft.com/office/drawing/2014/main" id="{7030A12B-ECB7-65F6-88F9-6C00B045CEF6}"/>
+                <a16:creationId xmlns:a16="http://schemas.microsoft.com/office/drawing/2014/main" id="{8184365A-06F4-36CE-9772-56140B50664F}"/>
               </a:ext>
             </a:extLst>
           </p:cNvPr>
@@ -3508,7 +3508,7 @@
     </p:spTree>
     <p:extLst>
       <p:ext uri="{BB962C8B-B14F-4D97-AF65-F5344CB8AC3E}">
-        <p14:creationId xmlns:p14="http://schemas.microsoft.com/office/powerpoint/2010/main" val="4039121936"/>
+        <p14:creationId xmlns:p14="http://schemas.microsoft.com/office/powerpoint/2010/main" val="2938935809"/>
       </p:ext>
     </p:extLst>
   </p:cSld>
@@ -3540,7 +3540,7 @@
           <p:cNvPr id="3" name="Graphic 2">
             <a:extLst>
               <a:ext uri="{FF2B5EF4-FFF2-40B4-BE49-F238E27FC236}">
-                <a16:creationId xmlns:a16="http://schemas.microsoft.com/office/drawing/2014/main" id="{75190DB2-5224-460F-866B-B9F2322122E5}"/>
+                <a16:creationId xmlns:a16="http://schemas.microsoft.com/office/drawing/2014/main" id="{09E4DBDD-265D-F4A4-8260-3E0ED490121B}"/>
               </a:ext>
             </a:extLst>
           </p:cNvPr>
@@ -3574,7 +3574,7 @@
     </p:spTree>
     <p:extLst>
       <p:ext uri="{BB962C8B-B14F-4D97-AF65-F5344CB8AC3E}">
-        <p14:creationId xmlns:p14="http://schemas.microsoft.com/office/powerpoint/2010/main" val="2019174981"/>
+        <p14:creationId xmlns:p14="http://schemas.microsoft.com/office/powerpoint/2010/main" val="880126653"/>
       </p:ext>
     </p:extLst>
   </p:cSld>
@@ -3606,7 +3606,7 @@
           <p:cNvPr id="3" name="Graphic 2">
             <a:extLst>
               <a:ext uri="{FF2B5EF4-FFF2-40B4-BE49-F238E27FC236}">
-                <a16:creationId xmlns:a16="http://schemas.microsoft.com/office/drawing/2014/main" id="{9DA0ED23-8AAC-C11D-2EF1-DA92F1C0F275}"/>
+                <a16:creationId xmlns:a16="http://schemas.microsoft.com/office/drawing/2014/main" id="{A44668FD-A7E0-947F-9816-6A894B2CAC3C}"/>
               </a:ext>
             </a:extLst>
           </p:cNvPr>
@@ -3640,7 +3640,7 @@
     </p:spTree>
     <p:extLst>
       <p:ext uri="{BB962C8B-B14F-4D97-AF65-F5344CB8AC3E}">
-        <p14:creationId xmlns:p14="http://schemas.microsoft.com/office/powerpoint/2010/main" val="1936292533"/>
+        <p14:creationId xmlns:p14="http://schemas.microsoft.com/office/powerpoint/2010/main" val="3625774391"/>
       </p:ext>
     </p:extLst>
   </p:cSld>
@@ -3672,7 +3672,7 @@
           <p:cNvPr id="3" name="Graphic 2">
             <a:extLst>
               <a:ext uri="{FF2B5EF4-FFF2-40B4-BE49-F238E27FC236}">
-                <a16:creationId xmlns:a16="http://schemas.microsoft.com/office/drawing/2014/main" id="{C8ADBA7B-D95E-AEEC-AA0C-E580E2D8AC60}"/>
+                <a16:creationId xmlns:a16="http://schemas.microsoft.com/office/drawing/2014/main" id="{CF0930BE-11D2-D563-328E-E895F5EEA9B7}"/>
               </a:ext>
             </a:extLst>
           </p:cNvPr>
@@ -3706,7 +3706,7 @@
     </p:spTree>
     <p:extLst>
       <p:ext uri="{BB962C8B-B14F-4D97-AF65-F5344CB8AC3E}">
-        <p14:creationId xmlns:p14="http://schemas.microsoft.com/office/powerpoint/2010/main" val="4104730675"/>
+        <p14:creationId xmlns:p14="http://schemas.microsoft.com/office/powerpoint/2010/main" val="2832981894"/>
       </p:ext>
     </p:extLst>
   </p:cSld>
@@ -3738,7 +3738,7 @@
           <p:cNvPr id="3" name="Graphic 2">
             <a:extLst>
               <a:ext uri="{FF2B5EF4-FFF2-40B4-BE49-F238E27FC236}">
-                <a16:creationId xmlns:a16="http://schemas.microsoft.com/office/drawing/2014/main" id="{71F75FEA-A8B9-FEE2-CA56-9C95064A05EE}"/>
+                <a16:creationId xmlns:a16="http://schemas.microsoft.com/office/drawing/2014/main" id="{F7C1D1B2-99D5-EC4F-32C4-5FC838D330D4}"/>
               </a:ext>
             </a:extLst>
           </p:cNvPr>
@@ -3772,7 +3772,7 @@
     </p:spTree>
     <p:extLst>
       <p:ext uri="{BB962C8B-B14F-4D97-AF65-F5344CB8AC3E}">
-        <p14:creationId xmlns:p14="http://schemas.microsoft.com/office/powerpoint/2010/main" val="1293303525"/>
+        <p14:creationId xmlns:p14="http://schemas.microsoft.com/office/powerpoint/2010/main" val="2430454025"/>
       </p:ext>
     </p:extLst>
   </p:cSld>
@@ -3804,7 +3804,7 @@
           <p:cNvPr id="3" name="Graphic 2">
             <a:extLst>
               <a:ext uri="{FF2B5EF4-FFF2-40B4-BE49-F238E27FC236}">
-                <a16:creationId xmlns:a16="http://schemas.microsoft.com/office/drawing/2014/main" id="{524E0FF1-153B-65A0-96DC-2109BE2C2EA3}"/>
+                <a16:creationId xmlns:a16="http://schemas.microsoft.com/office/drawing/2014/main" id="{1A4316F7-91FA-D3CB-1B5D-B7EE0585997E}"/>
               </a:ext>
             </a:extLst>
           </p:cNvPr>
@@ -3838,7 +3838,7 @@
     </p:spTree>
     <p:extLst>
       <p:ext uri="{BB962C8B-B14F-4D97-AF65-F5344CB8AC3E}">
-        <p14:creationId xmlns:p14="http://schemas.microsoft.com/office/powerpoint/2010/main" val="583190438"/>
+        <p14:creationId xmlns:p14="http://schemas.microsoft.com/office/powerpoint/2010/main" val="498321637"/>
       </p:ext>
     </p:extLst>
   </p:cSld>
@@ -3870,7 +3870,7 @@
           <p:cNvPr id="3" name="Graphic 2">
             <a:extLst>
               <a:ext uri="{FF2B5EF4-FFF2-40B4-BE49-F238E27FC236}">
-                <a16:creationId xmlns:a16="http://schemas.microsoft.com/office/drawing/2014/main" id="{FEEB56B5-A0BD-07BC-A6FA-9D4D68FFBF76}"/>
+                <a16:creationId xmlns:a16="http://schemas.microsoft.com/office/drawing/2014/main" id="{ACE8E3D8-6052-7A5B-4944-59CD4080A7A9}"/>
               </a:ext>
             </a:extLst>
           </p:cNvPr>
@@ -3904,7 +3904,7 @@
     </p:spTree>
     <p:extLst>
       <p:ext uri="{BB962C8B-B14F-4D97-AF65-F5344CB8AC3E}">
-        <p14:creationId xmlns:p14="http://schemas.microsoft.com/office/powerpoint/2010/main" val="225370991"/>
+        <p14:creationId xmlns:p14="http://schemas.microsoft.com/office/powerpoint/2010/main" val="2865797827"/>
       </p:ext>
     </p:extLst>
   </p:cSld>
@@ -3936,7 +3936,7 @@
           <p:cNvPr id="3" name="Graphic 2">
             <a:extLst>
               <a:ext uri="{FF2B5EF4-FFF2-40B4-BE49-F238E27FC236}">
-                <a16:creationId xmlns:a16="http://schemas.microsoft.com/office/drawing/2014/main" id="{F5109D40-C484-EC73-7C9D-C6B310D2A16E}"/>
+                <a16:creationId xmlns:a16="http://schemas.microsoft.com/office/drawing/2014/main" id="{68508788-0F4D-2980-3ECF-1221CD6956E3}"/>
               </a:ext>
             </a:extLst>
           </p:cNvPr>
@@ -3970,7 +3970,7 @@
     </p:spTree>
     <p:extLst>
       <p:ext uri="{BB962C8B-B14F-4D97-AF65-F5344CB8AC3E}">
-        <p14:creationId xmlns:p14="http://schemas.microsoft.com/office/powerpoint/2010/main" val="1009400312"/>
+        <p14:creationId xmlns:p14="http://schemas.microsoft.com/office/powerpoint/2010/main" val="3076005136"/>
       </p:ext>
     </p:extLst>
   </p:cSld>
@@ -4002,7 +4002,7 @@
           <p:cNvPr id="3" name="Graphic 2">
             <a:extLst>
               <a:ext uri="{FF2B5EF4-FFF2-40B4-BE49-F238E27FC236}">
-                <a16:creationId xmlns:a16="http://schemas.microsoft.com/office/drawing/2014/main" id="{F0262E2C-C5D0-B679-9C18-0C10E4A59BC9}"/>
+                <a16:creationId xmlns:a16="http://schemas.microsoft.com/office/drawing/2014/main" id="{8929B8F8-6F79-A89C-B1CC-87E61DF67672}"/>
               </a:ext>
             </a:extLst>
           </p:cNvPr>
@@ -4036,7 +4036,7 @@
     </p:spTree>
     <p:extLst>
       <p:ext uri="{BB962C8B-B14F-4D97-AF65-F5344CB8AC3E}">
-        <p14:creationId xmlns:p14="http://schemas.microsoft.com/office/powerpoint/2010/main" val="2840240341"/>
+        <p14:creationId xmlns:p14="http://schemas.microsoft.com/office/powerpoint/2010/main" val="2136554912"/>
       </p:ext>
     </p:extLst>
   </p:cSld>
@@ -4068,7 +4068,7 @@
           <p:cNvPr id="3" name="Graphic 2">
             <a:extLst>
               <a:ext uri="{FF2B5EF4-FFF2-40B4-BE49-F238E27FC236}">
-                <a16:creationId xmlns:a16="http://schemas.microsoft.com/office/drawing/2014/main" id="{97B895BA-2A80-921E-179A-77EFD2FCFAF1}"/>
+                <a16:creationId xmlns:a16="http://schemas.microsoft.com/office/drawing/2014/main" id="{E740EED8-E6F4-0845-8354-0313DE936269}"/>
               </a:ext>
             </a:extLst>
           </p:cNvPr>
@@ -4102,7 +4102,7 @@
     </p:spTree>
     <p:extLst>
       <p:ext uri="{BB962C8B-B14F-4D97-AF65-F5344CB8AC3E}">
-        <p14:creationId xmlns:p14="http://schemas.microsoft.com/office/powerpoint/2010/main" val="759380427"/>
+        <p14:creationId xmlns:p14="http://schemas.microsoft.com/office/powerpoint/2010/main" val="3827906272"/>
       </p:ext>
     </p:extLst>
   </p:cSld>
@@ -4134,7 +4134,7 @@
           <p:cNvPr id="3" name="Graphic 2">
             <a:extLst>
               <a:ext uri="{FF2B5EF4-FFF2-40B4-BE49-F238E27FC236}">
-                <a16:creationId xmlns:a16="http://schemas.microsoft.com/office/drawing/2014/main" id="{28109043-D0DC-D92A-1A85-E23D121478DB}"/>
+                <a16:creationId xmlns:a16="http://schemas.microsoft.com/office/drawing/2014/main" id="{AE039402-43F4-B7A5-E1F3-7D4E75A7D198}"/>
               </a:ext>
             </a:extLst>
           </p:cNvPr>
@@ -4168,7 +4168,7 @@
     </p:spTree>
     <p:extLst>
       <p:ext uri="{BB962C8B-B14F-4D97-AF65-F5344CB8AC3E}">
-        <p14:creationId xmlns:p14="http://schemas.microsoft.com/office/powerpoint/2010/main" val="4017089264"/>
+        <p14:creationId xmlns:p14="http://schemas.microsoft.com/office/powerpoint/2010/main" val="1260385467"/>
       </p:ext>
     </p:extLst>
   </p:cSld>
@@ -4200,7 +4200,7 @@
           <p:cNvPr id="3" name="Graphic 2">
             <a:extLst>
               <a:ext uri="{FF2B5EF4-FFF2-40B4-BE49-F238E27FC236}">
-                <a16:creationId xmlns:a16="http://schemas.microsoft.com/office/drawing/2014/main" id="{0AC63663-2EA0-351F-F31B-12F00AAB2E98}"/>
+                <a16:creationId xmlns:a16="http://schemas.microsoft.com/office/drawing/2014/main" id="{9A61B24C-2A02-A717-62D3-51C410ECE1A3}"/>
               </a:ext>
             </a:extLst>
           </p:cNvPr>
@@ -4234,7 +4234,7 @@
     </p:spTree>
     <p:extLst>
       <p:ext uri="{BB962C8B-B14F-4D97-AF65-F5344CB8AC3E}">
-        <p14:creationId xmlns:p14="http://schemas.microsoft.com/office/powerpoint/2010/main" val="986445224"/>
+        <p14:creationId xmlns:p14="http://schemas.microsoft.com/office/powerpoint/2010/main" val="1536116679"/>
       </p:ext>
     </p:extLst>
   </p:cSld>
@@ -4266,7 +4266,7 @@
           <p:cNvPr id="3" name="Graphic 2">
             <a:extLst>
               <a:ext uri="{FF2B5EF4-FFF2-40B4-BE49-F238E27FC236}">
-                <a16:creationId xmlns:a16="http://schemas.microsoft.com/office/drawing/2014/main" id="{C8D18C86-FDD0-3ADD-22F8-738B41C8414F}"/>
+                <a16:creationId xmlns:a16="http://schemas.microsoft.com/office/drawing/2014/main" id="{C2A5E449-482E-894B-B401-C87560505E92}"/>
               </a:ext>
             </a:extLst>
           </p:cNvPr>
@@ -4300,7 +4300,7 @@
     </p:spTree>
     <p:extLst>
       <p:ext uri="{BB962C8B-B14F-4D97-AF65-F5344CB8AC3E}">
-        <p14:creationId xmlns:p14="http://schemas.microsoft.com/office/powerpoint/2010/main" val="1539388671"/>
+        <p14:creationId xmlns:p14="http://schemas.microsoft.com/office/powerpoint/2010/main" val="3571904793"/>
       </p:ext>
     </p:extLst>
   </p:cSld>
@@ -4332,7 +4332,7 @@
           <p:cNvPr id="3" name="Graphic 2">
             <a:extLst>
               <a:ext uri="{FF2B5EF4-FFF2-40B4-BE49-F238E27FC236}">
-                <a16:creationId xmlns:a16="http://schemas.microsoft.com/office/drawing/2014/main" id="{0108D528-13C8-5FB4-63F1-4F8D243CBEAA}"/>
+                <a16:creationId xmlns:a16="http://schemas.microsoft.com/office/drawing/2014/main" id="{461A9A40-C089-F6AA-65EB-62FA7EA7B993}"/>
               </a:ext>
             </a:extLst>
           </p:cNvPr>
@@ -4366,7 +4366,7 @@
     </p:spTree>
     <p:extLst>
       <p:ext uri="{BB962C8B-B14F-4D97-AF65-F5344CB8AC3E}">
-        <p14:creationId xmlns:p14="http://schemas.microsoft.com/office/powerpoint/2010/main" val="2252675723"/>
+        <p14:creationId xmlns:p14="http://schemas.microsoft.com/office/powerpoint/2010/main" val="2833709363"/>
       </p:ext>
     </p:extLst>
   </p:cSld>
@@ -4398,7 +4398,7 @@
           <p:cNvPr id="3" name="Graphic 2">
             <a:extLst>
               <a:ext uri="{FF2B5EF4-FFF2-40B4-BE49-F238E27FC236}">
-                <a16:creationId xmlns:a16="http://schemas.microsoft.com/office/drawing/2014/main" id="{0FFA3141-0F32-5545-0E9A-A0D50B5F215E}"/>
+                <a16:creationId xmlns:a16="http://schemas.microsoft.com/office/drawing/2014/main" id="{11C6731D-DA96-3F78-BAE8-18C158D7E094}"/>
               </a:ext>
             </a:extLst>
           </p:cNvPr>
@@ -4432,7 +4432,7 @@
     </p:spTree>
     <p:extLst>
       <p:ext uri="{BB962C8B-B14F-4D97-AF65-F5344CB8AC3E}">
-        <p14:creationId xmlns:p14="http://schemas.microsoft.com/office/powerpoint/2010/main" val="2379754349"/>
+        <p14:creationId xmlns:p14="http://schemas.microsoft.com/office/powerpoint/2010/main" val="470052688"/>
       </p:ext>
     </p:extLst>
   </p:cSld>

</xml_diff>

<commit_message>
refactor(svg): replace foreignObject with native SVG
</commit_message>
<xml_diff>
--- a/Desktop/Proposal/exports/LeadFlow-Proposal-v1.0.pptx
+++ b/Desktop/Proposal/exports/LeadFlow-Proposal-v1.0.pptx
@@ -145,7 +145,7 @@
           <p:cNvPr id="2" name="Title 1">
             <a:extLst>
               <a:ext uri="{FF2B5EF4-FFF2-40B4-BE49-F238E27FC236}">
-                <a16:creationId xmlns:a16="http://schemas.microsoft.com/office/drawing/2014/main" id="{C1E22094-4858-DD62-FCAC-4231B25C70F0}"/>
+                <a16:creationId xmlns:a16="http://schemas.microsoft.com/office/drawing/2014/main" id="{30126BE7-CC2A-E090-1516-3340998988DE}"/>
               </a:ext>
             </a:extLst>
           </p:cNvPr>
@@ -182,7 +182,7 @@
           <p:cNvPr id="3" name="Subtitle 2">
             <a:extLst>
               <a:ext uri="{FF2B5EF4-FFF2-40B4-BE49-F238E27FC236}">
-                <a16:creationId xmlns:a16="http://schemas.microsoft.com/office/drawing/2014/main" id="{AC8B790F-0AB7-462B-817A-E94E71850984}"/>
+                <a16:creationId xmlns:a16="http://schemas.microsoft.com/office/drawing/2014/main" id="{5D3739B2-54E2-5ECD-EFCC-F1F1C2D98285}"/>
               </a:ext>
             </a:extLst>
           </p:cNvPr>
@@ -252,7 +252,7 @@
           <p:cNvPr id="4" name="Date Placeholder 3">
             <a:extLst>
               <a:ext uri="{FF2B5EF4-FFF2-40B4-BE49-F238E27FC236}">
-                <a16:creationId xmlns:a16="http://schemas.microsoft.com/office/drawing/2014/main" id="{C3DABFA7-D100-5B1B-10B4-271B4604E99B}"/>
+                <a16:creationId xmlns:a16="http://schemas.microsoft.com/office/drawing/2014/main" id="{718BF69E-496A-EDD7-A6D2-3D81F12D95E7}"/>
               </a:ext>
             </a:extLst>
           </p:cNvPr>
@@ -268,7 +268,7 @@
           <a:bodyPr/>
           <a:lstStyle/>
           <a:p>
-            <a:fld id="{06F0BCA8-90DB-4D97-BB85-C321F5FFDC10}" type="datetimeFigureOut">
+            <a:fld id="{0BAD9C77-6EC3-4D89-8A0D-C68FA7E8B712}" type="datetimeFigureOut">
               <a:rPr lang="en-US" smtClean="0"/>
               <a:t>7/11/2026</a:t>
             </a:fld>
@@ -281,7 +281,7 @@
           <p:cNvPr id="5" name="Footer Placeholder 4">
             <a:extLst>
               <a:ext uri="{FF2B5EF4-FFF2-40B4-BE49-F238E27FC236}">
-                <a16:creationId xmlns:a16="http://schemas.microsoft.com/office/drawing/2014/main" id="{24C60BCF-9CB1-C49F-EAE0-0716DE770801}"/>
+                <a16:creationId xmlns:a16="http://schemas.microsoft.com/office/drawing/2014/main" id="{F2F112DC-C380-A937-BFFB-F0B04E555568}"/>
               </a:ext>
             </a:extLst>
           </p:cNvPr>
@@ -306,7 +306,7 @@
           <p:cNvPr id="6" name="Slide Number Placeholder 5">
             <a:extLst>
               <a:ext uri="{FF2B5EF4-FFF2-40B4-BE49-F238E27FC236}">
-                <a16:creationId xmlns:a16="http://schemas.microsoft.com/office/drawing/2014/main" id="{ADB868E1-27A1-DB55-3B6E-A77DDAAC6E96}"/>
+                <a16:creationId xmlns:a16="http://schemas.microsoft.com/office/drawing/2014/main" id="{0529C591-67B3-6D2F-3120-FAEFCE191C53}"/>
               </a:ext>
             </a:extLst>
           </p:cNvPr>
@@ -322,7 +322,7 @@
           <a:bodyPr/>
           <a:lstStyle/>
           <a:p>
-            <a:fld id="{0BDB6D22-B9A3-4D53-BECF-43E12A719D70}" type="slidenum">
+            <a:fld id="{DA215C20-D0E9-41CE-87D5-BCE849F24902}" type="slidenum">
               <a:rPr lang="en-US" smtClean="0"/>
               <a:t>‹#›</a:t>
             </a:fld>
@@ -333,7 +333,7 @@
     </p:spTree>
     <p:extLst>
       <p:ext uri="{BB962C8B-B14F-4D97-AF65-F5344CB8AC3E}">
-        <p14:creationId xmlns:p14="http://schemas.microsoft.com/office/powerpoint/2010/main" val="598486629"/>
+        <p14:creationId xmlns:p14="http://schemas.microsoft.com/office/powerpoint/2010/main" val="3710990470"/>
       </p:ext>
     </p:extLst>
   </p:cSld>
@@ -365,7 +365,7 @@
           <p:cNvPr id="2" name="Title 1">
             <a:extLst>
               <a:ext uri="{FF2B5EF4-FFF2-40B4-BE49-F238E27FC236}">
-                <a16:creationId xmlns:a16="http://schemas.microsoft.com/office/drawing/2014/main" id="{828910D2-0A12-91AD-9CBD-7B4E7A590F65}"/>
+                <a16:creationId xmlns:a16="http://schemas.microsoft.com/office/drawing/2014/main" id="{1CE76CDD-2BEB-A049-EEA0-D2AAEBAD4BE3}"/>
               </a:ext>
             </a:extLst>
           </p:cNvPr>
@@ -393,7 +393,7 @@
           <p:cNvPr id="3" name="Vertical Text Placeholder 2">
             <a:extLst>
               <a:ext uri="{FF2B5EF4-FFF2-40B4-BE49-F238E27FC236}">
-                <a16:creationId xmlns:a16="http://schemas.microsoft.com/office/drawing/2014/main" id="{67DAE542-5E3F-3AD1-90E3-CF9217B19B9D}"/>
+                <a16:creationId xmlns:a16="http://schemas.microsoft.com/office/drawing/2014/main" id="{53C8A72D-3D27-9F59-B4FD-0703471A6473}"/>
               </a:ext>
             </a:extLst>
           </p:cNvPr>
@@ -450,7 +450,7 @@
           <p:cNvPr id="4" name="Date Placeholder 3">
             <a:extLst>
               <a:ext uri="{FF2B5EF4-FFF2-40B4-BE49-F238E27FC236}">
-                <a16:creationId xmlns:a16="http://schemas.microsoft.com/office/drawing/2014/main" id="{613EB554-2CB9-C044-B212-097DA9C17251}"/>
+                <a16:creationId xmlns:a16="http://schemas.microsoft.com/office/drawing/2014/main" id="{90CCF179-7A3F-59FD-D77A-EAFB95F6C695}"/>
               </a:ext>
             </a:extLst>
           </p:cNvPr>
@@ -466,7 +466,7 @@
           <a:bodyPr/>
           <a:lstStyle/>
           <a:p>
-            <a:fld id="{06F0BCA8-90DB-4D97-BB85-C321F5FFDC10}" type="datetimeFigureOut">
+            <a:fld id="{0BAD9C77-6EC3-4D89-8A0D-C68FA7E8B712}" type="datetimeFigureOut">
               <a:rPr lang="en-US" smtClean="0"/>
               <a:t>7/11/2026</a:t>
             </a:fld>
@@ -479,7 +479,7 @@
           <p:cNvPr id="5" name="Footer Placeholder 4">
             <a:extLst>
               <a:ext uri="{FF2B5EF4-FFF2-40B4-BE49-F238E27FC236}">
-                <a16:creationId xmlns:a16="http://schemas.microsoft.com/office/drawing/2014/main" id="{80E6B62B-715E-1C26-8DCB-C943464A9CBB}"/>
+                <a16:creationId xmlns:a16="http://schemas.microsoft.com/office/drawing/2014/main" id="{6E39E8FA-E116-672A-BDEC-8B22F98CA690}"/>
               </a:ext>
             </a:extLst>
           </p:cNvPr>
@@ -504,7 +504,7 @@
           <p:cNvPr id="6" name="Slide Number Placeholder 5">
             <a:extLst>
               <a:ext uri="{FF2B5EF4-FFF2-40B4-BE49-F238E27FC236}">
-                <a16:creationId xmlns:a16="http://schemas.microsoft.com/office/drawing/2014/main" id="{D8595887-F983-43D6-490D-52E2BD44BA91}"/>
+                <a16:creationId xmlns:a16="http://schemas.microsoft.com/office/drawing/2014/main" id="{0B5E8556-153B-FB4E-058D-39F97F3B4999}"/>
               </a:ext>
             </a:extLst>
           </p:cNvPr>
@@ -520,7 +520,7 @@
           <a:bodyPr/>
           <a:lstStyle/>
           <a:p>
-            <a:fld id="{0BDB6D22-B9A3-4D53-BECF-43E12A719D70}" type="slidenum">
+            <a:fld id="{DA215C20-D0E9-41CE-87D5-BCE849F24902}" type="slidenum">
               <a:rPr lang="en-US" smtClean="0"/>
               <a:t>‹#›</a:t>
             </a:fld>
@@ -531,7 +531,7 @@
     </p:spTree>
     <p:extLst>
       <p:ext uri="{BB962C8B-B14F-4D97-AF65-F5344CB8AC3E}">
-        <p14:creationId xmlns:p14="http://schemas.microsoft.com/office/powerpoint/2010/main" val="3326148293"/>
+        <p14:creationId xmlns:p14="http://schemas.microsoft.com/office/powerpoint/2010/main" val="3379462897"/>
       </p:ext>
     </p:extLst>
   </p:cSld>
@@ -563,7 +563,7 @@
           <p:cNvPr id="2" name="Vertical Title 1">
             <a:extLst>
               <a:ext uri="{FF2B5EF4-FFF2-40B4-BE49-F238E27FC236}">
-                <a16:creationId xmlns:a16="http://schemas.microsoft.com/office/drawing/2014/main" id="{58C8F3FE-F186-1ADE-E521-BE17FD83EB7A}"/>
+                <a16:creationId xmlns:a16="http://schemas.microsoft.com/office/drawing/2014/main" id="{F87A2208-0942-77A5-0F2A-ABD6CBBEDF18}"/>
               </a:ext>
             </a:extLst>
           </p:cNvPr>
@@ -596,7 +596,7 @@
           <p:cNvPr id="3" name="Vertical Text Placeholder 2">
             <a:extLst>
               <a:ext uri="{FF2B5EF4-FFF2-40B4-BE49-F238E27FC236}">
-                <a16:creationId xmlns:a16="http://schemas.microsoft.com/office/drawing/2014/main" id="{E258FF9C-262D-DF97-8208-E9FD2E0412DC}"/>
+                <a16:creationId xmlns:a16="http://schemas.microsoft.com/office/drawing/2014/main" id="{EDCF593E-E429-5ECF-1227-AC08F94E3467}"/>
               </a:ext>
             </a:extLst>
           </p:cNvPr>
@@ -658,7 +658,7 @@
           <p:cNvPr id="4" name="Date Placeholder 3">
             <a:extLst>
               <a:ext uri="{FF2B5EF4-FFF2-40B4-BE49-F238E27FC236}">
-                <a16:creationId xmlns:a16="http://schemas.microsoft.com/office/drawing/2014/main" id="{626D5E98-FECF-DCD6-632E-A6A0D883CF50}"/>
+                <a16:creationId xmlns:a16="http://schemas.microsoft.com/office/drawing/2014/main" id="{F28B4FC3-8D59-ACFD-6DE9-308B96DD7C0E}"/>
               </a:ext>
             </a:extLst>
           </p:cNvPr>
@@ -674,7 +674,7 @@
           <a:bodyPr/>
           <a:lstStyle/>
           <a:p>
-            <a:fld id="{06F0BCA8-90DB-4D97-BB85-C321F5FFDC10}" type="datetimeFigureOut">
+            <a:fld id="{0BAD9C77-6EC3-4D89-8A0D-C68FA7E8B712}" type="datetimeFigureOut">
               <a:rPr lang="en-US" smtClean="0"/>
               <a:t>7/11/2026</a:t>
             </a:fld>
@@ -687,7 +687,7 @@
           <p:cNvPr id="5" name="Footer Placeholder 4">
             <a:extLst>
               <a:ext uri="{FF2B5EF4-FFF2-40B4-BE49-F238E27FC236}">
-                <a16:creationId xmlns:a16="http://schemas.microsoft.com/office/drawing/2014/main" id="{26456053-E3F9-63FE-E800-3A7A98ED8032}"/>
+                <a16:creationId xmlns:a16="http://schemas.microsoft.com/office/drawing/2014/main" id="{EF1C698F-A540-3F5B-86F1-CBAFC36DD46C}"/>
               </a:ext>
             </a:extLst>
           </p:cNvPr>
@@ -712,7 +712,7 @@
           <p:cNvPr id="6" name="Slide Number Placeholder 5">
             <a:extLst>
               <a:ext uri="{FF2B5EF4-FFF2-40B4-BE49-F238E27FC236}">
-                <a16:creationId xmlns:a16="http://schemas.microsoft.com/office/drawing/2014/main" id="{934B75C3-4F09-F452-AEAC-AF0A68436370}"/>
+                <a16:creationId xmlns:a16="http://schemas.microsoft.com/office/drawing/2014/main" id="{537B4225-2937-60BA-3B93-52C3A3536939}"/>
               </a:ext>
             </a:extLst>
           </p:cNvPr>
@@ -728,7 +728,7 @@
           <a:bodyPr/>
           <a:lstStyle/>
           <a:p>
-            <a:fld id="{0BDB6D22-B9A3-4D53-BECF-43E12A719D70}" type="slidenum">
+            <a:fld id="{DA215C20-D0E9-41CE-87D5-BCE849F24902}" type="slidenum">
               <a:rPr lang="en-US" smtClean="0"/>
               <a:t>‹#›</a:t>
             </a:fld>
@@ -739,7 +739,7 @@
     </p:spTree>
     <p:extLst>
       <p:ext uri="{BB962C8B-B14F-4D97-AF65-F5344CB8AC3E}">
-        <p14:creationId xmlns:p14="http://schemas.microsoft.com/office/powerpoint/2010/main" val="3984497823"/>
+        <p14:creationId xmlns:p14="http://schemas.microsoft.com/office/powerpoint/2010/main" val="2216149430"/>
       </p:ext>
     </p:extLst>
   </p:cSld>
@@ -771,7 +771,7 @@
           <p:cNvPr id="2" name="Title 1">
             <a:extLst>
               <a:ext uri="{FF2B5EF4-FFF2-40B4-BE49-F238E27FC236}">
-                <a16:creationId xmlns:a16="http://schemas.microsoft.com/office/drawing/2014/main" id="{E8AFC074-EF7E-1F72-5EA8-4DAD1F174E0F}"/>
+                <a16:creationId xmlns:a16="http://schemas.microsoft.com/office/drawing/2014/main" id="{8ED4E5A3-ABC8-7D51-EB35-CF31ADD4CD96}"/>
               </a:ext>
             </a:extLst>
           </p:cNvPr>
@@ -799,7 +799,7 @@
           <p:cNvPr id="3" name="Content Placeholder 2">
             <a:extLst>
               <a:ext uri="{FF2B5EF4-FFF2-40B4-BE49-F238E27FC236}">
-                <a16:creationId xmlns:a16="http://schemas.microsoft.com/office/drawing/2014/main" id="{3CB93F29-286C-B61B-9C02-32063F7EE6D7}"/>
+                <a16:creationId xmlns:a16="http://schemas.microsoft.com/office/drawing/2014/main" id="{6C8B194A-CA7A-2916-69BE-480810A11C90}"/>
               </a:ext>
             </a:extLst>
           </p:cNvPr>
@@ -856,7 +856,7 @@
           <p:cNvPr id="4" name="Date Placeholder 3">
             <a:extLst>
               <a:ext uri="{FF2B5EF4-FFF2-40B4-BE49-F238E27FC236}">
-                <a16:creationId xmlns:a16="http://schemas.microsoft.com/office/drawing/2014/main" id="{8249F381-46DD-35FA-438B-8C81F43F8759}"/>
+                <a16:creationId xmlns:a16="http://schemas.microsoft.com/office/drawing/2014/main" id="{C8DCB60F-91FA-2A5B-31A5-2BB524CC12FD}"/>
               </a:ext>
             </a:extLst>
           </p:cNvPr>
@@ -872,7 +872,7 @@
           <a:bodyPr/>
           <a:lstStyle/>
           <a:p>
-            <a:fld id="{06F0BCA8-90DB-4D97-BB85-C321F5FFDC10}" type="datetimeFigureOut">
+            <a:fld id="{0BAD9C77-6EC3-4D89-8A0D-C68FA7E8B712}" type="datetimeFigureOut">
               <a:rPr lang="en-US" smtClean="0"/>
               <a:t>7/11/2026</a:t>
             </a:fld>
@@ -885,7 +885,7 @@
           <p:cNvPr id="5" name="Footer Placeholder 4">
             <a:extLst>
               <a:ext uri="{FF2B5EF4-FFF2-40B4-BE49-F238E27FC236}">
-                <a16:creationId xmlns:a16="http://schemas.microsoft.com/office/drawing/2014/main" id="{9DB1CB94-B447-6B5F-0C19-402AB0E9BC8D}"/>
+                <a16:creationId xmlns:a16="http://schemas.microsoft.com/office/drawing/2014/main" id="{19BD7FCF-0C0C-4607-4896-71541EA29E11}"/>
               </a:ext>
             </a:extLst>
           </p:cNvPr>
@@ -910,7 +910,7 @@
           <p:cNvPr id="6" name="Slide Number Placeholder 5">
             <a:extLst>
               <a:ext uri="{FF2B5EF4-FFF2-40B4-BE49-F238E27FC236}">
-                <a16:creationId xmlns:a16="http://schemas.microsoft.com/office/drawing/2014/main" id="{F788E90C-1DCB-6982-6707-EE88EB3B5878}"/>
+                <a16:creationId xmlns:a16="http://schemas.microsoft.com/office/drawing/2014/main" id="{BC6FBDB8-04FF-D324-D82B-01E9232DB8C7}"/>
               </a:ext>
             </a:extLst>
           </p:cNvPr>
@@ -926,7 +926,7 @@
           <a:bodyPr/>
           <a:lstStyle/>
           <a:p>
-            <a:fld id="{0BDB6D22-B9A3-4D53-BECF-43E12A719D70}" type="slidenum">
+            <a:fld id="{DA215C20-D0E9-41CE-87D5-BCE849F24902}" type="slidenum">
               <a:rPr lang="en-US" smtClean="0"/>
               <a:t>‹#›</a:t>
             </a:fld>
@@ -937,7 +937,7 @@
     </p:spTree>
     <p:extLst>
       <p:ext uri="{BB962C8B-B14F-4D97-AF65-F5344CB8AC3E}">
-        <p14:creationId xmlns:p14="http://schemas.microsoft.com/office/powerpoint/2010/main" val="937395066"/>
+        <p14:creationId xmlns:p14="http://schemas.microsoft.com/office/powerpoint/2010/main" val="618426814"/>
       </p:ext>
     </p:extLst>
   </p:cSld>
@@ -969,7 +969,7 @@
           <p:cNvPr id="2" name="Title 1">
             <a:extLst>
               <a:ext uri="{FF2B5EF4-FFF2-40B4-BE49-F238E27FC236}">
-                <a16:creationId xmlns:a16="http://schemas.microsoft.com/office/drawing/2014/main" id="{AE3948B0-812E-A9A4-0B0A-F8B9C67976D5}"/>
+                <a16:creationId xmlns:a16="http://schemas.microsoft.com/office/drawing/2014/main" id="{408B61B2-69F0-02CA-E214-E530D1816F3E}"/>
               </a:ext>
             </a:extLst>
           </p:cNvPr>
@@ -1006,7 +1006,7 @@
           <p:cNvPr id="3" name="Text Placeholder 2">
             <a:extLst>
               <a:ext uri="{FF2B5EF4-FFF2-40B4-BE49-F238E27FC236}">
-                <a16:creationId xmlns:a16="http://schemas.microsoft.com/office/drawing/2014/main" id="{74C09B40-562A-8A83-6EDB-DDBC2FD28BE5}"/>
+                <a16:creationId xmlns:a16="http://schemas.microsoft.com/office/drawing/2014/main" id="{52AF39C9-120A-BA26-6865-26E6ED8B654B}"/>
               </a:ext>
             </a:extLst>
           </p:cNvPr>
@@ -1131,7 +1131,7 @@
           <p:cNvPr id="4" name="Date Placeholder 3">
             <a:extLst>
               <a:ext uri="{FF2B5EF4-FFF2-40B4-BE49-F238E27FC236}">
-                <a16:creationId xmlns:a16="http://schemas.microsoft.com/office/drawing/2014/main" id="{BD819338-4013-A919-B12B-4F915F490ED9}"/>
+                <a16:creationId xmlns:a16="http://schemas.microsoft.com/office/drawing/2014/main" id="{10D2F3BB-B16C-AD6E-FC12-3D350BB8C61C}"/>
               </a:ext>
             </a:extLst>
           </p:cNvPr>
@@ -1147,7 +1147,7 @@
           <a:bodyPr/>
           <a:lstStyle/>
           <a:p>
-            <a:fld id="{06F0BCA8-90DB-4D97-BB85-C321F5FFDC10}" type="datetimeFigureOut">
+            <a:fld id="{0BAD9C77-6EC3-4D89-8A0D-C68FA7E8B712}" type="datetimeFigureOut">
               <a:rPr lang="en-US" smtClean="0"/>
               <a:t>7/11/2026</a:t>
             </a:fld>
@@ -1160,7 +1160,7 @@
           <p:cNvPr id="5" name="Footer Placeholder 4">
             <a:extLst>
               <a:ext uri="{FF2B5EF4-FFF2-40B4-BE49-F238E27FC236}">
-                <a16:creationId xmlns:a16="http://schemas.microsoft.com/office/drawing/2014/main" id="{2EC96C89-8136-5218-DBF9-EE65BBB5D005}"/>
+                <a16:creationId xmlns:a16="http://schemas.microsoft.com/office/drawing/2014/main" id="{E98517F0-9013-69FC-EA91-E3D6B4FD7936}"/>
               </a:ext>
             </a:extLst>
           </p:cNvPr>
@@ -1185,7 +1185,7 @@
           <p:cNvPr id="6" name="Slide Number Placeholder 5">
             <a:extLst>
               <a:ext uri="{FF2B5EF4-FFF2-40B4-BE49-F238E27FC236}">
-                <a16:creationId xmlns:a16="http://schemas.microsoft.com/office/drawing/2014/main" id="{2E7FBA0E-704D-D267-0AFD-9475E40DF06D}"/>
+                <a16:creationId xmlns:a16="http://schemas.microsoft.com/office/drawing/2014/main" id="{AEF22B1D-FEAC-95DA-B8D1-868345354888}"/>
               </a:ext>
             </a:extLst>
           </p:cNvPr>
@@ -1201,7 +1201,7 @@
           <a:bodyPr/>
           <a:lstStyle/>
           <a:p>
-            <a:fld id="{0BDB6D22-B9A3-4D53-BECF-43E12A719D70}" type="slidenum">
+            <a:fld id="{DA215C20-D0E9-41CE-87D5-BCE849F24902}" type="slidenum">
               <a:rPr lang="en-US" smtClean="0"/>
               <a:t>‹#›</a:t>
             </a:fld>
@@ -1212,7 +1212,7 @@
     </p:spTree>
     <p:extLst>
       <p:ext uri="{BB962C8B-B14F-4D97-AF65-F5344CB8AC3E}">
-        <p14:creationId xmlns:p14="http://schemas.microsoft.com/office/powerpoint/2010/main" val="2178901110"/>
+        <p14:creationId xmlns:p14="http://schemas.microsoft.com/office/powerpoint/2010/main" val="1755030188"/>
       </p:ext>
     </p:extLst>
   </p:cSld>
@@ -1244,7 +1244,7 @@
           <p:cNvPr id="2" name="Title 1">
             <a:extLst>
               <a:ext uri="{FF2B5EF4-FFF2-40B4-BE49-F238E27FC236}">
-                <a16:creationId xmlns:a16="http://schemas.microsoft.com/office/drawing/2014/main" id="{E77577B6-FC73-B630-575A-E0B932FDD6A3}"/>
+                <a16:creationId xmlns:a16="http://schemas.microsoft.com/office/drawing/2014/main" id="{906133E0-715F-E6B5-A6B5-510D0079F8D1}"/>
               </a:ext>
             </a:extLst>
           </p:cNvPr>
@@ -1272,7 +1272,7 @@
           <p:cNvPr id="3" name="Content Placeholder 2">
             <a:extLst>
               <a:ext uri="{FF2B5EF4-FFF2-40B4-BE49-F238E27FC236}">
-                <a16:creationId xmlns:a16="http://schemas.microsoft.com/office/drawing/2014/main" id="{77298EF6-F121-0471-7736-98A5B3DCCDBD}"/>
+                <a16:creationId xmlns:a16="http://schemas.microsoft.com/office/drawing/2014/main" id="{F92B81E9-9D3F-42D2-15AD-4BC8FB426083}"/>
               </a:ext>
             </a:extLst>
           </p:cNvPr>
@@ -1334,7 +1334,7 @@
           <p:cNvPr id="4" name="Content Placeholder 3">
             <a:extLst>
               <a:ext uri="{FF2B5EF4-FFF2-40B4-BE49-F238E27FC236}">
-                <a16:creationId xmlns:a16="http://schemas.microsoft.com/office/drawing/2014/main" id="{955F03C8-44CE-1BE1-B61A-3FB7D93781CA}"/>
+                <a16:creationId xmlns:a16="http://schemas.microsoft.com/office/drawing/2014/main" id="{1E2EF95E-A96B-BDA4-0737-353B40C6BE05}"/>
               </a:ext>
             </a:extLst>
           </p:cNvPr>
@@ -1396,7 +1396,7 @@
           <p:cNvPr id="5" name="Date Placeholder 4">
             <a:extLst>
               <a:ext uri="{FF2B5EF4-FFF2-40B4-BE49-F238E27FC236}">
-                <a16:creationId xmlns:a16="http://schemas.microsoft.com/office/drawing/2014/main" id="{01C3425E-9638-2554-46FD-08D474F644D5}"/>
+                <a16:creationId xmlns:a16="http://schemas.microsoft.com/office/drawing/2014/main" id="{D9EB6D51-F5F2-095B-0CE8-4D050ABFF28B}"/>
               </a:ext>
             </a:extLst>
           </p:cNvPr>
@@ -1412,7 +1412,7 @@
           <a:bodyPr/>
           <a:lstStyle/>
           <a:p>
-            <a:fld id="{06F0BCA8-90DB-4D97-BB85-C321F5FFDC10}" type="datetimeFigureOut">
+            <a:fld id="{0BAD9C77-6EC3-4D89-8A0D-C68FA7E8B712}" type="datetimeFigureOut">
               <a:rPr lang="en-US" smtClean="0"/>
               <a:t>7/11/2026</a:t>
             </a:fld>
@@ -1425,7 +1425,7 @@
           <p:cNvPr id="6" name="Footer Placeholder 5">
             <a:extLst>
               <a:ext uri="{FF2B5EF4-FFF2-40B4-BE49-F238E27FC236}">
-                <a16:creationId xmlns:a16="http://schemas.microsoft.com/office/drawing/2014/main" id="{EF7F977A-475B-E6A9-D6A9-47D7F99F032C}"/>
+                <a16:creationId xmlns:a16="http://schemas.microsoft.com/office/drawing/2014/main" id="{3F87365A-B20A-1259-596A-22882A97B8FA}"/>
               </a:ext>
             </a:extLst>
           </p:cNvPr>
@@ -1450,7 +1450,7 @@
           <p:cNvPr id="7" name="Slide Number Placeholder 6">
             <a:extLst>
               <a:ext uri="{FF2B5EF4-FFF2-40B4-BE49-F238E27FC236}">
-                <a16:creationId xmlns:a16="http://schemas.microsoft.com/office/drawing/2014/main" id="{44700487-0662-6EAA-946B-C9F2B054C594}"/>
+                <a16:creationId xmlns:a16="http://schemas.microsoft.com/office/drawing/2014/main" id="{98769B1B-8C69-D90E-1846-E433C1BA21BC}"/>
               </a:ext>
             </a:extLst>
           </p:cNvPr>
@@ -1466,7 +1466,7 @@
           <a:bodyPr/>
           <a:lstStyle/>
           <a:p>
-            <a:fld id="{0BDB6D22-B9A3-4D53-BECF-43E12A719D70}" type="slidenum">
+            <a:fld id="{DA215C20-D0E9-41CE-87D5-BCE849F24902}" type="slidenum">
               <a:rPr lang="en-US" smtClean="0"/>
               <a:t>‹#›</a:t>
             </a:fld>
@@ -1477,7 +1477,7 @@
     </p:spTree>
     <p:extLst>
       <p:ext uri="{BB962C8B-B14F-4D97-AF65-F5344CB8AC3E}">
-        <p14:creationId xmlns:p14="http://schemas.microsoft.com/office/powerpoint/2010/main" val="3384313111"/>
+        <p14:creationId xmlns:p14="http://schemas.microsoft.com/office/powerpoint/2010/main" val="3561859439"/>
       </p:ext>
     </p:extLst>
   </p:cSld>
@@ -1509,7 +1509,7 @@
           <p:cNvPr id="2" name="Title 1">
             <a:extLst>
               <a:ext uri="{FF2B5EF4-FFF2-40B4-BE49-F238E27FC236}">
-                <a16:creationId xmlns:a16="http://schemas.microsoft.com/office/drawing/2014/main" id="{35FB442F-20E2-F73D-FC5F-21341B5F2799}"/>
+                <a16:creationId xmlns:a16="http://schemas.microsoft.com/office/drawing/2014/main" id="{673125E5-1F28-18C8-FD86-79625D784C37}"/>
               </a:ext>
             </a:extLst>
           </p:cNvPr>
@@ -1542,7 +1542,7 @@
           <p:cNvPr id="3" name="Text Placeholder 2">
             <a:extLst>
               <a:ext uri="{FF2B5EF4-FFF2-40B4-BE49-F238E27FC236}">
-                <a16:creationId xmlns:a16="http://schemas.microsoft.com/office/drawing/2014/main" id="{FFE9A7A7-D66C-3361-7A8B-E88B4621487C}"/>
+                <a16:creationId xmlns:a16="http://schemas.microsoft.com/office/drawing/2014/main" id="{D90406AE-98E4-6365-B4B7-611EF719DFC8}"/>
               </a:ext>
             </a:extLst>
           </p:cNvPr>
@@ -1613,7 +1613,7 @@
           <p:cNvPr id="4" name="Content Placeholder 3">
             <a:extLst>
               <a:ext uri="{FF2B5EF4-FFF2-40B4-BE49-F238E27FC236}">
-                <a16:creationId xmlns:a16="http://schemas.microsoft.com/office/drawing/2014/main" id="{2D34C8E6-EB52-7D76-BFF7-DA46C8566CB5}"/>
+                <a16:creationId xmlns:a16="http://schemas.microsoft.com/office/drawing/2014/main" id="{8F20C78F-9F58-A471-EC00-127789143A3E}"/>
               </a:ext>
             </a:extLst>
           </p:cNvPr>
@@ -1675,7 +1675,7 @@
           <p:cNvPr id="5" name="Text Placeholder 4">
             <a:extLst>
               <a:ext uri="{FF2B5EF4-FFF2-40B4-BE49-F238E27FC236}">
-                <a16:creationId xmlns:a16="http://schemas.microsoft.com/office/drawing/2014/main" id="{D3A6ECA7-D8E3-FE09-2188-AE542E31B1DC}"/>
+                <a16:creationId xmlns:a16="http://schemas.microsoft.com/office/drawing/2014/main" id="{C4D9C9F6-0EDD-DD17-5E6A-837914731263}"/>
               </a:ext>
             </a:extLst>
           </p:cNvPr>
@@ -1746,7 +1746,7 @@
           <p:cNvPr id="6" name="Content Placeholder 5">
             <a:extLst>
               <a:ext uri="{FF2B5EF4-FFF2-40B4-BE49-F238E27FC236}">
-                <a16:creationId xmlns:a16="http://schemas.microsoft.com/office/drawing/2014/main" id="{A79CEA59-7362-2A14-8606-DEC6A7E48536}"/>
+                <a16:creationId xmlns:a16="http://schemas.microsoft.com/office/drawing/2014/main" id="{C0A749AD-E7A2-BCE8-3568-13787B8DAD00}"/>
               </a:ext>
             </a:extLst>
           </p:cNvPr>
@@ -1808,7 +1808,7 @@
           <p:cNvPr id="7" name="Date Placeholder 6">
             <a:extLst>
               <a:ext uri="{FF2B5EF4-FFF2-40B4-BE49-F238E27FC236}">
-                <a16:creationId xmlns:a16="http://schemas.microsoft.com/office/drawing/2014/main" id="{3805A217-C689-172C-5D57-422DA5088C87}"/>
+                <a16:creationId xmlns:a16="http://schemas.microsoft.com/office/drawing/2014/main" id="{CCA35106-84D6-1C09-BED0-52EAFE853D88}"/>
               </a:ext>
             </a:extLst>
           </p:cNvPr>
@@ -1824,7 +1824,7 @@
           <a:bodyPr/>
           <a:lstStyle/>
           <a:p>
-            <a:fld id="{06F0BCA8-90DB-4D97-BB85-C321F5FFDC10}" type="datetimeFigureOut">
+            <a:fld id="{0BAD9C77-6EC3-4D89-8A0D-C68FA7E8B712}" type="datetimeFigureOut">
               <a:rPr lang="en-US" smtClean="0"/>
               <a:t>7/11/2026</a:t>
             </a:fld>
@@ -1837,7 +1837,7 @@
           <p:cNvPr id="8" name="Footer Placeholder 7">
             <a:extLst>
               <a:ext uri="{FF2B5EF4-FFF2-40B4-BE49-F238E27FC236}">
-                <a16:creationId xmlns:a16="http://schemas.microsoft.com/office/drawing/2014/main" id="{A0C23FE6-D765-6262-E98D-409060374E4B}"/>
+                <a16:creationId xmlns:a16="http://schemas.microsoft.com/office/drawing/2014/main" id="{B17EAF57-ABFC-D9C6-C994-6067D4F858AB}"/>
               </a:ext>
             </a:extLst>
           </p:cNvPr>
@@ -1862,7 +1862,7 @@
           <p:cNvPr id="9" name="Slide Number Placeholder 8">
             <a:extLst>
               <a:ext uri="{FF2B5EF4-FFF2-40B4-BE49-F238E27FC236}">
-                <a16:creationId xmlns:a16="http://schemas.microsoft.com/office/drawing/2014/main" id="{79F03EA6-C61E-024C-5D50-9368B393DDC0}"/>
+                <a16:creationId xmlns:a16="http://schemas.microsoft.com/office/drawing/2014/main" id="{1F80D8AE-2142-8BF0-D74D-C680A65E3DEE}"/>
               </a:ext>
             </a:extLst>
           </p:cNvPr>
@@ -1878,7 +1878,7 @@
           <a:bodyPr/>
           <a:lstStyle/>
           <a:p>
-            <a:fld id="{0BDB6D22-B9A3-4D53-BECF-43E12A719D70}" type="slidenum">
+            <a:fld id="{DA215C20-D0E9-41CE-87D5-BCE849F24902}" type="slidenum">
               <a:rPr lang="en-US" smtClean="0"/>
               <a:t>‹#›</a:t>
             </a:fld>
@@ -1889,7 +1889,7 @@
     </p:spTree>
     <p:extLst>
       <p:ext uri="{BB962C8B-B14F-4D97-AF65-F5344CB8AC3E}">
-        <p14:creationId xmlns:p14="http://schemas.microsoft.com/office/powerpoint/2010/main" val="161158049"/>
+        <p14:creationId xmlns:p14="http://schemas.microsoft.com/office/powerpoint/2010/main" val="2140765357"/>
       </p:ext>
     </p:extLst>
   </p:cSld>
@@ -1921,7 +1921,7 @@
           <p:cNvPr id="2" name="Title 1">
             <a:extLst>
               <a:ext uri="{FF2B5EF4-FFF2-40B4-BE49-F238E27FC236}">
-                <a16:creationId xmlns:a16="http://schemas.microsoft.com/office/drawing/2014/main" id="{60FD09B1-092E-6519-CB22-E9A5AC5B1B5C}"/>
+                <a16:creationId xmlns:a16="http://schemas.microsoft.com/office/drawing/2014/main" id="{D76E5F51-A81A-95D7-CAF8-1FD9225A8B91}"/>
               </a:ext>
             </a:extLst>
           </p:cNvPr>
@@ -1949,7 +1949,7 @@
           <p:cNvPr id="3" name="Date Placeholder 2">
             <a:extLst>
               <a:ext uri="{FF2B5EF4-FFF2-40B4-BE49-F238E27FC236}">
-                <a16:creationId xmlns:a16="http://schemas.microsoft.com/office/drawing/2014/main" id="{4168F744-F8B4-8DEB-B81F-BE548063B4A8}"/>
+                <a16:creationId xmlns:a16="http://schemas.microsoft.com/office/drawing/2014/main" id="{765E1782-049F-56BF-459F-D145D4ED7484}"/>
               </a:ext>
             </a:extLst>
           </p:cNvPr>
@@ -1965,7 +1965,7 @@
           <a:bodyPr/>
           <a:lstStyle/>
           <a:p>
-            <a:fld id="{06F0BCA8-90DB-4D97-BB85-C321F5FFDC10}" type="datetimeFigureOut">
+            <a:fld id="{0BAD9C77-6EC3-4D89-8A0D-C68FA7E8B712}" type="datetimeFigureOut">
               <a:rPr lang="en-US" smtClean="0"/>
               <a:t>7/11/2026</a:t>
             </a:fld>
@@ -1978,7 +1978,7 @@
           <p:cNvPr id="4" name="Footer Placeholder 3">
             <a:extLst>
               <a:ext uri="{FF2B5EF4-FFF2-40B4-BE49-F238E27FC236}">
-                <a16:creationId xmlns:a16="http://schemas.microsoft.com/office/drawing/2014/main" id="{A4DC79B4-A426-72D4-3F46-C3AF140B3FF5}"/>
+                <a16:creationId xmlns:a16="http://schemas.microsoft.com/office/drawing/2014/main" id="{A2E180AE-42A2-8D2D-788E-0CC3F091DF81}"/>
               </a:ext>
             </a:extLst>
           </p:cNvPr>
@@ -2003,7 +2003,7 @@
           <p:cNvPr id="5" name="Slide Number Placeholder 4">
             <a:extLst>
               <a:ext uri="{FF2B5EF4-FFF2-40B4-BE49-F238E27FC236}">
-                <a16:creationId xmlns:a16="http://schemas.microsoft.com/office/drawing/2014/main" id="{AF506797-B875-06D0-DEA7-66FD9558EC88}"/>
+                <a16:creationId xmlns:a16="http://schemas.microsoft.com/office/drawing/2014/main" id="{292B5702-0A8B-E564-BE43-D1A1B704599F}"/>
               </a:ext>
             </a:extLst>
           </p:cNvPr>
@@ -2019,7 +2019,7 @@
           <a:bodyPr/>
           <a:lstStyle/>
           <a:p>
-            <a:fld id="{0BDB6D22-B9A3-4D53-BECF-43E12A719D70}" type="slidenum">
+            <a:fld id="{DA215C20-D0E9-41CE-87D5-BCE849F24902}" type="slidenum">
               <a:rPr lang="en-US" smtClean="0"/>
               <a:t>‹#›</a:t>
             </a:fld>
@@ -2030,7 +2030,7 @@
     </p:spTree>
     <p:extLst>
       <p:ext uri="{BB962C8B-B14F-4D97-AF65-F5344CB8AC3E}">
-        <p14:creationId xmlns:p14="http://schemas.microsoft.com/office/powerpoint/2010/main" val="1945771606"/>
+        <p14:creationId xmlns:p14="http://schemas.microsoft.com/office/powerpoint/2010/main" val="2281236445"/>
       </p:ext>
     </p:extLst>
   </p:cSld>
@@ -2062,7 +2062,7 @@
           <p:cNvPr id="2" name="Date Placeholder 1">
             <a:extLst>
               <a:ext uri="{FF2B5EF4-FFF2-40B4-BE49-F238E27FC236}">
-                <a16:creationId xmlns:a16="http://schemas.microsoft.com/office/drawing/2014/main" id="{33F57D1B-013C-63EA-357A-D2CE6B52229D}"/>
+                <a16:creationId xmlns:a16="http://schemas.microsoft.com/office/drawing/2014/main" id="{AE8896CA-5A34-5F17-2811-8F8F6D2EE200}"/>
               </a:ext>
             </a:extLst>
           </p:cNvPr>
@@ -2078,7 +2078,7 @@
           <a:bodyPr/>
           <a:lstStyle/>
           <a:p>
-            <a:fld id="{06F0BCA8-90DB-4D97-BB85-C321F5FFDC10}" type="datetimeFigureOut">
+            <a:fld id="{0BAD9C77-6EC3-4D89-8A0D-C68FA7E8B712}" type="datetimeFigureOut">
               <a:rPr lang="en-US" smtClean="0"/>
               <a:t>7/11/2026</a:t>
             </a:fld>
@@ -2091,7 +2091,7 @@
           <p:cNvPr id="3" name="Footer Placeholder 2">
             <a:extLst>
               <a:ext uri="{FF2B5EF4-FFF2-40B4-BE49-F238E27FC236}">
-                <a16:creationId xmlns:a16="http://schemas.microsoft.com/office/drawing/2014/main" id="{0E6E1856-D197-746A-FCAC-71825E7E0794}"/>
+                <a16:creationId xmlns:a16="http://schemas.microsoft.com/office/drawing/2014/main" id="{6B55BA59-488E-7A04-ED9E-6B9394635D5B}"/>
               </a:ext>
             </a:extLst>
           </p:cNvPr>
@@ -2116,7 +2116,7 @@
           <p:cNvPr id="4" name="Slide Number Placeholder 3">
             <a:extLst>
               <a:ext uri="{FF2B5EF4-FFF2-40B4-BE49-F238E27FC236}">
-                <a16:creationId xmlns:a16="http://schemas.microsoft.com/office/drawing/2014/main" id="{077EACC6-1C8A-E542-38F7-9ACDC2DA3D91}"/>
+                <a16:creationId xmlns:a16="http://schemas.microsoft.com/office/drawing/2014/main" id="{0D8E5459-8F6E-5523-80BB-E306F28578BA}"/>
               </a:ext>
             </a:extLst>
           </p:cNvPr>
@@ -2132,7 +2132,7 @@
           <a:bodyPr/>
           <a:lstStyle/>
           <a:p>
-            <a:fld id="{0BDB6D22-B9A3-4D53-BECF-43E12A719D70}" type="slidenum">
+            <a:fld id="{DA215C20-D0E9-41CE-87D5-BCE849F24902}" type="slidenum">
               <a:rPr lang="en-US" smtClean="0"/>
               <a:t>‹#›</a:t>
             </a:fld>
@@ -2143,7 +2143,7 @@
     </p:spTree>
     <p:extLst>
       <p:ext uri="{BB962C8B-B14F-4D97-AF65-F5344CB8AC3E}">
-        <p14:creationId xmlns:p14="http://schemas.microsoft.com/office/powerpoint/2010/main" val="1087883133"/>
+        <p14:creationId xmlns:p14="http://schemas.microsoft.com/office/powerpoint/2010/main" val="1916325369"/>
       </p:ext>
     </p:extLst>
   </p:cSld>
@@ -2175,7 +2175,7 @@
           <p:cNvPr id="2" name="Title 1">
             <a:extLst>
               <a:ext uri="{FF2B5EF4-FFF2-40B4-BE49-F238E27FC236}">
-                <a16:creationId xmlns:a16="http://schemas.microsoft.com/office/drawing/2014/main" id="{116B97CC-F04C-BBD9-CBFB-B447893A585F}"/>
+                <a16:creationId xmlns:a16="http://schemas.microsoft.com/office/drawing/2014/main" id="{F10A5F63-993D-C5C9-44E4-050E3BFF3AF4}"/>
               </a:ext>
             </a:extLst>
           </p:cNvPr>
@@ -2212,7 +2212,7 @@
           <p:cNvPr id="3" name="Content Placeholder 2">
             <a:extLst>
               <a:ext uri="{FF2B5EF4-FFF2-40B4-BE49-F238E27FC236}">
-                <a16:creationId xmlns:a16="http://schemas.microsoft.com/office/drawing/2014/main" id="{85568603-CFBC-EE50-0ED8-B8E3F645630C}"/>
+                <a16:creationId xmlns:a16="http://schemas.microsoft.com/office/drawing/2014/main" id="{C37EEA42-0D10-1CC7-857F-0AB5F28154E3}"/>
               </a:ext>
             </a:extLst>
           </p:cNvPr>
@@ -2302,7 +2302,7 @@
           <p:cNvPr id="4" name="Text Placeholder 3">
             <a:extLst>
               <a:ext uri="{FF2B5EF4-FFF2-40B4-BE49-F238E27FC236}">
-                <a16:creationId xmlns:a16="http://schemas.microsoft.com/office/drawing/2014/main" id="{29FB8B6E-30FC-1C88-8B20-DB6601073F71}"/>
+                <a16:creationId xmlns:a16="http://schemas.microsoft.com/office/drawing/2014/main" id="{66CC122D-DB31-9931-3210-5158B0F0E5F0}"/>
               </a:ext>
             </a:extLst>
           </p:cNvPr>
@@ -2373,7 +2373,7 @@
           <p:cNvPr id="5" name="Date Placeholder 4">
             <a:extLst>
               <a:ext uri="{FF2B5EF4-FFF2-40B4-BE49-F238E27FC236}">
-                <a16:creationId xmlns:a16="http://schemas.microsoft.com/office/drawing/2014/main" id="{019E3F94-C212-3AB8-C889-2D1A4D150973}"/>
+                <a16:creationId xmlns:a16="http://schemas.microsoft.com/office/drawing/2014/main" id="{68D2552D-669D-A8E8-F9F1-29F517AB147D}"/>
               </a:ext>
             </a:extLst>
           </p:cNvPr>
@@ -2389,7 +2389,7 @@
           <a:bodyPr/>
           <a:lstStyle/>
           <a:p>
-            <a:fld id="{06F0BCA8-90DB-4D97-BB85-C321F5FFDC10}" type="datetimeFigureOut">
+            <a:fld id="{0BAD9C77-6EC3-4D89-8A0D-C68FA7E8B712}" type="datetimeFigureOut">
               <a:rPr lang="en-US" smtClean="0"/>
               <a:t>7/11/2026</a:t>
             </a:fld>
@@ -2402,7 +2402,7 @@
           <p:cNvPr id="6" name="Footer Placeholder 5">
             <a:extLst>
               <a:ext uri="{FF2B5EF4-FFF2-40B4-BE49-F238E27FC236}">
-                <a16:creationId xmlns:a16="http://schemas.microsoft.com/office/drawing/2014/main" id="{75B37CA8-B6E7-ECBA-97E0-F90539858DBD}"/>
+                <a16:creationId xmlns:a16="http://schemas.microsoft.com/office/drawing/2014/main" id="{DCD95D5B-9505-DF8F-0884-017F55863B84}"/>
               </a:ext>
             </a:extLst>
           </p:cNvPr>
@@ -2427,7 +2427,7 @@
           <p:cNvPr id="7" name="Slide Number Placeholder 6">
             <a:extLst>
               <a:ext uri="{FF2B5EF4-FFF2-40B4-BE49-F238E27FC236}">
-                <a16:creationId xmlns:a16="http://schemas.microsoft.com/office/drawing/2014/main" id="{CCF96257-E97E-EA7B-FC4E-775052290470}"/>
+                <a16:creationId xmlns:a16="http://schemas.microsoft.com/office/drawing/2014/main" id="{9D455057-ACDD-AF0B-B831-6A327ADC4222}"/>
               </a:ext>
             </a:extLst>
           </p:cNvPr>
@@ -2443,7 +2443,7 @@
           <a:bodyPr/>
           <a:lstStyle/>
           <a:p>
-            <a:fld id="{0BDB6D22-B9A3-4D53-BECF-43E12A719D70}" type="slidenum">
+            <a:fld id="{DA215C20-D0E9-41CE-87D5-BCE849F24902}" type="slidenum">
               <a:rPr lang="en-US" smtClean="0"/>
               <a:t>‹#›</a:t>
             </a:fld>
@@ -2454,7 +2454,7 @@
     </p:spTree>
     <p:extLst>
       <p:ext uri="{BB962C8B-B14F-4D97-AF65-F5344CB8AC3E}">
-        <p14:creationId xmlns:p14="http://schemas.microsoft.com/office/powerpoint/2010/main" val="3922041337"/>
+        <p14:creationId xmlns:p14="http://schemas.microsoft.com/office/powerpoint/2010/main" val="3362090815"/>
       </p:ext>
     </p:extLst>
   </p:cSld>
@@ -2486,7 +2486,7 @@
           <p:cNvPr id="2" name="Title 1">
             <a:extLst>
               <a:ext uri="{FF2B5EF4-FFF2-40B4-BE49-F238E27FC236}">
-                <a16:creationId xmlns:a16="http://schemas.microsoft.com/office/drawing/2014/main" id="{6ABD9324-7165-8BB8-E419-46F0F96A2F6E}"/>
+                <a16:creationId xmlns:a16="http://schemas.microsoft.com/office/drawing/2014/main" id="{E1C2EF9E-47A5-105E-E594-EDBAA4C99D89}"/>
               </a:ext>
             </a:extLst>
           </p:cNvPr>
@@ -2523,7 +2523,7 @@
           <p:cNvPr id="3" name="Picture Placeholder 2">
             <a:extLst>
               <a:ext uri="{FF2B5EF4-FFF2-40B4-BE49-F238E27FC236}">
-                <a16:creationId xmlns:a16="http://schemas.microsoft.com/office/drawing/2014/main" id="{0423B0F0-DD01-77AA-C828-2B3BA42AFD53}"/>
+                <a16:creationId xmlns:a16="http://schemas.microsoft.com/office/drawing/2014/main" id="{97EF978B-C1E7-60E0-A99A-75AEF4CDBF86}"/>
               </a:ext>
             </a:extLst>
           </p:cNvPr>
@@ -2590,7 +2590,7 @@
           <p:cNvPr id="4" name="Text Placeholder 3">
             <a:extLst>
               <a:ext uri="{FF2B5EF4-FFF2-40B4-BE49-F238E27FC236}">
-                <a16:creationId xmlns:a16="http://schemas.microsoft.com/office/drawing/2014/main" id="{F5A2B303-4BE2-58ED-AABE-45F334661E5A}"/>
+                <a16:creationId xmlns:a16="http://schemas.microsoft.com/office/drawing/2014/main" id="{09A8C6B4-E1CF-858E-8A27-B210F8F11358}"/>
               </a:ext>
             </a:extLst>
           </p:cNvPr>
@@ -2661,7 +2661,7 @@
           <p:cNvPr id="5" name="Date Placeholder 4">
             <a:extLst>
               <a:ext uri="{FF2B5EF4-FFF2-40B4-BE49-F238E27FC236}">
-                <a16:creationId xmlns:a16="http://schemas.microsoft.com/office/drawing/2014/main" id="{0E4D6E39-21F8-AAA5-4BE5-13EE60F6F8FF}"/>
+                <a16:creationId xmlns:a16="http://schemas.microsoft.com/office/drawing/2014/main" id="{3DDD61BB-3A65-DF1B-B519-709221CBC7BD}"/>
               </a:ext>
             </a:extLst>
           </p:cNvPr>
@@ -2677,7 +2677,7 @@
           <a:bodyPr/>
           <a:lstStyle/>
           <a:p>
-            <a:fld id="{06F0BCA8-90DB-4D97-BB85-C321F5FFDC10}" type="datetimeFigureOut">
+            <a:fld id="{0BAD9C77-6EC3-4D89-8A0D-C68FA7E8B712}" type="datetimeFigureOut">
               <a:rPr lang="en-US" smtClean="0"/>
               <a:t>7/11/2026</a:t>
             </a:fld>
@@ -2690,7 +2690,7 @@
           <p:cNvPr id="6" name="Footer Placeholder 5">
             <a:extLst>
               <a:ext uri="{FF2B5EF4-FFF2-40B4-BE49-F238E27FC236}">
-                <a16:creationId xmlns:a16="http://schemas.microsoft.com/office/drawing/2014/main" id="{D731C5D6-98D4-1413-6966-6CADE96A57E0}"/>
+                <a16:creationId xmlns:a16="http://schemas.microsoft.com/office/drawing/2014/main" id="{3F559079-984A-4E88-6E8F-FA3DD3A509FD}"/>
               </a:ext>
             </a:extLst>
           </p:cNvPr>
@@ -2715,7 +2715,7 @@
           <p:cNvPr id="7" name="Slide Number Placeholder 6">
             <a:extLst>
               <a:ext uri="{FF2B5EF4-FFF2-40B4-BE49-F238E27FC236}">
-                <a16:creationId xmlns:a16="http://schemas.microsoft.com/office/drawing/2014/main" id="{B66F6484-655B-90D2-72D9-C47DD7E4F937}"/>
+                <a16:creationId xmlns:a16="http://schemas.microsoft.com/office/drawing/2014/main" id="{CF1825C8-1AD5-85F0-6BE8-EC13DFF1C634}"/>
               </a:ext>
             </a:extLst>
           </p:cNvPr>
@@ -2731,7 +2731,7 @@
           <a:bodyPr/>
           <a:lstStyle/>
           <a:p>
-            <a:fld id="{0BDB6D22-B9A3-4D53-BECF-43E12A719D70}" type="slidenum">
+            <a:fld id="{DA215C20-D0E9-41CE-87D5-BCE849F24902}" type="slidenum">
               <a:rPr lang="en-US" smtClean="0"/>
               <a:t>‹#›</a:t>
             </a:fld>
@@ -2742,7 +2742,7 @@
     </p:spTree>
     <p:extLst>
       <p:ext uri="{BB962C8B-B14F-4D97-AF65-F5344CB8AC3E}">
-        <p14:creationId xmlns:p14="http://schemas.microsoft.com/office/powerpoint/2010/main" val="108997241"/>
+        <p14:creationId xmlns:p14="http://schemas.microsoft.com/office/powerpoint/2010/main" val="17509244"/>
       </p:ext>
     </p:extLst>
   </p:cSld>
@@ -2779,7 +2779,7 @@
           <p:cNvPr id="2" name="Title Placeholder 1">
             <a:extLst>
               <a:ext uri="{FF2B5EF4-FFF2-40B4-BE49-F238E27FC236}">
-                <a16:creationId xmlns:a16="http://schemas.microsoft.com/office/drawing/2014/main" id="{899F6976-5CCD-0196-19EF-542AFC2BAD0E}"/>
+                <a16:creationId xmlns:a16="http://schemas.microsoft.com/office/drawing/2014/main" id="{B95D78C2-CB47-CEDE-C0AB-74E0CCF3CE7D}"/>
               </a:ext>
             </a:extLst>
           </p:cNvPr>
@@ -2817,7 +2817,7 @@
           <p:cNvPr id="3" name="Text Placeholder 2">
             <a:extLst>
               <a:ext uri="{FF2B5EF4-FFF2-40B4-BE49-F238E27FC236}">
-                <a16:creationId xmlns:a16="http://schemas.microsoft.com/office/drawing/2014/main" id="{3ADCABB7-7ACD-D6BE-A594-E038401AD98E}"/>
+                <a16:creationId xmlns:a16="http://schemas.microsoft.com/office/drawing/2014/main" id="{30B60612-FFFF-5072-3EE0-BCEE38FD041A}"/>
               </a:ext>
             </a:extLst>
           </p:cNvPr>
@@ -2884,7 +2884,7 @@
           <p:cNvPr id="4" name="Date Placeholder 3">
             <a:extLst>
               <a:ext uri="{FF2B5EF4-FFF2-40B4-BE49-F238E27FC236}">
-                <a16:creationId xmlns:a16="http://schemas.microsoft.com/office/drawing/2014/main" id="{CD12C3C1-71CF-442B-AD15-011D5AF8A02C}"/>
+                <a16:creationId xmlns:a16="http://schemas.microsoft.com/office/drawing/2014/main" id="{67593DCB-D8BD-5632-6448-1A5019E1DB33}"/>
               </a:ext>
             </a:extLst>
           </p:cNvPr>
@@ -2918,7 +2918,7 @@
             </a:lvl1pPr>
           </a:lstStyle>
           <a:p>
-            <a:fld id="{06F0BCA8-90DB-4D97-BB85-C321F5FFDC10}" type="datetimeFigureOut">
+            <a:fld id="{0BAD9C77-6EC3-4D89-8A0D-C68FA7E8B712}" type="datetimeFigureOut">
               <a:rPr lang="en-US" smtClean="0"/>
               <a:t>7/11/2026</a:t>
             </a:fld>
@@ -2931,7 +2931,7 @@
           <p:cNvPr id="5" name="Footer Placeholder 4">
             <a:extLst>
               <a:ext uri="{FF2B5EF4-FFF2-40B4-BE49-F238E27FC236}">
-                <a16:creationId xmlns:a16="http://schemas.microsoft.com/office/drawing/2014/main" id="{9A1B1181-FC50-0D05-9F87-F4F42E84ABE3}"/>
+                <a16:creationId xmlns:a16="http://schemas.microsoft.com/office/drawing/2014/main" id="{1DEFC029-CEE2-55C7-614D-49EE6D862806}"/>
               </a:ext>
             </a:extLst>
           </p:cNvPr>
@@ -2974,7 +2974,7 @@
           <p:cNvPr id="6" name="Slide Number Placeholder 5">
             <a:extLst>
               <a:ext uri="{FF2B5EF4-FFF2-40B4-BE49-F238E27FC236}">
-                <a16:creationId xmlns:a16="http://schemas.microsoft.com/office/drawing/2014/main" id="{52019BA1-5D6B-C203-25CF-992D10EC8584}"/>
+                <a16:creationId xmlns:a16="http://schemas.microsoft.com/office/drawing/2014/main" id="{5400E529-4745-8A00-5177-3D47DE317A54}"/>
               </a:ext>
             </a:extLst>
           </p:cNvPr>
@@ -3008,7 +3008,7 @@
             </a:lvl1pPr>
           </a:lstStyle>
           <a:p>
-            <a:fld id="{0BDB6D22-B9A3-4D53-BECF-43E12A719D70}" type="slidenum">
+            <a:fld id="{DA215C20-D0E9-41CE-87D5-BCE849F24902}" type="slidenum">
               <a:rPr lang="en-US" smtClean="0"/>
               <a:t>‹#›</a:t>
             </a:fld>
@@ -3019,7 +3019,7 @@
     </p:spTree>
     <p:extLst>
       <p:ext uri="{BB962C8B-B14F-4D97-AF65-F5344CB8AC3E}">
-        <p14:creationId xmlns:p14="http://schemas.microsoft.com/office/powerpoint/2010/main" val="370525170"/>
+        <p14:creationId xmlns:p14="http://schemas.microsoft.com/office/powerpoint/2010/main" val="4110762453"/>
       </p:ext>
     </p:extLst>
   </p:cSld>
@@ -3342,7 +3342,7 @@
           <p:cNvPr id="3" name="Graphic 2">
             <a:extLst>
               <a:ext uri="{FF2B5EF4-FFF2-40B4-BE49-F238E27FC236}">
-                <a16:creationId xmlns:a16="http://schemas.microsoft.com/office/drawing/2014/main" id="{CAAA78F5-DC53-DFAF-6A9B-FBB2374664F9}"/>
+                <a16:creationId xmlns:a16="http://schemas.microsoft.com/office/drawing/2014/main" id="{771F7B88-E859-23FC-2E2B-EF6F8B65AC8C}"/>
               </a:ext>
             </a:extLst>
           </p:cNvPr>
@@ -3376,7 +3376,7 @@
     </p:spTree>
     <p:extLst>
       <p:ext uri="{BB962C8B-B14F-4D97-AF65-F5344CB8AC3E}">
-        <p14:creationId xmlns:p14="http://schemas.microsoft.com/office/powerpoint/2010/main" val="3379358246"/>
+        <p14:creationId xmlns:p14="http://schemas.microsoft.com/office/powerpoint/2010/main" val="2122084841"/>
       </p:ext>
     </p:extLst>
   </p:cSld>
@@ -3408,7 +3408,7 @@
           <p:cNvPr id="3" name="Graphic 2">
             <a:extLst>
               <a:ext uri="{FF2B5EF4-FFF2-40B4-BE49-F238E27FC236}">
-                <a16:creationId xmlns:a16="http://schemas.microsoft.com/office/drawing/2014/main" id="{A8987AE6-B244-7516-94F4-E152CAE9D5E1}"/>
+                <a16:creationId xmlns:a16="http://schemas.microsoft.com/office/drawing/2014/main" id="{06380517-32CD-A69C-F976-B104CE95C9FD}"/>
               </a:ext>
             </a:extLst>
           </p:cNvPr>
@@ -3442,7 +3442,7 @@
     </p:spTree>
     <p:extLst>
       <p:ext uri="{BB962C8B-B14F-4D97-AF65-F5344CB8AC3E}">
-        <p14:creationId xmlns:p14="http://schemas.microsoft.com/office/powerpoint/2010/main" val="1549981714"/>
+        <p14:creationId xmlns:p14="http://schemas.microsoft.com/office/powerpoint/2010/main" val="771874965"/>
       </p:ext>
     </p:extLst>
   </p:cSld>
@@ -3474,7 +3474,7 @@
           <p:cNvPr id="3" name="Graphic 2">
             <a:extLst>
               <a:ext uri="{FF2B5EF4-FFF2-40B4-BE49-F238E27FC236}">
-                <a16:creationId xmlns:a16="http://schemas.microsoft.com/office/drawing/2014/main" id="{8184365A-06F4-36CE-9772-56140B50664F}"/>
+                <a16:creationId xmlns:a16="http://schemas.microsoft.com/office/drawing/2014/main" id="{F307430C-8162-8470-E620-A9966C8B0788}"/>
               </a:ext>
             </a:extLst>
           </p:cNvPr>
@@ -3508,7 +3508,7 @@
     </p:spTree>
     <p:extLst>
       <p:ext uri="{BB962C8B-B14F-4D97-AF65-F5344CB8AC3E}">
-        <p14:creationId xmlns:p14="http://schemas.microsoft.com/office/powerpoint/2010/main" val="2938935809"/>
+        <p14:creationId xmlns:p14="http://schemas.microsoft.com/office/powerpoint/2010/main" val="1009731601"/>
       </p:ext>
     </p:extLst>
   </p:cSld>
@@ -3540,7 +3540,7 @@
           <p:cNvPr id="3" name="Graphic 2">
             <a:extLst>
               <a:ext uri="{FF2B5EF4-FFF2-40B4-BE49-F238E27FC236}">
-                <a16:creationId xmlns:a16="http://schemas.microsoft.com/office/drawing/2014/main" id="{09E4DBDD-265D-F4A4-8260-3E0ED490121B}"/>
+                <a16:creationId xmlns:a16="http://schemas.microsoft.com/office/drawing/2014/main" id="{C187C293-5BE3-A3B0-DE51-45771BD546E3}"/>
               </a:ext>
             </a:extLst>
           </p:cNvPr>
@@ -3574,7 +3574,7 @@
     </p:spTree>
     <p:extLst>
       <p:ext uri="{BB962C8B-B14F-4D97-AF65-F5344CB8AC3E}">
-        <p14:creationId xmlns:p14="http://schemas.microsoft.com/office/powerpoint/2010/main" val="880126653"/>
+        <p14:creationId xmlns:p14="http://schemas.microsoft.com/office/powerpoint/2010/main" val="2456392042"/>
       </p:ext>
     </p:extLst>
   </p:cSld>
@@ -3606,7 +3606,7 @@
           <p:cNvPr id="3" name="Graphic 2">
             <a:extLst>
               <a:ext uri="{FF2B5EF4-FFF2-40B4-BE49-F238E27FC236}">
-                <a16:creationId xmlns:a16="http://schemas.microsoft.com/office/drawing/2014/main" id="{A44668FD-A7E0-947F-9816-6A894B2CAC3C}"/>
+                <a16:creationId xmlns:a16="http://schemas.microsoft.com/office/drawing/2014/main" id="{AD3ED291-4D92-708B-155C-9751CB555000}"/>
               </a:ext>
             </a:extLst>
           </p:cNvPr>
@@ -3640,7 +3640,7 @@
     </p:spTree>
     <p:extLst>
       <p:ext uri="{BB962C8B-B14F-4D97-AF65-F5344CB8AC3E}">
-        <p14:creationId xmlns:p14="http://schemas.microsoft.com/office/powerpoint/2010/main" val="3625774391"/>
+        <p14:creationId xmlns:p14="http://schemas.microsoft.com/office/powerpoint/2010/main" val="25924875"/>
       </p:ext>
     </p:extLst>
   </p:cSld>
@@ -3672,7 +3672,7 @@
           <p:cNvPr id="3" name="Graphic 2">
             <a:extLst>
               <a:ext uri="{FF2B5EF4-FFF2-40B4-BE49-F238E27FC236}">
-                <a16:creationId xmlns:a16="http://schemas.microsoft.com/office/drawing/2014/main" id="{CF0930BE-11D2-D563-328E-E895F5EEA9B7}"/>
+                <a16:creationId xmlns:a16="http://schemas.microsoft.com/office/drawing/2014/main" id="{9F663EE8-D4CF-13C7-4EA1-FBD84C96E7AF}"/>
               </a:ext>
             </a:extLst>
           </p:cNvPr>
@@ -3706,7 +3706,7 @@
     </p:spTree>
     <p:extLst>
       <p:ext uri="{BB962C8B-B14F-4D97-AF65-F5344CB8AC3E}">
-        <p14:creationId xmlns:p14="http://schemas.microsoft.com/office/powerpoint/2010/main" val="2832981894"/>
+        <p14:creationId xmlns:p14="http://schemas.microsoft.com/office/powerpoint/2010/main" val="2933935928"/>
       </p:ext>
     </p:extLst>
   </p:cSld>
@@ -3738,7 +3738,7 @@
           <p:cNvPr id="3" name="Graphic 2">
             <a:extLst>
               <a:ext uri="{FF2B5EF4-FFF2-40B4-BE49-F238E27FC236}">
-                <a16:creationId xmlns:a16="http://schemas.microsoft.com/office/drawing/2014/main" id="{F7C1D1B2-99D5-EC4F-32C4-5FC838D330D4}"/>
+                <a16:creationId xmlns:a16="http://schemas.microsoft.com/office/drawing/2014/main" id="{D3C85373-8DEE-8192-1518-DEAD8F58A9DD}"/>
               </a:ext>
             </a:extLst>
           </p:cNvPr>
@@ -3772,7 +3772,7 @@
     </p:spTree>
     <p:extLst>
       <p:ext uri="{BB962C8B-B14F-4D97-AF65-F5344CB8AC3E}">
-        <p14:creationId xmlns:p14="http://schemas.microsoft.com/office/powerpoint/2010/main" val="2430454025"/>
+        <p14:creationId xmlns:p14="http://schemas.microsoft.com/office/powerpoint/2010/main" val="3575124240"/>
       </p:ext>
     </p:extLst>
   </p:cSld>
@@ -3804,7 +3804,7 @@
           <p:cNvPr id="3" name="Graphic 2">
             <a:extLst>
               <a:ext uri="{FF2B5EF4-FFF2-40B4-BE49-F238E27FC236}">
-                <a16:creationId xmlns:a16="http://schemas.microsoft.com/office/drawing/2014/main" id="{1A4316F7-91FA-D3CB-1B5D-B7EE0585997E}"/>
+                <a16:creationId xmlns:a16="http://schemas.microsoft.com/office/drawing/2014/main" id="{DFE79E98-0C00-E217-6094-927C244445D9}"/>
               </a:ext>
             </a:extLst>
           </p:cNvPr>
@@ -3838,7 +3838,7 @@
     </p:spTree>
     <p:extLst>
       <p:ext uri="{BB962C8B-B14F-4D97-AF65-F5344CB8AC3E}">
-        <p14:creationId xmlns:p14="http://schemas.microsoft.com/office/powerpoint/2010/main" val="498321637"/>
+        <p14:creationId xmlns:p14="http://schemas.microsoft.com/office/powerpoint/2010/main" val="2140822266"/>
       </p:ext>
     </p:extLst>
   </p:cSld>
@@ -3870,7 +3870,7 @@
           <p:cNvPr id="3" name="Graphic 2">
             <a:extLst>
               <a:ext uri="{FF2B5EF4-FFF2-40B4-BE49-F238E27FC236}">
-                <a16:creationId xmlns:a16="http://schemas.microsoft.com/office/drawing/2014/main" id="{ACE8E3D8-6052-7A5B-4944-59CD4080A7A9}"/>
+                <a16:creationId xmlns:a16="http://schemas.microsoft.com/office/drawing/2014/main" id="{2779BD3F-0B22-0137-9EC0-7F710C01CCDE}"/>
               </a:ext>
             </a:extLst>
           </p:cNvPr>
@@ -3904,7 +3904,7 @@
     </p:spTree>
     <p:extLst>
       <p:ext uri="{BB962C8B-B14F-4D97-AF65-F5344CB8AC3E}">
-        <p14:creationId xmlns:p14="http://schemas.microsoft.com/office/powerpoint/2010/main" val="2865797827"/>
+        <p14:creationId xmlns:p14="http://schemas.microsoft.com/office/powerpoint/2010/main" val="454660959"/>
       </p:ext>
     </p:extLst>
   </p:cSld>
@@ -3936,7 +3936,7 @@
           <p:cNvPr id="3" name="Graphic 2">
             <a:extLst>
               <a:ext uri="{FF2B5EF4-FFF2-40B4-BE49-F238E27FC236}">
-                <a16:creationId xmlns:a16="http://schemas.microsoft.com/office/drawing/2014/main" id="{68508788-0F4D-2980-3ECF-1221CD6956E3}"/>
+                <a16:creationId xmlns:a16="http://schemas.microsoft.com/office/drawing/2014/main" id="{0472CFBA-DCC7-19C4-0FE3-442203FB878B}"/>
               </a:ext>
             </a:extLst>
           </p:cNvPr>
@@ -3970,7 +3970,7 @@
     </p:spTree>
     <p:extLst>
       <p:ext uri="{BB962C8B-B14F-4D97-AF65-F5344CB8AC3E}">
-        <p14:creationId xmlns:p14="http://schemas.microsoft.com/office/powerpoint/2010/main" val="3076005136"/>
+        <p14:creationId xmlns:p14="http://schemas.microsoft.com/office/powerpoint/2010/main" val="2882298827"/>
       </p:ext>
     </p:extLst>
   </p:cSld>
@@ -4002,7 +4002,7 @@
           <p:cNvPr id="3" name="Graphic 2">
             <a:extLst>
               <a:ext uri="{FF2B5EF4-FFF2-40B4-BE49-F238E27FC236}">
-                <a16:creationId xmlns:a16="http://schemas.microsoft.com/office/drawing/2014/main" id="{8929B8F8-6F79-A89C-B1CC-87E61DF67672}"/>
+                <a16:creationId xmlns:a16="http://schemas.microsoft.com/office/drawing/2014/main" id="{80C608B7-821E-ED55-1634-636A56D37E80}"/>
               </a:ext>
             </a:extLst>
           </p:cNvPr>
@@ -4036,7 +4036,7 @@
     </p:spTree>
     <p:extLst>
       <p:ext uri="{BB962C8B-B14F-4D97-AF65-F5344CB8AC3E}">
-        <p14:creationId xmlns:p14="http://schemas.microsoft.com/office/powerpoint/2010/main" val="2136554912"/>
+        <p14:creationId xmlns:p14="http://schemas.microsoft.com/office/powerpoint/2010/main" val="3284552477"/>
       </p:ext>
     </p:extLst>
   </p:cSld>
@@ -4068,7 +4068,7 @@
           <p:cNvPr id="3" name="Graphic 2">
             <a:extLst>
               <a:ext uri="{FF2B5EF4-FFF2-40B4-BE49-F238E27FC236}">
-                <a16:creationId xmlns:a16="http://schemas.microsoft.com/office/drawing/2014/main" id="{E740EED8-E6F4-0845-8354-0313DE936269}"/>
+                <a16:creationId xmlns:a16="http://schemas.microsoft.com/office/drawing/2014/main" id="{AEAB79A7-F618-44D7-6CDD-934A3346981B}"/>
               </a:ext>
             </a:extLst>
           </p:cNvPr>
@@ -4102,7 +4102,7 @@
     </p:spTree>
     <p:extLst>
       <p:ext uri="{BB962C8B-B14F-4D97-AF65-F5344CB8AC3E}">
-        <p14:creationId xmlns:p14="http://schemas.microsoft.com/office/powerpoint/2010/main" val="3827906272"/>
+        <p14:creationId xmlns:p14="http://schemas.microsoft.com/office/powerpoint/2010/main" val="3148945429"/>
       </p:ext>
     </p:extLst>
   </p:cSld>
@@ -4134,7 +4134,7 @@
           <p:cNvPr id="3" name="Graphic 2">
             <a:extLst>
               <a:ext uri="{FF2B5EF4-FFF2-40B4-BE49-F238E27FC236}">
-                <a16:creationId xmlns:a16="http://schemas.microsoft.com/office/drawing/2014/main" id="{AE039402-43F4-B7A5-E1F3-7D4E75A7D198}"/>
+                <a16:creationId xmlns:a16="http://schemas.microsoft.com/office/drawing/2014/main" id="{FCA25E2E-D8AF-1249-6780-7E1CBF716230}"/>
               </a:ext>
             </a:extLst>
           </p:cNvPr>
@@ -4168,7 +4168,7 @@
     </p:spTree>
     <p:extLst>
       <p:ext uri="{BB962C8B-B14F-4D97-AF65-F5344CB8AC3E}">
-        <p14:creationId xmlns:p14="http://schemas.microsoft.com/office/powerpoint/2010/main" val="1260385467"/>
+        <p14:creationId xmlns:p14="http://schemas.microsoft.com/office/powerpoint/2010/main" val="3335036668"/>
       </p:ext>
     </p:extLst>
   </p:cSld>
@@ -4200,7 +4200,7 @@
           <p:cNvPr id="3" name="Graphic 2">
             <a:extLst>
               <a:ext uri="{FF2B5EF4-FFF2-40B4-BE49-F238E27FC236}">
-                <a16:creationId xmlns:a16="http://schemas.microsoft.com/office/drawing/2014/main" id="{9A61B24C-2A02-A717-62D3-51C410ECE1A3}"/>
+                <a16:creationId xmlns:a16="http://schemas.microsoft.com/office/drawing/2014/main" id="{EA080342-392D-71AE-6268-5B511FBE0DED}"/>
               </a:ext>
             </a:extLst>
           </p:cNvPr>
@@ -4234,7 +4234,7 @@
     </p:spTree>
     <p:extLst>
       <p:ext uri="{BB962C8B-B14F-4D97-AF65-F5344CB8AC3E}">
-        <p14:creationId xmlns:p14="http://schemas.microsoft.com/office/powerpoint/2010/main" val="1536116679"/>
+        <p14:creationId xmlns:p14="http://schemas.microsoft.com/office/powerpoint/2010/main" val="1072996193"/>
       </p:ext>
     </p:extLst>
   </p:cSld>
@@ -4266,7 +4266,7 @@
           <p:cNvPr id="3" name="Graphic 2">
             <a:extLst>
               <a:ext uri="{FF2B5EF4-FFF2-40B4-BE49-F238E27FC236}">
-                <a16:creationId xmlns:a16="http://schemas.microsoft.com/office/drawing/2014/main" id="{C2A5E449-482E-894B-B401-C87560505E92}"/>
+                <a16:creationId xmlns:a16="http://schemas.microsoft.com/office/drawing/2014/main" id="{508AEFB0-F889-711D-C318-2D3BD32C6BC3}"/>
               </a:ext>
             </a:extLst>
           </p:cNvPr>
@@ -4300,7 +4300,7 @@
     </p:spTree>
     <p:extLst>
       <p:ext uri="{BB962C8B-B14F-4D97-AF65-F5344CB8AC3E}">
-        <p14:creationId xmlns:p14="http://schemas.microsoft.com/office/powerpoint/2010/main" val="3571904793"/>
+        <p14:creationId xmlns:p14="http://schemas.microsoft.com/office/powerpoint/2010/main" val="2074858850"/>
       </p:ext>
     </p:extLst>
   </p:cSld>
@@ -4332,7 +4332,7 @@
           <p:cNvPr id="3" name="Graphic 2">
             <a:extLst>
               <a:ext uri="{FF2B5EF4-FFF2-40B4-BE49-F238E27FC236}">
-                <a16:creationId xmlns:a16="http://schemas.microsoft.com/office/drawing/2014/main" id="{461A9A40-C089-F6AA-65EB-62FA7EA7B993}"/>
+                <a16:creationId xmlns:a16="http://schemas.microsoft.com/office/drawing/2014/main" id="{D2F11FA3-812A-33DD-DEDF-E160B359EDD6}"/>
               </a:ext>
             </a:extLst>
           </p:cNvPr>
@@ -4366,7 +4366,7 @@
     </p:spTree>
     <p:extLst>
       <p:ext uri="{BB962C8B-B14F-4D97-AF65-F5344CB8AC3E}">
-        <p14:creationId xmlns:p14="http://schemas.microsoft.com/office/powerpoint/2010/main" val="2833709363"/>
+        <p14:creationId xmlns:p14="http://schemas.microsoft.com/office/powerpoint/2010/main" val="875486014"/>
       </p:ext>
     </p:extLst>
   </p:cSld>
@@ -4398,7 +4398,7 @@
           <p:cNvPr id="3" name="Graphic 2">
             <a:extLst>
               <a:ext uri="{FF2B5EF4-FFF2-40B4-BE49-F238E27FC236}">
-                <a16:creationId xmlns:a16="http://schemas.microsoft.com/office/drawing/2014/main" id="{11C6731D-DA96-3F78-BAE8-18C158D7E094}"/>
+                <a16:creationId xmlns:a16="http://schemas.microsoft.com/office/drawing/2014/main" id="{8CE4AC44-5991-55ED-9B0F-ACEB37DF07EE}"/>
               </a:ext>
             </a:extLst>
           </p:cNvPr>
@@ -4432,7 +4432,7 @@
     </p:spTree>
     <p:extLst>
       <p:ext uri="{BB962C8B-B14F-4D97-AF65-F5344CB8AC3E}">
-        <p14:creationId xmlns:p14="http://schemas.microsoft.com/office/powerpoint/2010/main" val="470052688"/>
+        <p14:creationId xmlns:p14="http://schemas.microsoft.com/office/powerpoint/2010/main" val="1807728771"/>
       </p:ext>
     </p:extLst>
   </p:cSld>

</xml_diff>

<commit_message>
fix(svg): improve Canva compatibility for page17
</commit_message>
<xml_diff>
--- a/Desktop/Proposal/exports/LeadFlow-Proposal-v1.0.pptx
+++ b/Desktop/Proposal/exports/LeadFlow-Proposal-v1.0.pptx
@@ -145,7 +145,7 @@
           <p:cNvPr id="2" name="Title 1">
             <a:extLst>
               <a:ext uri="{FF2B5EF4-FFF2-40B4-BE49-F238E27FC236}">
-                <a16:creationId xmlns:a16="http://schemas.microsoft.com/office/drawing/2014/main" id="{30126BE7-CC2A-E090-1516-3340998988DE}"/>
+                <a16:creationId xmlns:a16="http://schemas.microsoft.com/office/drawing/2014/main" id="{9FE85EB5-1A52-BB2E-2AA8-AC93F10EE484}"/>
               </a:ext>
             </a:extLst>
           </p:cNvPr>
@@ -182,7 +182,7 @@
           <p:cNvPr id="3" name="Subtitle 2">
             <a:extLst>
               <a:ext uri="{FF2B5EF4-FFF2-40B4-BE49-F238E27FC236}">
-                <a16:creationId xmlns:a16="http://schemas.microsoft.com/office/drawing/2014/main" id="{5D3739B2-54E2-5ECD-EFCC-F1F1C2D98285}"/>
+                <a16:creationId xmlns:a16="http://schemas.microsoft.com/office/drawing/2014/main" id="{9BBBE73F-58C4-22AB-9AAE-507CA52318A9}"/>
               </a:ext>
             </a:extLst>
           </p:cNvPr>
@@ -252,7 +252,7 @@
           <p:cNvPr id="4" name="Date Placeholder 3">
             <a:extLst>
               <a:ext uri="{FF2B5EF4-FFF2-40B4-BE49-F238E27FC236}">
-                <a16:creationId xmlns:a16="http://schemas.microsoft.com/office/drawing/2014/main" id="{718BF69E-496A-EDD7-A6D2-3D81F12D95E7}"/>
+                <a16:creationId xmlns:a16="http://schemas.microsoft.com/office/drawing/2014/main" id="{6F63D918-FC41-06CE-1088-7DC24FBCE3FD}"/>
               </a:ext>
             </a:extLst>
           </p:cNvPr>
@@ -268,7 +268,7 @@
           <a:bodyPr/>
           <a:lstStyle/>
           <a:p>
-            <a:fld id="{0BAD9C77-6EC3-4D89-8A0D-C68FA7E8B712}" type="datetimeFigureOut">
+            <a:fld id="{E9525A42-77D0-4AB8-8B39-6AC1494C132A}" type="datetimeFigureOut">
               <a:rPr lang="en-US" smtClean="0"/>
               <a:t>7/11/2026</a:t>
             </a:fld>
@@ -281,7 +281,7 @@
           <p:cNvPr id="5" name="Footer Placeholder 4">
             <a:extLst>
               <a:ext uri="{FF2B5EF4-FFF2-40B4-BE49-F238E27FC236}">
-                <a16:creationId xmlns:a16="http://schemas.microsoft.com/office/drawing/2014/main" id="{F2F112DC-C380-A937-BFFB-F0B04E555568}"/>
+                <a16:creationId xmlns:a16="http://schemas.microsoft.com/office/drawing/2014/main" id="{DFA988BE-427B-E9A4-C73E-DDAAD3C5FF7B}"/>
               </a:ext>
             </a:extLst>
           </p:cNvPr>
@@ -306,7 +306,7 @@
           <p:cNvPr id="6" name="Slide Number Placeholder 5">
             <a:extLst>
               <a:ext uri="{FF2B5EF4-FFF2-40B4-BE49-F238E27FC236}">
-                <a16:creationId xmlns:a16="http://schemas.microsoft.com/office/drawing/2014/main" id="{0529C591-67B3-6D2F-3120-FAEFCE191C53}"/>
+                <a16:creationId xmlns:a16="http://schemas.microsoft.com/office/drawing/2014/main" id="{9DC060CD-D0A0-1810-6AC0-F470D042AD0E}"/>
               </a:ext>
             </a:extLst>
           </p:cNvPr>
@@ -322,7 +322,7 @@
           <a:bodyPr/>
           <a:lstStyle/>
           <a:p>
-            <a:fld id="{DA215C20-D0E9-41CE-87D5-BCE849F24902}" type="slidenum">
+            <a:fld id="{75C8E502-030C-4066-857C-1F5FD0535842}" type="slidenum">
               <a:rPr lang="en-US" smtClean="0"/>
               <a:t>‹#›</a:t>
             </a:fld>
@@ -333,7 +333,7 @@
     </p:spTree>
     <p:extLst>
       <p:ext uri="{BB962C8B-B14F-4D97-AF65-F5344CB8AC3E}">
-        <p14:creationId xmlns:p14="http://schemas.microsoft.com/office/powerpoint/2010/main" val="3710990470"/>
+        <p14:creationId xmlns:p14="http://schemas.microsoft.com/office/powerpoint/2010/main" val="1775804514"/>
       </p:ext>
     </p:extLst>
   </p:cSld>
@@ -365,7 +365,7 @@
           <p:cNvPr id="2" name="Title 1">
             <a:extLst>
               <a:ext uri="{FF2B5EF4-FFF2-40B4-BE49-F238E27FC236}">
-                <a16:creationId xmlns:a16="http://schemas.microsoft.com/office/drawing/2014/main" id="{1CE76CDD-2BEB-A049-EEA0-D2AAEBAD4BE3}"/>
+                <a16:creationId xmlns:a16="http://schemas.microsoft.com/office/drawing/2014/main" id="{588E4A2C-9E8A-4ADD-3D58-35AE927FBC89}"/>
               </a:ext>
             </a:extLst>
           </p:cNvPr>
@@ -393,7 +393,7 @@
           <p:cNvPr id="3" name="Vertical Text Placeholder 2">
             <a:extLst>
               <a:ext uri="{FF2B5EF4-FFF2-40B4-BE49-F238E27FC236}">
-                <a16:creationId xmlns:a16="http://schemas.microsoft.com/office/drawing/2014/main" id="{53C8A72D-3D27-9F59-B4FD-0703471A6473}"/>
+                <a16:creationId xmlns:a16="http://schemas.microsoft.com/office/drawing/2014/main" id="{6C70EF55-B1E0-3986-40A0-26EC2B29F6C6}"/>
               </a:ext>
             </a:extLst>
           </p:cNvPr>
@@ -450,7 +450,7 @@
           <p:cNvPr id="4" name="Date Placeholder 3">
             <a:extLst>
               <a:ext uri="{FF2B5EF4-FFF2-40B4-BE49-F238E27FC236}">
-                <a16:creationId xmlns:a16="http://schemas.microsoft.com/office/drawing/2014/main" id="{90CCF179-7A3F-59FD-D77A-EAFB95F6C695}"/>
+                <a16:creationId xmlns:a16="http://schemas.microsoft.com/office/drawing/2014/main" id="{653A5F7C-B7FF-B240-329F-947155B568D3}"/>
               </a:ext>
             </a:extLst>
           </p:cNvPr>
@@ -466,7 +466,7 @@
           <a:bodyPr/>
           <a:lstStyle/>
           <a:p>
-            <a:fld id="{0BAD9C77-6EC3-4D89-8A0D-C68FA7E8B712}" type="datetimeFigureOut">
+            <a:fld id="{E9525A42-77D0-4AB8-8B39-6AC1494C132A}" type="datetimeFigureOut">
               <a:rPr lang="en-US" smtClean="0"/>
               <a:t>7/11/2026</a:t>
             </a:fld>
@@ -479,7 +479,7 @@
           <p:cNvPr id="5" name="Footer Placeholder 4">
             <a:extLst>
               <a:ext uri="{FF2B5EF4-FFF2-40B4-BE49-F238E27FC236}">
-                <a16:creationId xmlns:a16="http://schemas.microsoft.com/office/drawing/2014/main" id="{6E39E8FA-E116-672A-BDEC-8B22F98CA690}"/>
+                <a16:creationId xmlns:a16="http://schemas.microsoft.com/office/drawing/2014/main" id="{73FEBFEA-82CA-E69D-5EE5-AAAF58223B81}"/>
               </a:ext>
             </a:extLst>
           </p:cNvPr>
@@ -504,7 +504,7 @@
           <p:cNvPr id="6" name="Slide Number Placeholder 5">
             <a:extLst>
               <a:ext uri="{FF2B5EF4-FFF2-40B4-BE49-F238E27FC236}">
-                <a16:creationId xmlns:a16="http://schemas.microsoft.com/office/drawing/2014/main" id="{0B5E8556-153B-FB4E-058D-39F97F3B4999}"/>
+                <a16:creationId xmlns:a16="http://schemas.microsoft.com/office/drawing/2014/main" id="{519D84D4-988A-79C0-D03F-09AB75E8F21A}"/>
               </a:ext>
             </a:extLst>
           </p:cNvPr>
@@ -520,7 +520,7 @@
           <a:bodyPr/>
           <a:lstStyle/>
           <a:p>
-            <a:fld id="{DA215C20-D0E9-41CE-87D5-BCE849F24902}" type="slidenum">
+            <a:fld id="{75C8E502-030C-4066-857C-1F5FD0535842}" type="slidenum">
               <a:rPr lang="en-US" smtClean="0"/>
               <a:t>‹#›</a:t>
             </a:fld>
@@ -531,7 +531,7 @@
     </p:spTree>
     <p:extLst>
       <p:ext uri="{BB962C8B-B14F-4D97-AF65-F5344CB8AC3E}">
-        <p14:creationId xmlns:p14="http://schemas.microsoft.com/office/powerpoint/2010/main" val="3379462897"/>
+        <p14:creationId xmlns:p14="http://schemas.microsoft.com/office/powerpoint/2010/main" val="2906896765"/>
       </p:ext>
     </p:extLst>
   </p:cSld>
@@ -563,7 +563,7 @@
           <p:cNvPr id="2" name="Vertical Title 1">
             <a:extLst>
               <a:ext uri="{FF2B5EF4-FFF2-40B4-BE49-F238E27FC236}">
-                <a16:creationId xmlns:a16="http://schemas.microsoft.com/office/drawing/2014/main" id="{F87A2208-0942-77A5-0F2A-ABD6CBBEDF18}"/>
+                <a16:creationId xmlns:a16="http://schemas.microsoft.com/office/drawing/2014/main" id="{0D0A4F4C-D4A5-D9AC-F020-D7CB1A0A8F4E}"/>
               </a:ext>
             </a:extLst>
           </p:cNvPr>
@@ -596,7 +596,7 @@
           <p:cNvPr id="3" name="Vertical Text Placeholder 2">
             <a:extLst>
               <a:ext uri="{FF2B5EF4-FFF2-40B4-BE49-F238E27FC236}">
-                <a16:creationId xmlns:a16="http://schemas.microsoft.com/office/drawing/2014/main" id="{EDCF593E-E429-5ECF-1227-AC08F94E3467}"/>
+                <a16:creationId xmlns:a16="http://schemas.microsoft.com/office/drawing/2014/main" id="{478B9E79-5D7E-E509-0239-5551F0B21D95}"/>
               </a:ext>
             </a:extLst>
           </p:cNvPr>
@@ -658,7 +658,7 @@
           <p:cNvPr id="4" name="Date Placeholder 3">
             <a:extLst>
               <a:ext uri="{FF2B5EF4-FFF2-40B4-BE49-F238E27FC236}">
-                <a16:creationId xmlns:a16="http://schemas.microsoft.com/office/drawing/2014/main" id="{F28B4FC3-8D59-ACFD-6DE9-308B96DD7C0E}"/>
+                <a16:creationId xmlns:a16="http://schemas.microsoft.com/office/drawing/2014/main" id="{82F7EC0B-3637-C6C1-0AED-023704DF4ACF}"/>
               </a:ext>
             </a:extLst>
           </p:cNvPr>
@@ -674,7 +674,7 @@
           <a:bodyPr/>
           <a:lstStyle/>
           <a:p>
-            <a:fld id="{0BAD9C77-6EC3-4D89-8A0D-C68FA7E8B712}" type="datetimeFigureOut">
+            <a:fld id="{E9525A42-77D0-4AB8-8B39-6AC1494C132A}" type="datetimeFigureOut">
               <a:rPr lang="en-US" smtClean="0"/>
               <a:t>7/11/2026</a:t>
             </a:fld>
@@ -687,7 +687,7 @@
           <p:cNvPr id="5" name="Footer Placeholder 4">
             <a:extLst>
               <a:ext uri="{FF2B5EF4-FFF2-40B4-BE49-F238E27FC236}">
-                <a16:creationId xmlns:a16="http://schemas.microsoft.com/office/drawing/2014/main" id="{EF1C698F-A540-3F5B-86F1-CBAFC36DD46C}"/>
+                <a16:creationId xmlns:a16="http://schemas.microsoft.com/office/drawing/2014/main" id="{31D5D5C1-05FF-8917-FD5E-C677060F5C68}"/>
               </a:ext>
             </a:extLst>
           </p:cNvPr>
@@ -712,7 +712,7 @@
           <p:cNvPr id="6" name="Slide Number Placeholder 5">
             <a:extLst>
               <a:ext uri="{FF2B5EF4-FFF2-40B4-BE49-F238E27FC236}">
-                <a16:creationId xmlns:a16="http://schemas.microsoft.com/office/drawing/2014/main" id="{537B4225-2937-60BA-3B93-52C3A3536939}"/>
+                <a16:creationId xmlns:a16="http://schemas.microsoft.com/office/drawing/2014/main" id="{D6956D08-07D7-CE2D-3665-C3EE4A2D18D2}"/>
               </a:ext>
             </a:extLst>
           </p:cNvPr>
@@ -728,7 +728,7 @@
           <a:bodyPr/>
           <a:lstStyle/>
           <a:p>
-            <a:fld id="{DA215C20-D0E9-41CE-87D5-BCE849F24902}" type="slidenum">
+            <a:fld id="{75C8E502-030C-4066-857C-1F5FD0535842}" type="slidenum">
               <a:rPr lang="en-US" smtClean="0"/>
               <a:t>‹#›</a:t>
             </a:fld>
@@ -739,7 +739,7 @@
     </p:spTree>
     <p:extLst>
       <p:ext uri="{BB962C8B-B14F-4D97-AF65-F5344CB8AC3E}">
-        <p14:creationId xmlns:p14="http://schemas.microsoft.com/office/powerpoint/2010/main" val="2216149430"/>
+        <p14:creationId xmlns:p14="http://schemas.microsoft.com/office/powerpoint/2010/main" val="3576754917"/>
       </p:ext>
     </p:extLst>
   </p:cSld>
@@ -771,7 +771,7 @@
           <p:cNvPr id="2" name="Title 1">
             <a:extLst>
               <a:ext uri="{FF2B5EF4-FFF2-40B4-BE49-F238E27FC236}">
-                <a16:creationId xmlns:a16="http://schemas.microsoft.com/office/drawing/2014/main" id="{8ED4E5A3-ABC8-7D51-EB35-CF31ADD4CD96}"/>
+                <a16:creationId xmlns:a16="http://schemas.microsoft.com/office/drawing/2014/main" id="{FDE6DAB5-8FB1-EB5C-E699-CDD902182AFA}"/>
               </a:ext>
             </a:extLst>
           </p:cNvPr>
@@ -799,7 +799,7 @@
           <p:cNvPr id="3" name="Content Placeholder 2">
             <a:extLst>
               <a:ext uri="{FF2B5EF4-FFF2-40B4-BE49-F238E27FC236}">
-                <a16:creationId xmlns:a16="http://schemas.microsoft.com/office/drawing/2014/main" id="{6C8B194A-CA7A-2916-69BE-480810A11C90}"/>
+                <a16:creationId xmlns:a16="http://schemas.microsoft.com/office/drawing/2014/main" id="{CF8ED7FC-EF65-DFAC-4EA6-5CEFC6DF0DFB}"/>
               </a:ext>
             </a:extLst>
           </p:cNvPr>
@@ -856,7 +856,7 @@
           <p:cNvPr id="4" name="Date Placeholder 3">
             <a:extLst>
               <a:ext uri="{FF2B5EF4-FFF2-40B4-BE49-F238E27FC236}">
-                <a16:creationId xmlns:a16="http://schemas.microsoft.com/office/drawing/2014/main" id="{C8DCB60F-91FA-2A5B-31A5-2BB524CC12FD}"/>
+                <a16:creationId xmlns:a16="http://schemas.microsoft.com/office/drawing/2014/main" id="{271FB40C-7DE4-2DDC-CCD7-2A9176DD625C}"/>
               </a:ext>
             </a:extLst>
           </p:cNvPr>
@@ -872,7 +872,7 @@
           <a:bodyPr/>
           <a:lstStyle/>
           <a:p>
-            <a:fld id="{0BAD9C77-6EC3-4D89-8A0D-C68FA7E8B712}" type="datetimeFigureOut">
+            <a:fld id="{E9525A42-77D0-4AB8-8B39-6AC1494C132A}" type="datetimeFigureOut">
               <a:rPr lang="en-US" smtClean="0"/>
               <a:t>7/11/2026</a:t>
             </a:fld>
@@ -885,7 +885,7 @@
           <p:cNvPr id="5" name="Footer Placeholder 4">
             <a:extLst>
               <a:ext uri="{FF2B5EF4-FFF2-40B4-BE49-F238E27FC236}">
-                <a16:creationId xmlns:a16="http://schemas.microsoft.com/office/drawing/2014/main" id="{19BD7FCF-0C0C-4607-4896-71541EA29E11}"/>
+                <a16:creationId xmlns:a16="http://schemas.microsoft.com/office/drawing/2014/main" id="{6DA3B8EB-5D42-3267-57B7-EDADDE01666E}"/>
               </a:ext>
             </a:extLst>
           </p:cNvPr>
@@ -910,7 +910,7 @@
           <p:cNvPr id="6" name="Slide Number Placeholder 5">
             <a:extLst>
               <a:ext uri="{FF2B5EF4-FFF2-40B4-BE49-F238E27FC236}">
-                <a16:creationId xmlns:a16="http://schemas.microsoft.com/office/drawing/2014/main" id="{BC6FBDB8-04FF-D324-D82B-01E9232DB8C7}"/>
+                <a16:creationId xmlns:a16="http://schemas.microsoft.com/office/drawing/2014/main" id="{2197D935-D0C4-B04B-2AFC-C9B51D02115D}"/>
               </a:ext>
             </a:extLst>
           </p:cNvPr>
@@ -926,7 +926,7 @@
           <a:bodyPr/>
           <a:lstStyle/>
           <a:p>
-            <a:fld id="{DA215C20-D0E9-41CE-87D5-BCE849F24902}" type="slidenum">
+            <a:fld id="{75C8E502-030C-4066-857C-1F5FD0535842}" type="slidenum">
               <a:rPr lang="en-US" smtClean="0"/>
               <a:t>‹#›</a:t>
             </a:fld>
@@ -937,7 +937,7 @@
     </p:spTree>
     <p:extLst>
       <p:ext uri="{BB962C8B-B14F-4D97-AF65-F5344CB8AC3E}">
-        <p14:creationId xmlns:p14="http://schemas.microsoft.com/office/powerpoint/2010/main" val="618426814"/>
+        <p14:creationId xmlns:p14="http://schemas.microsoft.com/office/powerpoint/2010/main" val="2007284412"/>
       </p:ext>
     </p:extLst>
   </p:cSld>
@@ -969,7 +969,7 @@
           <p:cNvPr id="2" name="Title 1">
             <a:extLst>
               <a:ext uri="{FF2B5EF4-FFF2-40B4-BE49-F238E27FC236}">
-                <a16:creationId xmlns:a16="http://schemas.microsoft.com/office/drawing/2014/main" id="{408B61B2-69F0-02CA-E214-E530D1816F3E}"/>
+                <a16:creationId xmlns:a16="http://schemas.microsoft.com/office/drawing/2014/main" id="{71B01E47-6007-C36D-5E71-2E82B4BBC132}"/>
               </a:ext>
             </a:extLst>
           </p:cNvPr>
@@ -1006,7 +1006,7 @@
           <p:cNvPr id="3" name="Text Placeholder 2">
             <a:extLst>
               <a:ext uri="{FF2B5EF4-FFF2-40B4-BE49-F238E27FC236}">
-                <a16:creationId xmlns:a16="http://schemas.microsoft.com/office/drawing/2014/main" id="{52AF39C9-120A-BA26-6865-26E6ED8B654B}"/>
+                <a16:creationId xmlns:a16="http://schemas.microsoft.com/office/drawing/2014/main" id="{EB7F2AE1-4A26-532F-171B-9710191AA8E2}"/>
               </a:ext>
             </a:extLst>
           </p:cNvPr>
@@ -1131,7 +1131,7 @@
           <p:cNvPr id="4" name="Date Placeholder 3">
             <a:extLst>
               <a:ext uri="{FF2B5EF4-FFF2-40B4-BE49-F238E27FC236}">
-                <a16:creationId xmlns:a16="http://schemas.microsoft.com/office/drawing/2014/main" id="{10D2F3BB-B16C-AD6E-FC12-3D350BB8C61C}"/>
+                <a16:creationId xmlns:a16="http://schemas.microsoft.com/office/drawing/2014/main" id="{81E85C01-C5F6-711F-6FBB-E735B5009535}"/>
               </a:ext>
             </a:extLst>
           </p:cNvPr>
@@ -1147,7 +1147,7 @@
           <a:bodyPr/>
           <a:lstStyle/>
           <a:p>
-            <a:fld id="{0BAD9C77-6EC3-4D89-8A0D-C68FA7E8B712}" type="datetimeFigureOut">
+            <a:fld id="{E9525A42-77D0-4AB8-8B39-6AC1494C132A}" type="datetimeFigureOut">
               <a:rPr lang="en-US" smtClean="0"/>
               <a:t>7/11/2026</a:t>
             </a:fld>
@@ -1160,7 +1160,7 @@
           <p:cNvPr id="5" name="Footer Placeholder 4">
             <a:extLst>
               <a:ext uri="{FF2B5EF4-FFF2-40B4-BE49-F238E27FC236}">
-                <a16:creationId xmlns:a16="http://schemas.microsoft.com/office/drawing/2014/main" id="{E98517F0-9013-69FC-EA91-E3D6B4FD7936}"/>
+                <a16:creationId xmlns:a16="http://schemas.microsoft.com/office/drawing/2014/main" id="{AFEF41F0-663E-3A84-5E33-6738ADE08725}"/>
               </a:ext>
             </a:extLst>
           </p:cNvPr>
@@ -1185,7 +1185,7 @@
           <p:cNvPr id="6" name="Slide Number Placeholder 5">
             <a:extLst>
               <a:ext uri="{FF2B5EF4-FFF2-40B4-BE49-F238E27FC236}">
-                <a16:creationId xmlns:a16="http://schemas.microsoft.com/office/drawing/2014/main" id="{AEF22B1D-FEAC-95DA-B8D1-868345354888}"/>
+                <a16:creationId xmlns:a16="http://schemas.microsoft.com/office/drawing/2014/main" id="{59A3925C-CAC2-C035-22B5-CFEEAD0D1146}"/>
               </a:ext>
             </a:extLst>
           </p:cNvPr>
@@ -1201,7 +1201,7 @@
           <a:bodyPr/>
           <a:lstStyle/>
           <a:p>
-            <a:fld id="{DA215C20-D0E9-41CE-87D5-BCE849F24902}" type="slidenum">
+            <a:fld id="{75C8E502-030C-4066-857C-1F5FD0535842}" type="slidenum">
               <a:rPr lang="en-US" smtClean="0"/>
               <a:t>‹#›</a:t>
             </a:fld>
@@ -1212,7 +1212,7 @@
     </p:spTree>
     <p:extLst>
       <p:ext uri="{BB962C8B-B14F-4D97-AF65-F5344CB8AC3E}">
-        <p14:creationId xmlns:p14="http://schemas.microsoft.com/office/powerpoint/2010/main" val="1755030188"/>
+        <p14:creationId xmlns:p14="http://schemas.microsoft.com/office/powerpoint/2010/main" val="524915226"/>
       </p:ext>
     </p:extLst>
   </p:cSld>
@@ -1244,7 +1244,7 @@
           <p:cNvPr id="2" name="Title 1">
             <a:extLst>
               <a:ext uri="{FF2B5EF4-FFF2-40B4-BE49-F238E27FC236}">
-                <a16:creationId xmlns:a16="http://schemas.microsoft.com/office/drawing/2014/main" id="{906133E0-715F-E6B5-A6B5-510D0079F8D1}"/>
+                <a16:creationId xmlns:a16="http://schemas.microsoft.com/office/drawing/2014/main" id="{1DD76A51-37FE-035D-4542-41F6E37DEFCF}"/>
               </a:ext>
             </a:extLst>
           </p:cNvPr>
@@ -1272,7 +1272,7 @@
           <p:cNvPr id="3" name="Content Placeholder 2">
             <a:extLst>
               <a:ext uri="{FF2B5EF4-FFF2-40B4-BE49-F238E27FC236}">
-                <a16:creationId xmlns:a16="http://schemas.microsoft.com/office/drawing/2014/main" id="{F92B81E9-9D3F-42D2-15AD-4BC8FB426083}"/>
+                <a16:creationId xmlns:a16="http://schemas.microsoft.com/office/drawing/2014/main" id="{DC3E4C8C-18D1-DC7E-6B93-A25E63E3ECEF}"/>
               </a:ext>
             </a:extLst>
           </p:cNvPr>
@@ -1334,7 +1334,7 @@
           <p:cNvPr id="4" name="Content Placeholder 3">
             <a:extLst>
               <a:ext uri="{FF2B5EF4-FFF2-40B4-BE49-F238E27FC236}">
-                <a16:creationId xmlns:a16="http://schemas.microsoft.com/office/drawing/2014/main" id="{1E2EF95E-A96B-BDA4-0737-353B40C6BE05}"/>
+                <a16:creationId xmlns:a16="http://schemas.microsoft.com/office/drawing/2014/main" id="{3126215C-D958-5C20-5D08-A7772FDA4F90}"/>
               </a:ext>
             </a:extLst>
           </p:cNvPr>
@@ -1396,7 +1396,7 @@
           <p:cNvPr id="5" name="Date Placeholder 4">
             <a:extLst>
               <a:ext uri="{FF2B5EF4-FFF2-40B4-BE49-F238E27FC236}">
-                <a16:creationId xmlns:a16="http://schemas.microsoft.com/office/drawing/2014/main" id="{D9EB6D51-F5F2-095B-0CE8-4D050ABFF28B}"/>
+                <a16:creationId xmlns:a16="http://schemas.microsoft.com/office/drawing/2014/main" id="{C25304F6-6EBE-723F-F93A-8FBBCDDB0F98}"/>
               </a:ext>
             </a:extLst>
           </p:cNvPr>
@@ -1412,7 +1412,7 @@
           <a:bodyPr/>
           <a:lstStyle/>
           <a:p>
-            <a:fld id="{0BAD9C77-6EC3-4D89-8A0D-C68FA7E8B712}" type="datetimeFigureOut">
+            <a:fld id="{E9525A42-77D0-4AB8-8B39-6AC1494C132A}" type="datetimeFigureOut">
               <a:rPr lang="en-US" smtClean="0"/>
               <a:t>7/11/2026</a:t>
             </a:fld>
@@ -1425,7 +1425,7 @@
           <p:cNvPr id="6" name="Footer Placeholder 5">
             <a:extLst>
               <a:ext uri="{FF2B5EF4-FFF2-40B4-BE49-F238E27FC236}">
-                <a16:creationId xmlns:a16="http://schemas.microsoft.com/office/drawing/2014/main" id="{3F87365A-B20A-1259-596A-22882A97B8FA}"/>
+                <a16:creationId xmlns:a16="http://schemas.microsoft.com/office/drawing/2014/main" id="{DEFE9CB6-98D9-7388-FE25-4B70B8671C81}"/>
               </a:ext>
             </a:extLst>
           </p:cNvPr>
@@ -1450,7 +1450,7 @@
           <p:cNvPr id="7" name="Slide Number Placeholder 6">
             <a:extLst>
               <a:ext uri="{FF2B5EF4-FFF2-40B4-BE49-F238E27FC236}">
-                <a16:creationId xmlns:a16="http://schemas.microsoft.com/office/drawing/2014/main" id="{98769B1B-8C69-D90E-1846-E433C1BA21BC}"/>
+                <a16:creationId xmlns:a16="http://schemas.microsoft.com/office/drawing/2014/main" id="{6AFA5C10-CF5C-224E-49E1-99A5D4FEC11C}"/>
               </a:ext>
             </a:extLst>
           </p:cNvPr>
@@ -1466,7 +1466,7 @@
           <a:bodyPr/>
           <a:lstStyle/>
           <a:p>
-            <a:fld id="{DA215C20-D0E9-41CE-87D5-BCE849F24902}" type="slidenum">
+            <a:fld id="{75C8E502-030C-4066-857C-1F5FD0535842}" type="slidenum">
               <a:rPr lang="en-US" smtClean="0"/>
               <a:t>‹#›</a:t>
             </a:fld>
@@ -1477,7 +1477,7 @@
     </p:spTree>
     <p:extLst>
       <p:ext uri="{BB962C8B-B14F-4D97-AF65-F5344CB8AC3E}">
-        <p14:creationId xmlns:p14="http://schemas.microsoft.com/office/powerpoint/2010/main" val="3561859439"/>
+        <p14:creationId xmlns:p14="http://schemas.microsoft.com/office/powerpoint/2010/main" val="195488365"/>
       </p:ext>
     </p:extLst>
   </p:cSld>
@@ -1509,7 +1509,7 @@
           <p:cNvPr id="2" name="Title 1">
             <a:extLst>
               <a:ext uri="{FF2B5EF4-FFF2-40B4-BE49-F238E27FC236}">
-                <a16:creationId xmlns:a16="http://schemas.microsoft.com/office/drawing/2014/main" id="{673125E5-1F28-18C8-FD86-79625D784C37}"/>
+                <a16:creationId xmlns:a16="http://schemas.microsoft.com/office/drawing/2014/main" id="{0F48E662-6D3F-D46D-8867-6F853A32A8FC}"/>
               </a:ext>
             </a:extLst>
           </p:cNvPr>
@@ -1542,7 +1542,7 @@
           <p:cNvPr id="3" name="Text Placeholder 2">
             <a:extLst>
               <a:ext uri="{FF2B5EF4-FFF2-40B4-BE49-F238E27FC236}">
-                <a16:creationId xmlns:a16="http://schemas.microsoft.com/office/drawing/2014/main" id="{D90406AE-98E4-6365-B4B7-611EF719DFC8}"/>
+                <a16:creationId xmlns:a16="http://schemas.microsoft.com/office/drawing/2014/main" id="{4C09D8EB-E9B0-CC50-D645-BE255E6F4548}"/>
               </a:ext>
             </a:extLst>
           </p:cNvPr>
@@ -1613,7 +1613,7 @@
           <p:cNvPr id="4" name="Content Placeholder 3">
             <a:extLst>
               <a:ext uri="{FF2B5EF4-FFF2-40B4-BE49-F238E27FC236}">
-                <a16:creationId xmlns:a16="http://schemas.microsoft.com/office/drawing/2014/main" id="{8F20C78F-9F58-A471-EC00-127789143A3E}"/>
+                <a16:creationId xmlns:a16="http://schemas.microsoft.com/office/drawing/2014/main" id="{EF14BA5F-788D-F779-2A84-78C29FBB4258}"/>
               </a:ext>
             </a:extLst>
           </p:cNvPr>
@@ -1675,7 +1675,7 @@
           <p:cNvPr id="5" name="Text Placeholder 4">
             <a:extLst>
               <a:ext uri="{FF2B5EF4-FFF2-40B4-BE49-F238E27FC236}">
-                <a16:creationId xmlns:a16="http://schemas.microsoft.com/office/drawing/2014/main" id="{C4D9C9F6-0EDD-DD17-5E6A-837914731263}"/>
+                <a16:creationId xmlns:a16="http://schemas.microsoft.com/office/drawing/2014/main" id="{F04DFC0B-6288-32FF-B8FC-2475357BCEAD}"/>
               </a:ext>
             </a:extLst>
           </p:cNvPr>
@@ -1746,7 +1746,7 @@
           <p:cNvPr id="6" name="Content Placeholder 5">
             <a:extLst>
               <a:ext uri="{FF2B5EF4-FFF2-40B4-BE49-F238E27FC236}">
-                <a16:creationId xmlns:a16="http://schemas.microsoft.com/office/drawing/2014/main" id="{C0A749AD-E7A2-BCE8-3568-13787B8DAD00}"/>
+                <a16:creationId xmlns:a16="http://schemas.microsoft.com/office/drawing/2014/main" id="{46F2115F-91B8-9BFF-61CB-140305113A01}"/>
               </a:ext>
             </a:extLst>
           </p:cNvPr>
@@ -1808,7 +1808,7 @@
           <p:cNvPr id="7" name="Date Placeholder 6">
             <a:extLst>
               <a:ext uri="{FF2B5EF4-FFF2-40B4-BE49-F238E27FC236}">
-                <a16:creationId xmlns:a16="http://schemas.microsoft.com/office/drawing/2014/main" id="{CCA35106-84D6-1C09-BED0-52EAFE853D88}"/>
+                <a16:creationId xmlns:a16="http://schemas.microsoft.com/office/drawing/2014/main" id="{C3E889C4-905F-7FB5-FCE4-22A308505C9C}"/>
               </a:ext>
             </a:extLst>
           </p:cNvPr>
@@ -1824,7 +1824,7 @@
           <a:bodyPr/>
           <a:lstStyle/>
           <a:p>
-            <a:fld id="{0BAD9C77-6EC3-4D89-8A0D-C68FA7E8B712}" type="datetimeFigureOut">
+            <a:fld id="{E9525A42-77D0-4AB8-8B39-6AC1494C132A}" type="datetimeFigureOut">
               <a:rPr lang="en-US" smtClean="0"/>
               <a:t>7/11/2026</a:t>
             </a:fld>
@@ -1837,7 +1837,7 @@
           <p:cNvPr id="8" name="Footer Placeholder 7">
             <a:extLst>
               <a:ext uri="{FF2B5EF4-FFF2-40B4-BE49-F238E27FC236}">
-                <a16:creationId xmlns:a16="http://schemas.microsoft.com/office/drawing/2014/main" id="{B17EAF57-ABFC-D9C6-C994-6067D4F858AB}"/>
+                <a16:creationId xmlns:a16="http://schemas.microsoft.com/office/drawing/2014/main" id="{65132BDF-3592-F470-8218-BCA166C9D77D}"/>
               </a:ext>
             </a:extLst>
           </p:cNvPr>
@@ -1862,7 +1862,7 @@
           <p:cNvPr id="9" name="Slide Number Placeholder 8">
             <a:extLst>
               <a:ext uri="{FF2B5EF4-FFF2-40B4-BE49-F238E27FC236}">
-                <a16:creationId xmlns:a16="http://schemas.microsoft.com/office/drawing/2014/main" id="{1F80D8AE-2142-8BF0-D74D-C680A65E3DEE}"/>
+                <a16:creationId xmlns:a16="http://schemas.microsoft.com/office/drawing/2014/main" id="{48FE8754-5328-1D52-AAF7-83262097ABE1}"/>
               </a:ext>
             </a:extLst>
           </p:cNvPr>
@@ -1878,7 +1878,7 @@
           <a:bodyPr/>
           <a:lstStyle/>
           <a:p>
-            <a:fld id="{DA215C20-D0E9-41CE-87D5-BCE849F24902}" type="slidenum">
+            <a:fld id="{75C8E502-030C-4066-857C-1F5FD0535842}" type="slidenum">
               <a:rPr lang="en-US" smtClean="0"/>
               <a:t>‹#›</a:t>
             </a:fld>
@@ -1889,7 +1889,7 @@
     </p:spTree>
     <p:extLst>
       <p:ext uri="{BB962C8B-B14F-4D97-AF65-F5344CB8AC3E}">
-        <p14:creationId xmlns:p14="http://schemas.microsoft.com/office/powerpoint/2010/main" val="2140765357"/>
+        <p14:creationId xmlns:p14="http://schemas.microsoft.com/office/powerpoint/2010/main" val="2252739207"/>
       </p:ext>
     </p:extLst>
   </p:cSld>
@@ -1921,7 +1921,7 @@
           <p:cNvPr id="2" name="Title 1">
             <a:extLst>
               <a:ext uri="{FF2B5EF4-FFF2-40B4-BE49-F238E27FC236}">
-                <a16:creationId xmlns:a16="http://schemas.microsoft.com/office/drawing/2014/main" id="{D76E5F51-A81A-95D7-CAF8-1FD9225A8B91}"/>
+                <a16:creationId xmlns:a16="http://schemas.microsoft.com/office/drawing/2014/main" id="{B06537AF-E5E1-F41E-C659-C990BCA751D0}"/>
               </a:ext>
             </a:extLst>
           </p:cNvPr>
@@ -1949,7 +1949,7 @@
           <p:cNvPr id="3" name="Date Placeholder 2">
             <a:extLst>
               <a:ext uri="{FF2B5EF4-FFF2-40B4-BE49-F238E27FC236}">
-                <a16:creationId xmlns:a16="http://schemas.microsoft.com/office/drawing/2014/main" id="{765E1782-049F-56BF-459F-D145D4ED7484}"/>
+                <a16:creationId xmlns:a16="http://schemas.microsoft.com/office/drawing/2014/main" id="{670471A4-8589-E8D7-016B-4279D6293B52}"/>
               </a:ext>
             </a:extLst>
           </p:cNvPr>
@@ -1965,7 +1965,7 @@
           <a:bodyPr/>
           <a:lstStyle/>
           <a:p>
-            <a:fld id="{0BAD9C77-6EC3-4D89-8A0D-C68FA7E8B712}" type="datetimeFigureOut">
+            <a:fld id="{E9525A42-77D0-4AB8-8B39-6AC1494C132A}" type="datetimeFigureOut">
               <a:rPr lang="en-US" smtClean="0"/>
               <a:t>7/11/2026</a:t>
             </a:fld>
@@ -1978,7 +1978,7 @@
           <p:cNvPr id="4" name="Footer Placeholder 3">
             <a:extLst>
               <a:ext uri="{FF2B5EF4-FFF2-40B4-BE49-F238E27FC236}">
-                <a16:creationId xmlns:a16="http://schemas.microsoft.com/office/drawing/2014/main" id="{A2E180AE-42A2-8D2D-788E-0CC3F091DF81}"/>
+                <a16:creationId xmlns:a16="http://schemas.microsoft.com/office/drawing/2014/main" id="{7FCD25E0-F803-A4E1-D444-F68A0A77EFC8}"/>
               </a:ext>
             </a:extLst>
           </p:cNvPr>
@@ -2003,7 +2003,7 @@
           <p:cNvPr id="5" name="Slide Number Placeholder 4">
             <a:extLst>
               <a:ext uri="{FF2B5EF4-FFF2-40B4-BE49-F238E27FC236}">
-                <a16:creationId xmlns:a16="http://schemas.microsoft.com/office/drawing/2014/main" id="{292B5702-0A8B-E564-BE43-D1A1B704599F}"/>
+                <a16:creationId xmlns:a16="http://schemas.microsoft.com/office/drawing/2014/main" id="{1602690E-7DC4-E589-3AE7-441D7580DDBC}"/>
               </a:ext>
             </a:extLst>
           </p:cNvPr>
@@ -2019,7 +2019,7 @@
           <a:bodyPr/>
           <a:lstStyle/>
           <a:p>
-            <a:fld id="{DA215C20-D0E9-41CE-87D5-BCE849F24902}" type="slidenum">
+            <a:fld id="{75C8E502-030C-4066-857C-1F5FD0535842}" type="slidenum">
               <a:rPr lang="en-US" smtClean="0"/>
               <a:t>‹#›</a:t>
             </a:fld>
@@ -2030,7 +2030,7 @@
     </p:spTree>
     <p:extLst>
       <p:ext uri="{BB962C8B-B14F-4D97-AF65-F5344CB8AC3E}">
-        <p14:creationId xmlns:p14="http://schemas.microsoft.com/office/powerpoint/2010/main" val="2281236445"/>
+        <p14:creationId xmlns:p14="http://schemas.microsoft.com/office/powerpoint/2010/main" val="691943046"/>
       </p:ext>
     </p:extLst>
   </p:cSld>
@@ -2062,7 +2062,7 @@
           <p:cNvPr id="2" name="Date Placeholder 1">
             <a:extLst>
               <a:ext uri="{FF2B5EF4-FFF2-40B4-BE49-F238E27FC236}">
-                <a16:creationId xmlns:a16="http://schemas.microsoft.com/office/drawing/2014/main" id="{AE8896CA-5A34-5F17-2811-8F8F6D2EE200}"/>
+                <a16:creationId xmlns:a16="http://schemas.microsoft.com/office/drawing/2014/main" id="{AF2123AB-37F6-2937-31A1-E2FE435BAF51}"/>
               </a:ext>
             </a:extLst>
           </p:cNvPr>
@@ -2078,7 +2078,7 @@
           <a:bodyPr/>
           <a:lstStyle/>
           <a:p>
-            <a:fld id="{0BAD9C77-6EC3-4D89-8A0D-C68FA7E8B712}" type="datetimeFigureOut">
+            <a:fld id="{E9525A42-77D0-4AB8-8B39-6AC1494C132A}" type="datetimeFigureOut">
               <a:rPr lang="en-US" smtClean="0"/>
               <a:t>7/11/2026</a:t>
             </a:fld>
@@ -2091,7 +2091,7 @@
           <p:cNvPr id="3" name="Footer Placeholder 2">
             <a:extLst>
               <a:ext uri="{FF2B5EF4-FFF2-40B4-BE49-F238E27FC236}">
-                <a16:creationId xmlns:a16="http://schemas.microsoft.com/office/drawing/2014/main" id="{6B55BA59-488E-7A04-ED9E-6B9394635D5B}"/>
+                <a16:creationId xmlns:a16="http://schemas.microsoft.com/office/drawing/2014/main" id="{F8A795D6-CB87-E56E-2097-333A91F7CA1D}"/>
               </a:ext>
             </a:extLst>
           </p:cNvPr>
@@ -2116,7 +2116,7 @@
           <p:cNvPr id="4" name="Slide Number Placeholder 3">
             <a:extLst>
               <a:ext uri="{FF2B5EF4-FFF2-40B4-BE49-F238E27FC236}">
-                <a16:creationId xmlns:a16="http://schemas.microsoft.com/office/drawing/2014/main" id="{0D8E5459-8F6E-5523-80BB-E306F28578BA}"/>
+                <a16:creationId xmlns:a16="http://schemas.microsoft.com/office/drawing/2014/main" id="{36084A78-9429-F8AB-C88A-1E8220801101}"/>
               </a:ext>
             </a:extLst>
           </p:cNvPr>
@@ -2132,7 +2132,7 @@
           <a:bodyPr/>
           <a:lstStyle/>
           <a:p>
-            <a:fld id="{DA215C20-D0E9-41CE-87D5-BCE849F24902}" type="slidenum">
+            <a:fld id="{75C8E502-030C-4066-857C-1F5FD0535842}" type="slidenum">
               <a:rPr lang="en-US" smtClean="0"/>
               <a:t>‹#›</a:t>
             </a:fld>
@@ -2143,7 +2143,7 @@
     </p:spTree>
     <p:extLst>
       <p:ext uri="{BB962C8B-B14F-4D97-AF65-F5344CB8AC3E}">
-        <p14:creationId xmlns:p14="http://schemas.microsoft.com/office/powerpoint/2010/main" val="1916325369"/>
+        <p14:creationId xmlns:p14="http://schemas.microsoft.com/office/powerpoint/2010/main" val="3740950571"/>
       </p:ext>
     </p:extLst>
   </p:cSld>
@@ -2175,7 +2175,7 @@
           <p:cNvPr id="2" name="Title 1">
             <a:extLst>
               <a:ext uri="{FF2B5EF4-FFF2-40B4-BE49-F238E27FC236}">
-                <a16:creationId xmlns:a16="http://schemas.microsoft.com/office/drawing/2014/main" id="{F10A5F63-993D-C5C9-44E4-050E3BFF3AF4}"/>
+                <a16:creationId xmlns:a16="http://schemas.microsoft.com/office/drawing/2014/main" id="{0D41AFA2-0968-6F07-F3EA-43FDFAEF12D4}"/>
               </a:ext>
             </a:extLst>
           </p:cNvPr>
@@ -2212,7 +2212,7 @@
           <p:cNvPr id="3" name="Content Placeholder 2">
             <a:extLst>
               <a:ext uri="{FF2B5EF4-FFF2-40B4-BE49-F238E27FC236}">
-                <a16:creationId xmlns:a16="http://schemas.microsoft.com/office/drawing/2014/main" id="{C37EEA42-0D10-1CC7-857F-0AB5F28154E3}"/>
+                <a16:creationId xmlns:a16="http://schemas.microsoft.com/office/drawing/2014/main" id="{658073E9-6775-7DEB-3614-68CCE2160466}"/>
               </a:ext>
             </a:extLst>
           </p:cNvPr>
@@ -2302,7 +2302,7 @@
           <p:cNvPr id="4" name="Text Placeholder 3">
             <a:extLst>
               <a:ext uri="{FF2B5EF4-FFF2-40B4-BE49-F238E27FC236}">
-                <a16:creationId xmlns:a16="http://schemas.microsoft.com/office/drawing/2014/main" id="{66CC122D-DB31-9931-3210-5158B0F0E5F0}"/>
+                <a16:creationId xmlns:a16="http://schemas.microsoft.com/office/drawing/2014/main" id="{0123D4B6-52C4-8375-CEC3-9EF63584C530}"/>
               </a:ext>
             </a:extLst>
           </p:cNvPr>
@@ -2373,7 +2373,7 @@
           <p:cNvPr id="5" name="Date Placeholder 4">
             <a:extLst>
               <a:ext uri="{FF2B5EF4-FFF2-40B4-BE49-F238E27FC236}">
-                <a16:creationId xmlns:a16="http://schemas.microsoft.com/office/drawing/2014/main" id="{68D2552D-669D-A8E8-F9F1-29F517AB147D}"/>
+                <a16:creationId xmlns:a16="http://schemas.microsoft.com/office/drawing/2014/main" id="{227A38B2-C810-C06D-3C2E-ED40BB92BED3}"/>
               </a:ext>
             </a:extLst>
           </p:cNvPr>
@@ -2389,7 +2389,7 @@
           <a:bodyPr/>
           <a:lstStyle/>
           <a:p>
-            <a:fld id="{0BAD9C77-6EC3-4D89-8A0D-C68FA7E8B712}" type="datetimeFigureOut">
+            <a:fld id="{E9525A42-77D0-4AB8-8B39-6AC1494C132A}" type="datetimeFigureOut">
               <a:rPr lang="en-US" smtClean="0"/>
               <a:t>7/11/2026</a:t>
             </a:fld>
@@ -2402,7 +2402,7 @@
           <p:cNvPr id="6" name="Footer Placeholder 5">
             <a:extLst>
               <a:ext uri="{FF2B5EF4-FFF2-40B4-BE49-F238E27FC236}">
-                <a16:creationId xmlns:a16="http://schemas.microsoft.com/office/drawing/2014/main" id="{DCD95D5B-9505-DF8F-0884-017F55863B84}"/>
+                <a16:creationId xmlns:a16="http://schemas.microsoft.com/office/drawing/2014/main" id="{37949D43-9351-5691-605B-3E3D81CC15F4}"/>
               </a:ext>
             </a:extLst>
           </p:cNvPr>
@@ -2427,7 +2427,7 @@
           <p:cNvPr id="7" name="Slide Number Placeholder 6">
             <a:extLst>
               <a:ext uri="{FF2B5EF4-FFF2-40B4-BE49-F238E27FC236}">
-                <a16:creationId xmlns:a16="http://schemas.microsoft.com/office/drawing/2014/main" id="{9D455057-ACDD-AF0B-B831-6A327ADC4222}"/>
+                <a16:creationId xmlns:a16="http://schemas.microsoft.com/office/drawing/2014/main" id="{ACC13581-CA08-35A6-E5E2-8208FB6D0108}"/>
               </a:ext>
             </a:extLst>
           </p:cNvPr>
@@ -2443,7 +2443,7 @@
           <a:bodyPr/>
           <a:lstStyle/>
           <a:p>
-            <a:fld id="{DA215C20-D0E9-41CE-87D5-BCE849F24902}" type="slidenum">
+            <a:fld id="{75C8E502-030C-4066-857C-1F5FD0535842}" type="slidenum">
               <a:rPr lang="en-US" smtClean="0"/>
               <a:t>‹#›</a:t>
             </a:fld>
@@ -2454,7 +2454,7 @@
     </p:spTree>
     <p:extLst>
       <p:ext uri="{BB962C8B-B14F-4D97-AF65-F5344CB8AC3E}">
-        <p14:creationId xmlns:p14="http://schemas.microsoft.com/office/powerpoint/2010/main" val="3362090815"/>
+        <p14:creationId xmlns:p14="http://schemas.microsoft.com/office/powerpoint/2010/main" val="4126145167"/>
       </p:ext>
     </p:extLst>
   </p:cSld>
@@ -2486,7 +2486,7 @@
           <p:cNvPr id="2" name="Title 1">
             <a:extLst>
               <a:ext uri="{FF2B5EF4-FFF2-40B4-BE49-F238E27FC236}">
-                <a16:creationId xmlns:a16="http://schemas.microsoft.com/office/drawing/2014/main" id="{E1C2EF9E-47A5-105E-E594-EDBAA4C99D89}"/>
+                <a16:creationId xmlns:a16="http://schemas.microsoft.com/office/drawing/2014/main" id="{25CD456B-CEB1-FA1B-BF15-18FA205F1295}"/>
               </a:ext>
             </a:extLst>
           </p:cNvPr>
@@ -2523,7 +2523,7 @@
           <p:cNvPr id="3" name="Picture Placeholder 2">
             <a:extLst>
               <a:ext uri="{FF2B5EF4-FFF2-40B4-BE49-F238E27FC236}">
-                <a16:creationId xmlns:a16="http://schemas.microsoft.com/office/drawing/2014/main" id="{97EF978B-C1E7-60E0-A99A-75AEF4CDBF86}"/>
+                <a16:creationId xmlns:a16="http://schemas.microsoft.com/office/drawing/2014/main" id="{52ABAEFB-51ED-56B2-17FE-B0F35FC098E2}"/>
               </a:ext>
             </a:extLst>
           </p:cNvPr>
@@ -2590,7 +2590,7 @@
           <p:cNvPr id="4" name="Text Placeholder 3">
             <a:extLst>
               <a:ext uri="{FF2B5EF4-FFF2-40B4-BE49-F238E27FC236}">
-                <a16:creationId xmlns:a16="http://schemas.microsoft.com/office/drawing/2014/main" id="{09A8C6B4-E1CF-858E-8A27-B210F8F11358}"/>
+                <a16:creationId xmlns:a16="http://schemas.microsoft.com/office/drawing/2014/main" id="{0B4208B5-1648-5100-5B7D-F2C127E08EEC}"/>
               </a:ext>
             </a:extLst>
           </p:cNvPr>
@@ -2661,7 +2661,7 @@
           <p:cNvPr id="5" name="Date Placeholder 4">
             <a:extLst>
               <a:ext uri="{FF2B5EF4-FFF2-40B4-BE49-F238E27FC236}">
-                <a16:creationId xmlns:a16="http://schemas.microsoft.com/office/drawing/2014/main" id="{3DDD61BB-3A65-DF1B-B519-709221CBC7BD}"/>
+                <a16:creationId xmlns:a16="http://schemas.microsoft.com/office/drawing/2014/main" id="{D5F9EDA7-C599-DD8E-44DC-32CE1DE2EFC6}"/>
               </a:ext>
             </a:extLst>
           </p:cNvPr>
@@ -2677,7 +2677,7 @@
           <a:bodyPr/>
           <a:lstStyle/>
           <a:p>
-            <a:fld id="{0BAD9C77-6EC3-4D89-8A0D-C68FA7E8B712}" type="datetimeFigureOut">
+            <a:fld id="{E9525A42-77D0-4AB8-8B39-6AC1494C132A}" type="datetimeFigureOut">
               <a:rPr lang="en-US" smtClean="0"/>
               <a:t>7/11/2026</a:t>
             </a:fld>
@@ -2690,7 +2690,7 @@
           <p:cNvPr id="6" name="Footer Placeholder 5">
             <a:extLst>
               <a:ext uri="{FF2B5EF4-FFF2-40B4-BE49-F238E27FC236}">
-                <a16:creationId xmlns:a16="http://schemas.microsoft.com/office/drawing/2014/main" id="{3F559079-984A-4E88-6E8F-FA3DD3A509FD}"/>
+                <a16:creationId xmlns:a16="http://schemas.microsoft.com/office/drawing/2014/main" id="{221ABEAE-E7FA-2117-446C-9D7E8F265684}"/>
               </a:ext>
             </a:extLst>
           </p:cNvPr>
@@ -2715,7 +2715,7 @@
           <p:cNvPr id="7" name="Slide Number Placeholder 6">
             <a:extLst>
               <a:ext uri="{FF2B5EF4-FFF2-40B4-BE49-F238E27FC236}">
-                <a16:creationId xmlns:a16="http://schemas.microsoft.com/office/drawing/2014/main" id="{CF1825C8-1AD5-85F0-6BE8-EC13DFF1C634}"/>
+                <a16:creationId xmlns:a16="http://schemas.microsoft.com/office/drawing/2014/main" id="{1417FE29-362E-51DF-37A4-E5B7E128E85B}"/>
               </a:ext>
             </a:extLst>
           </p:cNvPr>
@@ -2731,7 +2731,7 @@
           <a:bodyPr/>
           <a:lstStyle/>
           <a:p>
-            <a:fld id="{DA215C20-D0E9-41CE-87D5-BCE849F24902}" type="slidenum">
+            <a:fld id="{75C8E502-030C-4066-857C-1F5FD0535842}" type="slidenum">
               <a:rPr lang="en-US" smtClean="0"/>
               <a:t>‹#›</a:t>
             </a:fld>
@@ -2742,7 +2742,7 @@
     </p:spTree>
     <p:extLst>
       <p:ext uri="{BB962C8B-B14F-4D97-AF65-F5344CB8AC3E}">
-        <p14:creationId xmlns:p14="http://schemas.microsoft.com/office/powerpoint/2010/main" val="17509244"/>
+        <p14:creationId xmlns:p14="http://schemas.microsoft.com/office/powerpoint/2010/main" val="3719351156"/>
       </p:ext>
     </p:extLst>
   </p:cSld>
@@ -2779,7 +2779,7 @@
           <p:cNvPr id="2" name="Title Placeholder 1">
             <a:extLst>
               <a:ext uri="{FF2B5EF4-FFF2-40B4-BE49-F238E27FC236}">
-                <a16:creationId xmlns:a16="http://schemas.microsoft.com/office/drawing/2014/main" id="{B95D78C2-CB47-CEDE-C0AB-74E0CCF3CE7D}"/>
+                <a16:creationId xmlns:a16="http://schemas.microsoft.com/office/drawing/2014/main" id="{BEFAFA5B-ABAA-7618-C220-2E8B5194F547}"/>
               </a:ext>
             </a:extLst>
           </p:cNvPr>
@@ -2817,7 +2817,7 @@
           <p:cNvPr id="3" name="Text Placeholder 2">
             <a:extLst>
               <a:ext uri="{FF2B5EF4-FFF2-40B4-BE49-F238E27FC236}">
-                <a16:creationId xmlns:a16="http://schemas.microsoft.com/office/drawing/2014/main" id="{30B60612-FFFF-5072-3EE0-BCEE38FD041A}"/>
+                <a16:creationId xmlns:a16="http://schemas.microsoft.com/office/drawing/2014/main" id="{526FE458-D111-FEED-1F03-4BDDF5BE8663}"/>
               </a:ext>
             </a:extLst>
           </p:cNvPr>
@@ -2884,7 +2884,7 @@
           <p:cNvPr id="4" name="Date Placeholder 3">
             <a:extLst>
               <a:ext uri="{FF2B5EF4-FFF2-40B4-BE49-F238E27FC236}">
-                <a16:creationId xmlns:a16="http://schemas.microsoft.com/office/drawing/2014/main" id="{67593DCB-D8BD-5632-6448-1A5019E1DB33}"/>
+                <a16:creationId xmlns:a16="http://schemas.microsoft.com/office/drawing/2014/main" id="{34A2D5A2-3CF7-DB24-0493-05F31974294C}"/>
               </a:ext>
             </a:extLst>
           </p:cNvPr>
@@ -2918,7 +2918,7 @@
             </a:lvl1pPr>
           </a:lstStyle>
           <a:p>
-            <a:fld id="{0BAD9C77-6EC3-4D89-8A0D-C68FA7E8B712}" type="datetimeFigureOut">
+            <a:fld id="{E9525A42-77D0-4AB8-8B39-6AC1494C132A}" type="datetimeFigureOut">
               <a:rPr lang="en-US" smtClean="0"/>
               <a:t>7/11/2026</a:t>
             </a:fld>
@@ -2931,7 +2931,7 @@
           <p:cNvPr id="5" name="Footer Placeholder 4">
             <a:extLst>
               <a:ext uri="{FF2B5EF4-FFF2-40B4-BE49-F238E27FC236}">
-                <a16:creationId xmlns:a16="http://schemas.microsoft.com/office/drawing/2014/main" id="{1DEFC029-CEE2-55C7-614D-49EE6D862806}"/>
+                <a16:creationId xmlns:a16="http://schemas.microsoft.com/office/drawing/2014/main" id="{C337EE20-0B63-D203-E601-8D94598902E9}"/>
               </a:ext>
             </a:extLst>
           </p:cNvPr>
@@ -2974,7 +2974,7 @@
           <p:cNvPr id="6" name="Slide Number Placeholder 5">
             <a:extLst>
               <a:ext uri="{FF2B5EF4-FFF2-40B4-BE49-F238E27FC236}">
-                <a16:creationId xmlns:a16="http://schemas.microsoft.com/office/drawing/2014/main" id="{5400E529-4745-8A00-5177-3D47DE317A54}"/>
+                <a16:creationId xmlns:a16="http://schemas.microsoft.com/office/drawing/2014/main" id="{F46DDACE-A891-E00B-420F-EF7F14480230}"/>
               </a:ext>
             </a:extLst>
           </p:cNvPr>
@@ -3008,7 +3008,7 @@
             </a:lvl1pPr>
           </a:lstStyle>
           <a:p>
-            <a:fld id="{DA215C20-D0E9-41CE-87D5-BCE849F24902}" type="slidenum">
+            <a:fld id="{75C8E502-030C-4066-857C-1F5FD0535842}" type="slidenum">
               <a:rPr lang="en-US" smtClean="0"/>
               <a:t>‹#›</a:t>
             </a:fld>
@@ -3019,7 +3019,7 @@
     </p:spTree>
     <p:extLst>
       <p:ext uri="{BB962C8B-B14F-4D97-AF65-F5344CB8AC3E}">
-        <p14:creationId xmlns:p14="http://schemas.microsoft.com/office/powerpoint/2010/main" val="4110762453"/>
+        <p14:creationId xmlns:p14="http://schemas.microsoft.com/office/powerpoint/2010/main" val="3769238937"/>
       </p:ext>
     </p:extLst>
   </p:cSld>
@@ -3342,7 +3342,7 @@
           <p:cNvPr id="3" name="Graphic 2">
             <a:extLst>
               <a:ext uri="{FF2B5EF4-FFF2-40B4-BE49-F238E27FC236}">
-                <a16:creationId xmlns:a16="http://schemas.microsoft.com/office/drawing/2014/main" id="{771F7B88-E859-23FC-2E2B-EF6F8B65AC8C}"/>
+                <a16:creationId xmlns:a16="http://schemas.microsoft.com/office/drawing/2014/main" id="{0E4B6553-48BE-F17C-5275-9C9BC1750F6F}"/>
               </a:ext>
             </a:extLst>
           </p:cNvPr>
@@ -3376,7 +3376,7 @@
     </p:spTree>
     <p:extLst>
       <p:ext uri="{BB962C8B-B14F-4D97-AF65-F5344CB8AC3E}">
-        <p14:creationId xmlns:p14="http://schemas.microsoft.com/office/powerpoint/2010/main" val="2122084841"/>
+        <p14:creationId xmlns:p14="http://schemas.microsoft.com/office/powerpoint/2010/main" val="2262849282"/>
       </p:ext>
     </p:extLst>
   </p:cSld>
@@ -3408,7 +3408,7 @@
           <p:cNvPr id="3" name="Graphic 2">
             <a:extLst>
               <a:ext uri="{FF2B5EF4-FFF2-40B4-BE49-F238E27FC236}">
-                <a16:creationId xmlns:a16="http://schemas.microsoft.com/office/drawing/2014/main" id="{06380517-32CD-A69C-F976-B104CE95C9FD}"/>
+                <a16:creationId xmlns:a16="http://schemas.microsoft.com/office/drawing/2014/main" id="{F8EDE8F3-C37B-5BD0-7F10-CC4E10ED89EF}"/>
               </a:ext>
             </a:extLst>
           </p:cNvPr>
@@ -3442,7 +3442,7 @@
     </p:spTree>
     <p:extLst>
       <p:ext uri="{BB962C8B-B14F-4D97-AF65-F5344CB8AC3E}">
-        <p14:creationId xmlns:p14="http://schemas.microsoft.com/office/powerpoint/2010/main" val="771874965"/>
+        <p14:creationId xmlns:p14="http://schemas.microsoft.com/office/powerpoint/2010/main" val="1121599011"/>
       </p:ext>
     </p:extLst>
   </p:cSld>
@@ -3474,7 +3474,7 @@
           <p:cNvPr id="3" name="Graphic 2">
             <a:extLst>
               <a:ext uri="{FF2B5EF4-FFF2-40B4-BE49-F238E27FC236}">
-                <a16:creationId xmlns:a16="http://schemas.microsoft.com/office/drawing/2014/main" id="{F307430C-8162-8470-E620-A9966C8B0788}"/>
+                <a16:creationId xmlns:a16="http://schemas.microsoft.com/office/drawing/2014/main" id="{B98F5EAB-A8E8-1413-5719-6E36175A38C1}"/>
               </a:ext>
             </a:extLst>
           </p:cNvPr>
@@ -3508,7 +3508,7 @@
     </p:spTree>
     <p:extLst>
       <p:ext uri="{BB962C8B-B14F-4D97-AF65-F5344CB8AC3E}">
-        <p14:creationId xmlns:p14="http://schemas.microsoft.com/office/powerpoint/2010/main" val="1009731601"/>
+        <p14:creationId xmlns:p14="http://schemas.microsoft.com/office/powerpoint/2010/main" val="2564513970"/>
       </p:ext>
     </p:extLst>
   </p:cSld>
@@ -3540,7 +3540,7 @@
           <p:cNvPr id="3" name="Graphic 2">
             <a:extLst>
               <a:ext uri="{FF2B5EF4-FFF2-40B4-BE49-F238E27FC236}">
-                <a16:creationId xmlns:a16="http://schemas.microsoft.com/office/drawing/2014/main" id="{C187C293-5BE3-A3B0-DE51-45771BD546E3}"/>
+                <a16:creationId xmlns:a16="http://schemas.microsoft.com/office/drawing/2014/main" id="{12BDA992-1D46-A905-8D72-7A22CD228189}"/>
               </a:ext>
             </a:extLst>
           </p:cNvPr>
@@ -3574,7 +3574,7 @@
     </p:spTree>
     <p:extLst>
       <p:ext uri="{BB962C8B-B14F-4D97-AF65-F5344CB8AC3E}">
-        <p14:creationId xmlns:p14="http://schemas.microsoft.com/office/powerpoint/2010/main" val="2456392042"/>
+        <p14:creationId xmlns:p14="http://schemas.microsoft.com/office/powerpoint/2010/main" val="2915628055"/>
       </p:ext>
     </p:extLst>
   </p:cSld>
@@ -3606,7 +3606,7 @@
           <p:cNvPr id="3" name="Graphic 2">
             <a:extLst>
               <a:ext uri="{FF2B5EF4-FFF2-40B4-BE49-F238E27FC236}">
-                <a16:creationId xmlns:a16="http://schemas.microsoft.com/office/drawing/2014/main" id="{AD3ED291-4D92-708B-155C-9751CB555000}"/>
+                <a16:creationId xmlns:a16="http://schemas.microsoft.com/office/drawing/2014/main" id="{1DD371D7-E165-7362-85CB-17DCB9EEDCC9}"/>
               </a:ext>
             </a:extLst>
           </p:cNvPr>
@@ -3640,7 +3640,7 @@
     </p:spTree>
     <p:extLst>
       <p:ext uri="{BB962C8B-B14F-4D97-AF65-F5344CB8AC3E}">
-        <p14:creationId xmlns:p14="http://schemas.microsoft.com/office/powerpoint/2010/main" val="25924875"/>
+        <p14:creationId xmlns:p14="http://schemas.microsoft.com/office/powerpoint/2010/main" val="1811596294"/>
       </p:ext>
     </p:extLst>
   </p:cSld>
@@ -3672,7 +3672,7 @@
           <p:cNvPr id="3" name="Graphic 2">
             <a:extLst>
               <a:ext uri="{FF2B5EF4-FFF2-40B4-BE49-F238E27FC236}">
-                <a16:creationId xmlns:a16="http://schemas.microsoft.com/office/drawing/2014/main" id="{9F663EE8-D4CF-13C7-4EA1-FBD84C96E7AF}"/>
+                <a16:creationId xmlns:a16="http://schemas.microsoft.com/office/drawing/2014/main" id="{160998C7-B394-1159-D5C7-2422623A84B7}"/>
               </a:ext>
             </a:extLst>
           </p:cNvPr>
@@ -3706,7 +3706,7 @@
     </p:spTree>
     <p:extLst>
       <p:ext uri="{BB962C8B-B14F-4D97-AF65-F5344CB8AC3E}">
-        <p14:creationId xmlns:p14="http://schemas.microsoft.com/office/powerpoint/2010/main" val="2933935928"/>
+        <p14:creationId xmlns:p14="http://schemas.microsoft.com/office/powerpoint/2010/main" val="3303342242"/>
       </p:ext>
     </p:extLst>
   </p:cSld>
@@ -3738,7 +3738,7 @@
           <p:cNvPr id="3" name="Graphic 2">
             <a:extLst>
               <a:ext uri="{FF2B5EF4-FFF2-40B4-BE49-F238E27FC236}">
-                <a16:creationId xmlns:a16="http://schemas.microsoft.com/office/drawing/2014/main" id="{D3C85373-8DEE-8192-1518-DEAD8F58A9DD}"/>
+                <a16:creationId xmlns:a16="http://schemas.microsoft.com/office/drawing/2014/main" id="{DE5A6FEA-9E73-3260-4A01-2B9E06FC0B76}"/>
               </a:ext>
             </a:extLst>
           </p:cNvPr>
@@ -3772,7 +3772,7 @@
     </p:spTree>
     <p:extLst>
       <p:ext uri="{BB962C8B-B14F-4D97-AF65-F5344CB8AC3E}">
-        <p14:creationId xmlns:p14="http://schemas.microsoft.com/office/powerpoint/2010/main" val="3575124240"/>
+        <p14:creationId xmlns:p14="http://schemas.microsoft.com/office/powerpoint/2010/main" val="4149550987"/>
       </p:ext>
     </p:extLst>
   </p:cSld>
@@ -3804,7 +3804,7 @@
           <p:cNvPr id="3" name="Graphic 2">
             <a:extLst>
               <a:ext uri="{FF2B5EF4-FFF2-40B4-BE49-F238E27FC236}">
-                <a16:creationId xmlns:a16="http://schemas.microsoft.com/office/drawing/2014/main" id="{DFE79E98-0C00-E217-6094-927C244445D9}"/>
+                <a16:creationId xmlns:a16="http://schemas.microsoft.com/office/drawing/2014/main" id="{F09A3197-8CC7-37AB-2D3B-8A0F7AF1B59B}"/>
               </a:ext>
             </a:extLst>
           </p:cNvPr>
@@ -3838,7 +3838,7 @@
     </p:spTree>
     <p:extLst>
       <p:ext uri="{BB962C8B-B14F-4D97-AF65-F5344CB8AC3E}">
-        <p14:creationId xmlns:p14="http://schemas.microsoft.com/office/powerpoint/2010/main" val="2140822266"/>
+        <p14:creationId xmlns:p14="http://schemas.microsoft.com/office/powerpoint/2010/main" val="1543130090"/>
       </p:ext>
     </p:extLst>
   </p:cSld>
@@ -3870,7 +3870,7 @@
           <p:cNvPr id="3" name="Graphic 2">
             <a:extLst>
               <a:ext uri="{FF2B5EF4-FFF2-40B4-BE49-F238E27FC236}">
-                <a16:creationId xmlns:a16="http://schemas.microsoft.com/office/drawing/2014/main" id="{2779BD3F-0B22-0137-9EC0-7F710C01CCDE}"/>
+                <a16:creationId xmlns:a16="http://schemas.microsoft.com/office/drawing/2014/main" id="{1A0C7715-E1AE-4DE0-D426-E9A88A31A5E6}"/>
               </a:ext>
             </a:extLst>
           </p:cNvPr>
@@ -3904,7 +3904,7 @@
     </p:spTree>
     <p:extLst>
       <p:ext uri="{BB962C8B-B14F-4D97-AF65-F5344CB8AC3E}">
-        <p14:creationId xmlns:p14="http://schemas.microsoft.com/office/powerpoint/2010/main" val="454660959"/>
+        <p14:creationId xmlns:p14="http://schemas.microsoft.com/office/powerpoint/2010/main" val="3328945239"/>
       </p:ext>
     </p:extLst>
   </p:cSld>
@@ -3936,7 +3936,7 @@
           <p:cNvPr id="3" name="Graphic 2">
             <a:extLst>
               <a:ext uri="{FF2B5EF4-FFF2-40B4-BE49-F238E27FC236}">
-                <a16:creationId xmlns:a16="http://schemas.microsoft.com/office/drawing/2014/main" id="{0472CFBA-DCC7-19C4-0FE3-442203FB878B}"/>
+                <a16:creationId xmlns:a16="http://schemas.microsoft.com/office/drawing/2014/main" id="{508118DF-E824-4CFE-8C11-975A14213D1A}"/>
               </a:ext>
             </a:extLst>
           </p:cNvPr>
@@ -3970,7 +3970,7 @@
     </p:spTree>
     <p:extLst>
       <p:ext uri="{BB962C8B-B14F-4D97-AF65-F5344CB8AC3E}">
-        <p14:creationId xmlns:p14="http://schemas.microsoft.com/office/powerpoint/2010/main" val="2882298827"/>
+        <p14:creationId xmlns:p14="http://schemas.microsoft.com/office/powerpoint/2010/main" val="2564640964"/>
       </p:ext>
     </p:extLst>
   </p:cSld>
@@ -4002,7 +4002,7 @@
           <p:cNvPr id="3" name="Graphic 2">
             <a:extLst>
               <a:ext uri="{FF2B5EF4-FFF2-40B4-BE49-F238E27FC236}">
-                <a16:creationId xmlns:a16="http://schemas.microsoft.com/office/drawing/2014/main" id="{80C608B7-821E-ED55-1634-636A56D37E80}"/>
+                <a16:creationId xmlns:a16="http://schemas.microsoft.com/office/drawing/2014/main" id="{4AAC513C-B52B-C67F-3B2A-F38540DAAC10}"/>
               </a:ext>
             </a:extLst>
           </p:cNvPr>
@@ -4036,7 +4036,7 @@
     </p:spTree>
     <p:extLst>
       <p:ext uri="{BB962C8B-B14F-4D97-AF65-F5344CB8AC3E}">
-        <p14:creationId xmlns:p14="http://schemas.microsoft.com/office/powerpoint/2010/main" val="3284552477"/>
+        <p14:creationId xmlns:p14="http://schemas.microsoft.com/office/powerpoint/2010/main" val="2759902103"/>
       </p:ext>
     </p:extLst>
   </p:cSld>
@@ -4068,7 +4068,7 @@
           <p:cNvPr id="3" name="Graphic 2">
             <a:extLst>
               <a:ext uri="{FF2B5EF4-FFF2-40B4-BE49-F238E27FC236}">
-                <a16:creationId xmlns:a16="http://schemas.microsoft.com/office/drawing/2014/main" id="{AEAB79A7-F618-44D7-6CDD-934A3346981B}"/>
+                <a16:creationId xmlns:a16="http://schemas.microsoft.com/office/drawing/2014/main" id="{98568AEC-4706-E349-2253-0DD401B67393}"/>
               </a:ext>
             </a:extLst>
           </p:cNvPr>
@@ -4102,7 +4102,7 @@
     </p:spTree>
     <p:extLst>
       <p:ext uri="{BB962C8B-B14F-4D97-AF65-F5344CB8AC3E}">
-        <p14:creationId xmlns:p14="http://schemas.microsoft.com/office/powerpoint/2010/main" val="3148945429"/>
+        <p14:creationId xmlns:p14="http://schemas.microsoft.com/office/powerpoint/2010/main" val="2317355191"/>
       </p:ext>
     </p:extLst>
   </p:cSld>
@@ -4134,7 +4134,7 @@
           <p:cNvPr id="3" name="Graphic 2">
             <a:extLst>
               <a:ext uri="{FF2B5EF4-FFF2-40B4-BE49-F238E27FC236}">
-                <a16:creationId xmlns:a16="http://schemas.microsoft.com/office/drawing/2014/main" id="{FCA25E2E-D8AF-1249-6780-7E1CBF716230}"/>
+                <a16:creationId xmlns:a16="http://schemas.microsoft.com/office/drawing/2014/main" id="{6F9FDFC0-7F52-0BB7-2072-C3E06A003AF2}"/>
               </a:ext>
             </a:extLst>
           </p:cNvPr>
@@ -4168,7 +4168,7 @@
     </p:spTree>
     <p:extLst>
       <p:ext uri="{BB962C8B-B14F-4D97-AF65-F5344CB8AC3E}">
-        <p14:creationId xmlns:p14="http://schemas.microsoft.com/office/powerpoint/2010/main" val="3335036668"/>
+        <p14:creationId xmlns:p14="http://schemas.microsoft.com/office/powerpoint/2010/main" val="3602440666"/>
       </p:ext>
     </p:extLst>
   </p:cSld>
@@ -4200,7 +4200,7 @@
           <p:cNvPr id="3" name="Graphic 2">
             <a:extLst>
               <a:ext uri="{FF2B5EF4-FFF2-40B4-BE49-F238E27FC236}">
-                <a16:creationId xmlns:a16="http://schemas.microsoft.com/office/drawing/2014/main" id="{EA080342-392D-71AE-6268-5B511FBE0DED}"/>
+                <a16:creationId xmlns:a16="http://schemas.microsoft.com/office/drawing/2014/main" id="{32F0EB98-A2C9-3755-F485-7DD5F4A7E768}"/>
               </a:ext>
             </a:extLst>
           </p:cNvPr>
@@ -4234,7 +4234,7 @@
     </p:spTree>
     <p:extLst>
       <p:ext uri="{BB962C8B-B14F-4D97-AF65-F5344CB8AC3E}">
-        <p14:creationId xmlns:p14="http://schemas.microsoft.com/office/powerpoint/2010/main" val="1072996193"/>
+        <p14:creationId xmlns:p14="http://schemas.microsoft.com/office/powerpoint/2010/main" val="130899207"/>
       </p:ext>
     </p:extLst>
   </p:cSld>
@@ -4266,7 +4266,7 @@
           <p:cNvPr id="3" name="Graphic 2">
             <a:extLst>
               <a:ext uri="{FF2B5EF4-FFF2-40B4-BE49-F238E27FC236}">
-                <a16:creationId xmlns:a16="http://schemas.microsoft.com/office/drawing/2014/main" id="{508AEFB0-F889-711D-C318-2D3BD32C6BC3}"/>
+                <a16:creationId xmlns:a16="http://schemas.microsoft.com/office/drawing/2014/main" id="{5D74CB5D-CE58-78E9-C67F-9026FF62234C}"/>
               </a:ext>
             </a:extLst>
           </p:cNvPr>
@@ -4300,7 +4300,7 @@
     </p:spTree>
     <p:extLst>
       <p:ext uri="{BB962C8B-B14F-4D97-AF65-F5344CB8AC3E}">
-        <p14:creationId xmlns:p14="http://schemas.microsoft.com/office/powerpoint/2010/main" val="2074858850"/>
+        <p14:creationId xmlns:p14="http://schemas.microsoft.com/office/powerpoint/2010/main" val="2434387387"/>
       </p:ext>
     </p:extLst>
   </p:cSld>
@@ -4332,7 +4332,7 @@
           <p:cNvPr id="3" name="Graphic 2">
             <a:extLst>
               <a:ext uri="{FF2B5EF4-FFF2-40B4-BE49-F238E27FC236}">
-                <a16:creationId xmlns:a16="http://schemas.microsoft.com/office/drawing/2014/main" id="{D2F11FA3-812A-33DD-DEDF-E160B359EDD6}"/>
+                <a16:creationId xmlns:a16="http://schemas.microsoft.com/office/drawing/2014/main" id="{D900E145-C1C9-629E-EF01-0963BCDA31BB}"/>
               </a:ext>
             </a:extLst>
           </p:cNvPr>
@@ -4366,7 +4366,7 @@
     </p:spTree>
     <p:extLst>
       <p:ext uri="{BB962C8B-B14F-4D97-AF65-F5344CB8AC3E}">
-        <p14:creationId xmlns:p14="http://schemas.microsoft.com/office/powerpoint/2010/main" val="875486014"/>
+        <p14:creationId xmlns:p14="http://schemas.microsoft.com/office/powerpoint/2010/main" val="4004753414"/>
       </p:ext>
     </p:extLst>
   </p:cSld>
@@ -4398,7 +4398,7 @@
           <p:cNvPr id="3" name="Graphic 2">
             <a:extLst>
               <a:ext uri="{FF2B5EF4-FFF2-40B4-BE49-F238E27FC236}">
-                <a16:creationId xmlns:a16="http://schemas.microsoft.com/office/drawing/2014/main" id="{8CE4AC44-5991-55ED-9B0F-ACEB37DF07EE}"/>
+                <a16:creationId xmlns:a16="http://schemas.microsoft.com/office/drawing/2014/main" id="{B5B2026C-C9AD-C96E-3A29-F6A5EA41DCCC}"/>
               </a:ext>
             </a:extLst>
           </p:cNvPr>
@@ -4432,7 +4432,7 @@
     </p:spTree>
     <p:extLst>
       <p:ext uri="{BB962C8B-B14F-4D97-AF65-F5344CB8AC3E}">
-        <p14:creationId xmlns:p14="http://schemas.microsoft.com/office/powerpoint/2010/main" val="1807728771"/>
+        <p14:creationId xmlns:p14="http://schemas.microsoft.com/office/powerpoint/2010/main" val="2355539163"/>
       </p:ext>
     </p:extLst>
   </p:cSld>

</xml_diff>